<commit_message>
Correct presentation author line
</commit_message>
<xml_diff>
--- a/report/ebay_anchoring_rl_presentation.pptx
+++ b/report/ebay_anchoring_rl_presentation.pptx
@@ -2,29 +2,29 @@
 <file path=ppt/presentation.xml><?xml version="1.0" encoding="utf-8"?>
 <p:presentation xmlns:p="http://schemas.openxmlformats.org/presentationml/2006/main">
   <p:sldMasterIdLst>
-    <p:sldMasterId xmlns:r="http://schemas.openxmlformats.org/officeDocument/2006/relationships" id="2147483648" r:id="R0cde4c704c10437b"/>
-    <p:sldMasterId xmlns:r="http://schemas.openxmlformats.org/officeDocument/2006/relationships" id="2147483651" r:id="R0b58c77e3a9347fe"/>
-    <p:sldMasterId xmlns:r="http://schemas.openxmlformats.org/officeDocument/2006/relationships" id="2147483653" r:id="R23357731a8b64c69"/>
-    <p:sldMasterId xmlns:r="http://schemas.openxmlformats.org/officeDocument/2006/relationships" id="2147483656" r:id="R0583713eae1c432d"/>
-    <p:sldMasterId xmlns:r="http://schemas.openxmlformats.org/officeDocument/2006/relationships" id="2147483659" r:id="R44f53428791d4029"/>
-    <p:sldMasterId xmlns:r="http://schemas.openxmlformats.org/officeDocument/2006/relationships" id="2147483678" r:id="R591c3e0b80474d4a"/>
-    <p:sldMasterId xmlns:r="http://schemas.openxmlformats.org/officeDocument/2006/relationships" id="2147483680" r:id="Ra29e2e32dc904001"/>
+    <p:sldMasterId xmlns:r="http://schemas.openxmlformats.org/officeDocument/2006/relationships" id="2147483648" r:id="R743c506193a448d7"/>
+    <p:sldMasterId xmlns:r="http://schemas.openxmlformats.org/officeDocument/2006/relationships" id="2147483651" r:id="Rbefb6a906f2449ea"/>
+    <p:sldMasterId xmlns:r="http://schemas.openxmlformats.org/officeDocument/2006/relationships" id="2147483653" r:id="R8581195f533f470b"/>
+    <p:sldMasterId xmlns:r="http://schemas.openxmlformats.org/officeDocument/2006/relationships" id="2147483656" r:id="Rc087f7d309d24f04"/>
+    <p:sldMasterId xmlns:r="http://schemas.openxmlformats.org/officeDocument/2006/relationships" id="2147483659" r:id="R677f41ecdd9a4d57"/>
+    <p:sldMasterId xmlns:r="http://schemas.openxmlformats.org/officeDocument/2006/relationships" id="2147483678" r:id="Rd4020f0307584f52"/>
+    <p:sldMasterId xmlns:r="http://schemas.openxmlformats.org/officeDocument/2006/relationships" id="2147483680" r:id="R509edf10df6c42eb"/>
   </p:sldMasterIdLst>
   <p:notesMasterIdLst>
-    <p:notesMasterId xmlns:r="http://schemas.openxmlformats.org/officeDocument/2006/relationships" r:id="Racdbe72f8a57414d"/>
+    <p:notesMasterId xmlns:r="http://schemas.openxmlformats.org/officeDocument/2006/relationships" r:id="Rebd1237e162842a4"/>
   </p:notesMasterIdLst>
   <p:sldIdLst>
-    <p:sldId xmlns:r="http://schemas.openxmlformats.org/officeDocument/2006/relationships" id="256" r:id="R1a5e4f5d11584a1f"/>
-    <p:sldId xmlns:r="http://schemas.openxmlformats.org/officeDocument/2006/relationships" id="257" r:id="R32bfad5b9870490a"/>
-    <p:sldId xmlns:r="http://schemas.openxmlformats.org/officeDocument/2006/relationships" id="258" r:id="R4ba3af05f13e4d5e"/>
-    <p:sldId xmlns:r="http://schemas.openxmlformats.org/officeDocument/2006/relationships" id="259" r:id="R9c6af3324aa047f8"/>
-    <p:sldId xmlns:r="http://schemas.openxmlformats.org/officeDocument/2006/relationships" id="260" r:id="R0ba290964ac24585"/>
-    <p:sldId xmlns:r="http://schemas.openxmlformats.org/officeDocument/2006/relationships" id="261" r:id="R6d12626b898b4636"/>
-    <p:sldId xmlns:r="http://schemas.openxmlformats.org/officeDocument/2006/relationships" id="262" r:id="Rd4ff8320a3fb4f8f"/>
-    <p:sldId xmlns:r="http://schemas.openxmlformats.org/officeDocument/2006/relationships" id="263" r:id="Ra19615df69174af0"/>
-    <p:sldId xmlns:r="http://schemas.openxmlformats.org/officeDocument/2006/relationships" id="264" r:id="R635ae9f23e604755"/>
-    <p:sldId xmlns:r="http://schemas.openxmlformats.org/officeDocument/2006/relationships" id="265" r:id="Rab2cb8d4eaab4289"/>
-    <p:sldId xmlns:r="http://schemas.openxmlformats.org/officeDocument/2006/relationships" id="266" r:id="R04732871f2e0466a"/>
+    <p:sldId xmlns:r="http://schemas.openxmlformats.org/officeDocument/2006/relationships" id="256" r:id="R144adb0e54924706"/>
+    <p:sldId xmlns:r="http://schemas.openxmlformats.org/officeDocument/2006/relationships" id="257" r:id="Raf2786c8d0104135"/>
+    <p:sldId xmlns:r="http://schemas.openxmlformats.org/officeDocument/2006/relationships" id="258" r:id="R704d3811473b4db3"/>
+    <p:sldId xmlns:r="http://schemas.openxmlformats.org/officeDocument/2006/relationships" id="259" r:id="R9fd26a97216d4fae"/>
+    <p:sldId xmlns:r="http://schemas.openxmlformats.org/officeDocument/2006/relationships" id="260" r:id="Rabc25dab316042b3"/>
+    <p:sldId xmlns:r="http://schemas.openxmlformats.org/officeDocument/2006/relationships" id="261" r:id="Rda6b39315a4e4e5d"/>
+    <p:sldId xmlns:r="http://schemas.openxmlformats.org/officeDocument/2006/relationships" id="262" r:id="Ra94100e8b6174f84"/>
+    <p:sldId xmlns:r="http://schemas.openxmlformats.org/officeDocument/2006/relationships" id="263" r:id="R1d8b70bf120b4924"/>
+    <p:sldId xmlns:r="http://schemas.openxmlformats.org/officeDocument/2006/relationships" id="264" r:id="Rfae9d43120ea4e05"/>
+    <p:sldId xmlns:r="http://schemas.openxmlformats.org/officeDocument/2006/relationships" id="265" r:id="R015ffb0978a6427a"/>
+    <p:sldId xmlns:r="http://schemas.openxmlformats.org/officeDocument/2006/relationships" id="266" r:id="R381d7b2378d440ac"/>
   </p:sldIdLst>
   <p:sldSz cx="9144000" cy="5143500"/>
   <p:notesSz cx="6858000" cy="9144000"/>
@@ -4313,7 +4313,7 @@
           <p:nvPr/>
         </p:nvPicPr>
         <p:blipFill>
-          <a:blip xmlns:r="http://schemas.openxmlformats.org/officeDocument/2006/relationships" xmlns:a="http://schemas.openxmlformats.org/drawingml/2006/main" r:embed="R3fbe00b673ee4421"/>
+          <a:blip xmlns:r="http://schemas.openxmlformats.org/officeDocument/2006/relationships" xmlns:a="http://schemas.openxmlformats.org/drawingml/2006/main" r:embed="R098ceda945f84a4d"/>
           <a:stretch xmlns:a="http://schemas.openxmlformats.org/drawingml/2006/main">
             <a:fillRect l="0" t="0" r="0" b="0"/>
           </a:stretch>
@@ -7191,7 +7191,7 @@
           <p:nvPr/>
         </p:nvPicPr>
         <p:blipFill>
-          <a:blip xmlns:r="http://schemas.openxmlformats.org/officeDocument/2006/relationships" xmlns:a="http://schemas.openxmlformats.org/drawingml/2006/main" r:embed="Rf112d10286e2484e"/>
+          <a:blip xmlns:r="http://schemas.openxmlformats.org/officeDocument/2006/relationships" xmlns:a="http://schemas.openxmlformats.org/drawingml/2006/main" r:embed="Rb78a7d06019b4133"/>
           <a:stretch xmlns:a="http://schemas.openxmlformats.org/drawingml/2006/main">
             <a:fillRect l="0" t="0" r="0" b="0"/>
           </a:stretch>
@@ -7944,7 +7944,7 @@
           <p:nvPr/>
         </p:nvPicPr>
         <p:blipFill>
-          <a:blip xmlns:r="http://schemas.openxmlformats.org/officeDocument/2006/relationships" xmlns:a="http://schemas.openxmlformats.org/drawingml/2006/main" r:embed="R02587295c735481b"/>
+          <a:blip xmlns:r="http://schemas.openxmlformats.org/officeDocument/2006/relationships" xmlns:a="http://schemas.openxmlformats.org/drawingml/2006/main" r:embed="Rd8043deb2fdd40f4"/>
           <a:stretch xmlns:a="http://schemas.openxmlformats.org/drawingml/2006/main">
             <a:fillRect l="0" t="0" r="0" b="0"/>
           </a:stretch>
@@ -7963,8 +7963,8 @@
   </p:cSld>
   <p:clrMap bg1="lt1" tx1="dk1" bg2="lt2" tx2="dk2" accent1="accent1" accent2="accent2" accent3="accent3" accent4="accent4" accent5="accent5" accent6="accent6" hlink="hlink" folHlink="folHlink"/>
   <p:sldLayoutIdLst>
-    <p:sldLayoutId xmlns:r="http://schemas.openxmlformats.org/officeDocument/2006/relationships" id="2147483649" r:id="R520b2685f97d4276"/>
-    <p:sldLayoutId xmlns:r="http://schemas.openxmlformats.org/officeDocument/2006/relationships" id="2147483650" r:id="Rbb2ae502ff6a494e"/>
+    <p:sldLayoutId xmlns:r="http://schemas.openxmlformats.org/officeDocument/2006/relationships" id="2147483649" r:id="Rcdcbf14d247b4457"/>
+    <p:sldLayoutId xmlns:r="http://schemas.openxmlformats.org/officeDocument/2006/relationships" id="2147483650" r:id="Re53f1bc6b92044d8"/>
   </p:sldLayoutIdLst>
   <p:hf hdr="0" dt="0"/>
   <p:txStyles>
@@ -8330,7 +8330,7 @@
   </p:cSld>
   <p:clrMap bg1="lt1" tx1="dk1" bg2="lt2" tx2="dk2" accent1="accent1" accent2="accent2" accent3="accent3" accent4="accent4" accent5="accent5" accent6="accent6" hlink="hlink" folHlink="folHlink"/>
   <p:sldLayoutIdLst>
-    <p:sldLayoutId xmlns:r="http://schemas.openxmlformats.org/officeDocument/2006/relationships" id="2147483652" r:id="R6f6bacd4b1d14190"/>
+    <p:sldLayoutId xmlns:r="http://schemas.openxmlformats.org/officeDocument/2006/relationships" id="2147483652" r:id="R87fda122a45d4413"/>
   </p:sldLayoutIdLst>
   <p:txStyles>
     <p:titleStyle>
@@ -8697,7 +8697,7 @@
           <p:nvPr/>
         </p:nvPicPr>
         <p:blipFill>
-          <a:blip xmlns:r="http://schemas.openxmlformats.org/officeDocument/2006/relationships" xmlns:a="http://schemas.openxmlformats.org/drawingml/2006/main" r:embed="R6e4906e3a32a4047"/>
+          <a:blip xmlns:r="http://schemas.openxmlformats.org/officeDocument/2006/relationships" xmlns:a="http://schemas.openxmlformats.org/drawingml/2006/main" r:embed="Rc3e76cfec8af4515"/>
           <a:srcRect xmlns:a="http://schemas.openxmlformats.org/drawingml/2006/main" l="398" t="14167" r="0" b="10833"/>
           <a:stretch xmlns:a="http://schemas.openxmlformats.org/drawingml/2006/main">
             <a:fillRect l="0" t="0" r="0" b="0"/>
@@ -8722,7 +8722,7 @@
           <p:nvPr/>
         </p:nvPicPr>
         <p:blipFill>
-          <a:blip xmlns:r="http://schemas.openxmlformats.org/officeDocument/2006/relationships" xmlns:a="http://schemas.openxmlformats.org/drawingml/2006/main" r:embed="R665a7f8b3b8c436d"/>
+          <a:blip xmlns:r="http://schemas.openxmlformats.org/officeDocument/2006/relationships" xmlns:a="http://schemas.openxmlformats.org/drawingml/2006/main" r:embed="Rd2d48e6800044376"/>
           <a:stretch xmlns:a="http://schemas.openxmlformats.org/drawingml/2006/main">
             <a:fillRect l="0" t="0" r="0" b="0"/>
           </a:stretch>
@@ -8829,8 +8829,8 @@
   </p:cSld>
   <p:clrMap bg1="lt1" tx1="dk1" bg2="lt2" tx2="dk2" accent1="accent1" accent2="accent2" accent3="accent3" accent4="accent4" accent5="accent5" accent6="accent6" hlink="hlink" folHlink="folHlink"/>
   <p:sldLayoutIdLst>
-    <p:sldLayoutId xmlns:r="http://schemas.openxmlformats.org/officeDocument/2006/relationships" id="2147483654" r:id="R83dbbbba90134538"/>
-    <p:sldLayoutId xmlns:r="http://schemas.openxmlformats.org/officeDocument/2006/relationships" id="2147483655" r:id="R970294dacc6845c3"/>
+    <p:sldLayoutId xmlns:r="http://schemas.openxmlformats.org/officeDocument/2006/relationships" id="2147483654" r:id="R150d7dbb518646d3"/>
+    <p:sldLayoutId xmlns:r="http://schemas.openxmlformats.org/officeDocument/2006/relationships" id="2147483655" r:id="R0239ea74b55c474a"/>
   </p:sldLayoutIdLst>
   <p:hf hdr="0" dt="0"/>
   <p:txStyles>
@@ -9289,7 +9289,7 @@
           <p:nvPr/>
         </p:nvPicPr>
         <p:blipFill>
-          <a:blip xmlns:r="http://schemas.openxmlformats.org/officeDocument/2006/relationships" xmlns:a="http://schemas.openxmlformats.org/drawingml/2006/main" r:embed="Rb408763c0fbb4f0c"/>
+          <a:blip xmlns:r="http://schemas.openxmlformats.org/officeDocument/2006/relationships" xmlns:a="http://schemas.openxmlformats.org/drawingml/2006/main" r:embed="R82e4feb1db0e4816"/>
           <a:stretch xmlns:a="http://schemas.openxmlformats.org/drawingml/2006/main">
             <a:fillRect l="0" t="0" r="0" b="0"/>
           </a:stretch>
@@ -9396,8 +9396,8 @@
   </p:cSld>
   <p:clrMap bg1="lt1" tx1="dk1" bg2="lt2" tx2="dk2" accent1="accent1" accent2="accent2" accent3="accent3" accent4="accent4" accent5="accent5" accent6="accent6" hlink="hlink" folHlink="folHlink"/>
   <p:sldLayoutIdLst>
-    <p:sldLayoutId xmlns:r="http://schemas.openxmlformats.org/officeDocument/2006/relationships" id="2147483657" r:id="R1b40a161162b408b"/>
-    <p:sldLayoutId xmlns:r="http://schemas.openxmlformats.org/officeDocument/2006/relationships" id="2147483658" r:id="R8cadb8f17f5f4e00"/>
+    <p:sldLayoutId xmlns:r="http://schemas.openxmlformats.org/officeDocument/2006/relationships" id="2147483657" r:id="Rd1452dfe98604e60"/>
+    <p:sldLayoutId xmlns:r="http://schemas.openxmlformats.org/officeDocument/2006/relationships" id="2147483658" r:id="R71dd905b73ff4625"/>
   </p:sldLayoutIdLst>
   <p:hf hdr="0" dt="0"/>
   <p:txStyles>
@@ -9768,7 +9768,7 @@
           <p:nvPr/>
         </p:nvPicPr>
         <p:blipFill>
-          <a:blip xmlns:r="http://schemas.openxmlformats.org/officeDocument/2006/relationships" xmlns:a="http://schemas.openxmlformats.org/drawingml/2006/main" r:embed="R3bc505e3d7e24900"/>
+          <a:blip xmlns:r="http://schemas.openxmlformats.org/officeDocument/2006/relationships" xmlns:a="http://schemas.openxmlformats.org/drawingml/2006/main" r:embed="Rb64e5aa013da4384"/>
           <a:stretch xmlns:a="http://schemas.openxmlformats.org/drawingml/2006/main">
             <a:fillRect l="0" t="0" r="0" b="0"/>
           </a:stretch>
@@ -9875,24 +9875,24 @@
   </p:cSld>
   <p:clrMap bg1="lt1" tx1="dk1" bg2="lt2" tx2="dk2" accent1="accent1" accent2="accent2" accent3="accent3" accent4="accent4" accent5="accent5" accent6="accent6" hlink="hlink" folHlink="folHlink"/>
   <p:sldLayoutIdLst>
-    <p:sldLayoutId xmlns:r="http://schemas.openxmlformats.org/officeDocument/2006/relationships" id="2147483660" r:id="Reb721e16747e46b4"/>
-    <p:sldLayoutId xmlns:r="http://schemas.openxmlformats.org/officeDocument/2006/relationships" id="2147483661" r:id="Rb36aa605d6fc47c4"/>
-    <p:sldLayoutId xmlns:r="http://schemas.openxmlformats.org/officeDocument/2006/relationships" id="2147483662" r:id="R1972f43a5246417d"/>
-    <p:sldLayoutId xmlns:r="http://schemas.openxmlformats.org/officeDocument/2006/relationships" id="2147483663" r:id="R1602b0d12970454f"/>
-    <p:sldLayoutId xmlns:r="http://schemas.openxmlformats.org/officeDocument/2006/relationships" id="2147483664" r:id="R0dd8f74263404425"/>
-    <p:sldLayoutId xmlns:r="http://schemas.openxmlformats.org/officeDocument/2006/relationships" id="2147483665" r:id="Raf41d927342b4185"/>
-    <p:sldLayoutId xmlns:r="http://schemas.openxmlformats.org/officeDocument/2006/relationships" id="2147483666" r:id="Rd2d394b65a4a4edb"/>
-    <p:sldLayoutId xmlns:r="http://schemas.openxmlformats.org/officeDocument/2006/relationships" id="2147483667" r:id="Rbdd52f3459c94810"/>
-    <p:sldLayoutId xmlns:r="http://schemas.openxmlformats.org/officeDocument/2006/relationships" id="2147483668" r:id="R6953db1bf40e439c"/>
-    <p:sldLayoutId xmlns:r="http://schemas.openxmlformats.org/officeDocument/2006/relationships" id="2147483669" r:id="Rf7d06951aedd4cd3"/>
-    <p:sldLayoutId xmlns:r="http://schemas.openxmlformats.org/officeDocument/2006/relationships" id="2147483670" r:id="R2da9f2c66688483f"/>
-    <p:sldLayoutId xmlns:r="http://schemas.openxmlformats.org/officeDocument/2006/relationships" id="2147483671" r:id="Ra82011e34ea0470b"/>
-    <p:sldLayoutId xmlns:r="http://schemas.openxmlformats.org/officeDocument/2006/relationships" id="2147483672" r:id="R9dcc37d305b64a25"/>
-    <p:sldLayoutId xmlns:r="http://schemas.openxmlformats.org/officeDocument/2006/relationships" id="2147483673" r:id="R8f3afc43f2fe4361"/>
-    <p:sldLayoutId xmlns:r="http://schemas.openxmlformats.org/officeDocument/2006/relationships" id="2147483674" r:id="R3f1d1a3b8bc04562"/>
-    <p:sldLayoutId xmlns:r="http://schemas.openxmlformats.org/officeDocument/2006/relationships" id="2147483675" r:id="R90cb1192b7d9486b"/>
-    <p:sldLayoutId xmlns:r="http://schemas.openxmlformats.org/officeDocument/2006/relationships" id="2147483676" r:id="R8c4f6dcf2dc84854"/>
-    <p:sldLayoutId xmlns:r="http://schemas.openxmlformats.org/officeDocument/2006/relationships" id="2147483677" r:id="R1371b0eb7a954f07"/>
+    <p:sldLayoutId xmlns:r="http://schemas.openxmlformats.org/officeDocument/2006/relationships" id="2147483660" r:id="R6dfff7dba3f5460a"/>
+    <p:sldLayoutId xmlns:r="http://schemas.openxmlformats.org/officeDocument/2006/relationships" id="2147483661" r:id="R17d2fc9975ad40ce"/>
+    <p:sldLayoutId xmlns:r="http://schemas.openxmlformats.org/officeDocument/2006/relationships" id="2147483662" r:id="R939734f8e6454734"/>
+    <p:sldLayoutId xmlns:r="http://schemas.openxmlformats.org/officeDocument/2006/relationships" id="2147483663" r:id="R49bb90d95ba64c27"/>
+    <p:sldLayoutId xmlns:r="http://schemas.openxmlformats.org/officeDocument/2006/relationships" id="2147483664" r:id="Rd075a8c8625b4481"/>
+    <p:sldLayoutId xmlns:r="http://schemas.openxmlformats.org/officeDocument/2006/relationships" id="2147483665" r:id="R92b28ca4fdf54a37"/>
+    <p:sldLayoutId xmlns:r="http://schemas.openxmlformats.org/officeDocument/2006/relationships" id="2147483666" r:id="R9ecb1645487d419b"/>
+    <p:sldLayoutId xmlns:r="http://schemas.openxmlformats.org/officeDocument/2006/relationships" id="2147483667" r:id="Red33d9fa5be546ad"/>
+    <p:sldLayoutId xmlns:r="http://schemas.openxmlformats.org/officeDocument/2006/relationships" id="2147483668" r:id="R7897471309a5488e"/>
+    <p:sldLayoutId xmlns:r="http://schemas.openxmlformats.org/officeDocument/2006/relationships" id="2147483669" r:id="R4e2ca18b688e4e80"/>
+    <p:sldLayoutId xmlns:r="http://schemas.openxmlformats.org/officeDocument/2006/relationships" id="2147483670" r:id="R308a66b6e5824c7c"/>
+    <p:sldLayoutId xmlns:r="http://schemas.openxmlformats.org/officeDocument/2006/relationships" id="2147483671" r:id="R9d1b34c8677649d7"/>
+    <p:sldLayoutId xmlns:r="http://schemas.openxmlformats.org/officeDocument/2006/relationships" id="2147483672" r:id="R7e16060facfe4930"/>
+    <p:sldLayoutId xmlns:r="http://schemas.openxmlformats.org/officeDocument/2006/relationships" id="2147483673" r:id="R820e3d31c03b45a0"/>
+    <p:sldLayoutId xmlns:r="http://schemas.openxmlformats.org/officeDocument/2006/relationships" id="2147483674" r:id="Ra36c505c313f4b59"/>
+    <p:sldLayoutId xmlns:r="http://schemas.openxmlformats.org/officeDocument/2006/relationships" id="2147483675" r:id="R891bb355873642fb"/>
+    <p:sldLayoutId xmlns:r="http://schemas.openxmlformats.org/officeDocument/2006/relationships" id="2147483676" r:id="R8e12c461724847a0"/>
+    <p:sldLayoutId xmlns:r="http://schemas.openxmlformats.org/officeDocument/2006/relationships" id="2147483677" r:id="Rf6f6f114efdd4101"/>
   </p:sldLayoutIdLst>
   <p:hf hdr="0" dt="0"/>
   <p:txStyles>
@@ -10320,7 +10320,7 @@
           <p:nvPr/>
         </p:nvPicPr>
         <p:blipFill>
-          <a:blip xmlns:r="http://schemas.openxmlformats.org/officeDocument/2006/relationships" xmlns:a="http://schemas.openxmlformats.org/drawingml/2006/main" r:embed="R5421dad5f70e40f1"/>
+          <a:blip xmlns:r="http://schemas.openxmlformats.org/officeDocument/2006/relationships" xmlns:a="http://schemas.openxmlformats.org/drawingml/2006/main" r:embed="Rcb1e27caca7445c2"/>
           <a:stretch xmlns:a="http://schemas.openxmlformats.org/drawingml/2006/main">
             <a:fillRect l="0" t="0" r="0" b="0"/>
           </a:stretch>
@@ -10427,7 +10427,7 @@
   </p:cSld>
   <p:clrMap bg1="lt1" tx1="dk1" bg2="lt2" tx2="dk2" accent1="accent1" accent2="accent2" accent3="accent3" accent4="accent4" accent5="accent5" accent6="accent6" hlink="hlink" folHlink="folHlink"/>
   <p:sldLayoutIdLst>
-    <p:sldLayoutId xmlns:r="http://schemas.openxmlformats.org/officeDocument/2006/relationships" id="2147483679" r:id="R43eb7ee42d044234"/>
+    <p:sldLayoutId xmlns:r="http://schemas.openxmlformats.org/officeDocument/2006/relationships" id="2147483679" r:id="Rcd63dae349ab4fba"/>
   </p:sldLayoutIdLst>
   <p:hf hdr="0" dt="0"/>
   <p:txStyles>
@@ -10858,7 +10858,7 @@
           <p:nvPr/>
         </p:nvPicPr>
         <p:blipFill>
-          <a:blip xmlns:r="http://schemas.openxmlformats.org/officeDocument/2006/relationships" xmlns:a="http://schemas.openxmlformats.org/drawingml/2006/main" r:embed="Rbca2a666e1c6401e"/>
+          <a:blip xmlns:r="http://schemas.openxmlformats.org/officeDocument/2006/relationships" xmlns:a="http://schemas.openxmlformats.org/drawingml/2006/main" r:embed="R65af7736ccec408a"/>
           <a:stretch xmlns:a="http://schemas.openxmlformats.org/drawingml/2006/main">
             <a:fillRect l="0" t="0" r="0" b="0"/>
           </a:stretch>
@@ -10965,7 +10965,7 @@
   </p:cSld>
   <p:clrMap bg1="lt1" tx1="dk1" bg2="lt2" tx2="dk2" accent1="accent1" accent2="accent2" accent3="accent3" accent4="accent4" accent5="accent5" accent6="accent6" hlink="hlink" folHlink="folHlink"/>
   <p:sldLayoutIdLst>
-    <p:sldLayoutId xmlns:r="http://schemas.openxmlformats.org/officeDocument/2006/relationships" id="2147483681" r:id="R90854993d219471a"/>
+    <p:sldLayoutId xmlns:r="http://schemas.openxmlformats.org/officeDocument/2006/relationships" id="2147483681" r:id="R4d4238a45f0b406f"/>
   </p:sldLayoutIdLst>
   <p:hf hdr="0" dt="0"/>
   <p:txStyles>
@@ -13179,7 +13179,7 @@
           <p:nvPr/>
         </p:nvPicPr>
         <p:blipFill>
-          <a:blip xmlns:r="http://schemas.openxmlformats.org/officeDocument/2006/relationships" xmlns:a="http://schemas.openxmlformats.org/drawingml/2006/main" r:embed="R00d14ca362b8479c"/>
+          <a:blip xmlns:r="http://schemas.openxmlformats.org/officeDocument/2006/relationships" xmlns:a="http://schemas.openxmlformats.org/drawingml/2006/main" r:embed="Ra8e1ed3ce6f24162"/>
           <a:stretch xmlns:a="http://schemas.openxmlformats.org/drawingml/2006/main">
             <a:fillRect l="0" t="0" r="0" b="0"/>
           </a:stretch>
@@ -13246,7 +13246,7 @@
           </a:p>
           <a:p xmlns:a="http://schemas.openxmlformats.org/drawingml/2006/main">
             <a:r>
-              <a:t>Ming Liang | Final project presentation | July 2026</a:t>
+              <a:t>soluthan | Final project presentation | July 2026</a:t>
             </a:r>
           </a:p>
         </p:txBody>
@@ -14241,7 +14241,7 @@
           <p:cNvPr id="7" name="">
             <a:extLst xmlns:a="http://schemas.openxmlformats.org/drawingml/2006/main">
               <a:ext uri="{FF2B5EF4-FFF2-40B4-BE49-F238E27FC236}">
-                <a16:creationId xmlns:a16="http://schemas.microsoft.com/office/drawing/2014/main" id="{D01AFA04-91DC-4AF6-A35B-83C800AFCF2B}"/>
+                <a16:creationId xmlns:a16="http://schemas.microsoft.com/office/drawing/2014/main" id="{1285EDA0-5DE3-4AB6-A960-8130A20C1556}"/>
               </a:ext>
             </a:extLst>
           </p:cNvPr>
@@ -14274,7 +14274,7 @@
           <p:cNvPr id="8" name="">
             <a:extLst xmlns:a="http://schemas.openxmlformats.org/drawingml/2006/main">
               <a:ext uri="{FF2B5EF4-FFF2-40B4-BE49-F238E27FC236}">
-                <a16:creationId xmlns:a16="http://schemas.microsoft.com/office/drawing/2014/main" id="{43FAECC5-D2F1-488D-92C6-18651429A603}"/>
+                <a16:creationId xmlns:a16="http://schemas.microsoft.com/office/drawing/2014/main" id="{E38E9282-90DF-4CEF-87A6-DCFE09704FA7}"/>
               </a:ext>
             </a:extLst>
           </p:cNvPr>
@@ -14324,7 +14324,7 @@
           <p:cNvPr id="9" name="">
             <a:extLst xmlns:a="http://schemas.openxmlformats.org/drawingml/2006/main">
               <a:ext uri="{FF2B5EF4-FFF2-40B4-BE49-F238E27FC236}">
-                <a16:creationId xmlns:a16="http://schemas.microsoft.com/office/drawing/2014/main" id="{6E63E3F4-959E-4A46-876E-FB927945FACD}"/>
+                <a16:creationId xmlns:a16="http://schemas.microsoft.com/office/drawing/2014/main" id="{C4E6AB7C-1FA2-4AD3-A3C0-2D938E6EB77F}"/>
               </a:ext>
             </a:extLst>
           </p:cNvPr>
@@ -14374,7 +14374,7 @@
           <p:cNvPr id="10" name="">
             <a:extLst xmlns:a="http://schemas.openxmlformats.org/drawingml/2006/main">
               <a:ext uri="{FF2B5EF4-FFF2-40B4-BE49-F238E27FC236}">
-                <a16:creationId xmlns:a16="http://schemas.microsoft.com/office/drawing/2014/main" id="{98044173-AA32-4405-A5DA-216B3C15E17E}"/>
+                <a16:creationId xmlns:a16="http://schemas.microsoft.com/office/drawing/2014/main" id="{BDE6BD0C-2F28-49B6-9990-391E52111678}"/>
               </a:ext>
             </a:extLst>
           </p:cNvPr>
@@ -14407,7 +14407,7 @@
           <p:cNvPr id="11" name="">
             <a:extLst xmlns:a="http://schemas.openxmlformats.org/drawingml/2006/main">
               <a:ext uri="{FF2B5EF4-FFF2-40B4-BE49-F238E27FC236}">
-                <a16:creationId xmlns:a16="http://schemas.microsoft.com/office/drawing/2014/main" id="{7F168E22-1991-4FA0-9696-FD357A5FAF28}"/>
+                <a16:creationId xmlns:a16="http://schemas.microsoft.com/office/drawing/2014/main" id="{6DAA2806-F397-4735-A6EE-170E32A2717A}"/>
               </a:ext>
             </a:extLst>
           </p:cNvPr>
@@ -14457,7 +14457,7 @@
           <p:cNvPr id="12" name="">
             <a:extLst xmlns:a="http://schemas.openxmlformats.org/drawingml/2006/main">
               <a:ext uri="{FF2B5EF4-FFF2-40B4-BE49-F238E27FC236}">
-                <a16:creationId xmlns:a16="http://schemas.microsoft.com/office/drawing/2014/main" id="{FEEFBF91-1F12-4E00-BFD4-F295BA13A944}"/>
+                <a16:creationId xmlns:a16="http://schemas.microsoft.com/office/drawing/2014/main" id="{C41D1B8A-C7C4-4F18-85D6-056132BC5AFD}"/>
               </a:ext>
             </a:extLst>
           </p:cNvPr>
@@ -14507,7 +14507,7 @@
           <p:cNvPr id="13" name="">
             <a:extLst xmlns:a="http://schemas.openxmlformats.org/drawingml/2006/main">
               <a:ext uri="{FF2B5EF4-FFF2-40B4-BE49-F238E27FC236}">
-                <a16:creationId xmlns:a16="http://schemas.microsoft.com/office/drawing/2014/main" id="{4845D1E4-750A-48AE-BFC3-3E1DAAA39D33}"/>
+                <a16:creationId xmlns:a16="http://schemas.microsoft.com/office/drawing/2014/main" id="{DEBFFCF4-7D48-409F-8942-E7903519B987}"/>
               </a:ext>
             </a:extLst>
           </p:cNvPr>
@@ -14540,7 +14540,7 @@
           <p:cNvPr id="14" name="">
             <a:extLst xmlns:a="http://schemas.openxmlformats.org/drawingml/2006/main">
               <a:ext uri="{FF2B5EF4-FFF2-40B4-BE49-F238E27FC236}">
-                <a16:creationId xmlns:a16="http://schemas.microsoft.com/office/drawing/2014/main" id="{2A0EAF2D-FE1C-4F1D-AE88-D0532025CCD4}"/>
+                <a16:creationId xmlns:a16="http://schemas.microsoft.com/office/drawing/2014/main" id="{55ADCC09-5444-4F0F-83C7-DFCE971F063B}"/>
               </a:ext>
             </a:extLst>
           </p:cNvPr>
@@ -14590,7 +14590,7 @@
           <p:cNvPr id="15" name="">
             <a:extLst xmlns:a="http://schemas.openxmlformats.org/drawingml/2006/main">
               <a:ext uri="{FF2B5EF4-FFF2-40B4-BE49-F238E27FC236}">
-                <a16:creationId xmlns:a16="http://schemas.microsoft.com/office/drawing/2014/main" id="{2CCAF25F-E961-485E-9A80-FEA9517BFE9C}"/>
+                <a16:creationId xmlns:a16="http://schemas.microsoft.com/office/drawing/2014/main" id="{9D4129D1-411B-4F15-9775-0BED763D8970}"/>
               </a:ext>
             </a:extLst>
           </p:cNvPr>
@@ -14640,7 +14640,7 @@
           <p:cNvPr id="16" name="">
             <a:extLst xmlns:a="http://schemas.openxmlformats.org/drawingml/2006/main">
               <a:ext uri="{FF2B5EF4-FFF2-40B4-BE49-F238E27FC236}">
-                <a16:creationId xmlns:a16="http://schemas.microsoft.com/office/drawing/2014/main" id="{37141068-034D-4EE2-A04C-FB5A9ACA1AB7}"/>
+                <a16:creationId xmlns:a16="http://schemas.microsoft.com/office/drawing/2014/main" id="{F4576094-0DBA-4508-8322-41CD48DB3B1C}"/>
               </a:ext>
             </a:extLst>
           </p:cNvPr>
@@ -14870,7 +14870,7 @@
           <p:cNvPr id="7" name="">
             <a:extLst xmlns:a="http://schemas.openxmlformats.org/drawingml/2006/main">
               <a:ext uri="{FF2B5EF4-FFF2-40B4-BE49-F238E27FC236}">
-                <a16:creationId xmlns:a16="http://schemas.microsoft.com/office/drawing/2014/main" id="{4AADD3FD-E5BC-451F-B38E-6592F7BA249A}"/>
+                <a16:creationId xmlns:a16="http://schemas.microsoft.com/office/drawing/2014/main" id="{FE58300D-AD43-46E5-83B0-435D00D94B23}"/>
               </a:ext>
             </a:extLst>
           </p:cNvPr>
@@ -14903,7 +14903,7 @@
           <p:cNvPr id="8" name="">
             <a:extLst xmlns:a="http://schemas.openxmlformats.org/drawingml/2006/main">
               <a:ext uri="{FF2B5EF4-FFF2-40B4-BE49-F238E27FC236}">
-                <a16:creationId xmlns:a16="http://schemas.microsoft.com/office/drawing/2014/main" id="{CD74D665-8296-474E-A7A6-3C719BFE4EDB}"/>
+                <a16:creationId xmlns:a16="http://schemas.microsoft.com/office/drawing/2014/main" id="{C260DF0B-72BB-4152-9C53-CAAB2920362C}"/>
               </a:ext>
             </a:extLst>
           </p:cNvPr>
@@ -14953,7 +14953,7 @@
           <p:cNvPr id="9" name="">
             <a:extLst xmlns:a="http://schemas.openxmlformats.org/drawingml/2006/main">
               <a:ext uri="{FF2B5EF4-FFF2-40B4-BE49-F238E27FC236}">
-                <a16:creationId xmlns:a16="http://schemas.microsoft.com/office/drawing/2014/main" id="{E5DEC01C-6F6D-4B7C-897F-B6ED9423EFA3}"/>
+                <a16:creationId xmlns:a16="http://schemas.microsoft.com/office/drawing/2014/main" id="{F50674C3-A7F6-4BAD-A449-BF132B616FFD}"/>
               </a:ext>
             </a:extLst>
           </p:cNvPr>
@@ -14984,7 +14984,7 @@
           <p:cNvPr id="10" name="">
             <a:extLst xmlns:a="http://schemas.openxmlformats.org/drawingml/2006/main">
               <a:ext uri="{FF2B5EF4-FFF2-40B4-BE49-F238E27FC236}">
-                <a16:creationId xmlns:a16="http://schemas.microsoft.com/office/drawing/2014/main" id="{7807F31B-1D20-4A79-AD3A-71AB0F5BAF3D}"/>
+                <a16:creationId xmlns:a16="http://schemas.microsoft.com/office/drawing/2014/main" id="{D29BEB69-FC12-4CD1-A8BD-CDC0F011AC71}"/>
               </a:ext>
             </a:extLst>
           </p:cNvPr>
@@ -15034,7 +15034,7 @@
           <p:cNvPr id="11" name="">
             <a:extLst xmlns:a="http://schemas.openxmlformats.org/drawingml/2006/main">
               <a:ext uri="{FF2B5EF4-FFF2-40B4-BE49-F238E27FC236}">
-                <a16:creationId xmlns:a16="http://schemas.microsoft.com/office/drawing/2014/main" id="{F4C802F0-B8CF-4BAB-8622-F3B4BA16A2AA}"/>
+                <a16:creationId xmlns:a16="http://schemas.microsoft.com/office/drawing/2014/main" id="{FD42DC32-3734-4284-A9E1-DB4A6CCC5B11}"/>
               </a:ext>
             </a:extLst>
           </p:cNvPr>
@@ -15065,7 +15065,7 @@
           <p:cNvPr id="12" name="">
             <a:extLst xmlns:a="http://schemas.openxmlformats.org/drawingml/2006/main">
               <a:ext uri="{FF2B5EF4-FFF2-40B4-BE49-F238E27FC236}">
-                <a16:creationId xmlns:a16="http://schemas.microsoft.com/office/drawing/2014/main" id="{C0F764D8-87B8-4AB4-BB50-3D6A099AAED8}"/>
+                <a16:creationId xmlns:a16="http://schemas.microsoft.com/office/drawing/2014/main" id="{3BA2F3F8-DDD5-4816-97D8-8B645D978585}"/>
               </a:ext>
             </a:extLst>
           </p:cNvPr>
@@ -15115,7 +15115,7 @@
           <p:cNvPr id="13" name="">
             <a:extLst xmlns:a="http://schemas.openxmlformats.org/drawingml/2006/main">
               <a:ext uri="{FF2B5EF4-FFF2-40B4-BE49-F238E27FC236}">
-                <a16:creationId xmlns:a16="http://schemas.microsoft.com/office/drawing/2014/main" id="{2C944491-7E61-4087-8F31-F3498E3F8784}"/>
+                <a16:creationId xmlns:a16="http://schemas.microsoft.com/office/drawing/2014/main" id="{AC3F99C5-7F2A-45F7-9205-83A1367ED32D}"/>
               </a:ext>
             </a:extLst>
           </p:cNvPr>
@@ -15146,7 +15146,7 @@
           <p:cNvPr id="14" name="">
             <a:extLst xmlns:a="http://schemas.openxmlformats.org/drawingml/2006/main">
               <a:ext uri="{FF2B5EF4-FFF2-40B4-BE49-F238E27FC236}">
-                <a16:creationId xmlns:a16="http://schemas.microsoft.com/office/drawing/2014/main" id="{2D333E22-C3E0-4EE0-AE08-49CB586F67A2}"/>
+                <a16:creationId xmlns:a16="http://schemas.microsoft.com/office/drawing/2014/main" id="{48AD6342-7AF7-4B8D-90C6-00721F776C02}"/>
               </a:ext>
             </a:extLst>
           </p:cNvPr>
@@ -15196,7 +15196,7 @@
           <p:cNvPr id="15" name="">
             <a:extLst xmlns:a="http://schemas.openxmlformats.org/drawingml/2006/main">
               <a:ext uri="{FF2B5EF4-FFF2-40B4-BE49-F238E27FC236}">
-                <a16:creationId xmlns:a16="http://schemas.microsoft.com/office/drawing/2014/main" id="{3A330572-4047-4332-A6A0-B3B5A5C3DED6}"/>
+                <a16:creationId xmlns:a16="http://schemas.microsoft.com/office/drawing/2014/main" id="{5AE0B5B2-61C3-4079-9BA0-E59E6C729FD1}"/>
               </a:ext>
             </a:extLst>
           </p:cNvPr>
@@ -15229,7 +15229,7 @@
           <p:cNvPr id="16" name="">
             <a:extLst xmlns:a="http://schemas.openxmlformats.org/drawingml/2006/main">
               <a:ext uri="{FF2B5EF4-FFF2-40B4-BE49-F238E27FC236}">
-                <a16:creationId xmlns:a16="http://schemas.microsoft.com/office/drawing/2014/main" id="{1ACCCF7D-3A3B-4963-991A-3769C0F2FB2F}"/>
+                <a16:creationId xmlns:a16="http://schemas.microsoft.com/office/drawing/2014/main" id="{79BDF618-B7D9-4D8A-886C-D7A90998DBFE}"/>
               </a:ext>
             </a:extLst>
           </p:cNvPr>
@@ -15279,7 +15279,7 @@
           <p:cNvPr id="17" name="">
             <a:extLst xmlns:a="http://schemas.openxmlformats.org/drawingml/2006/main">
               <a:ext uri="{FF2B5EF4-FFF2-40B4-BE49-F238E27FC236}">
-                <a16:creationId xmlns:a16="http://schemas.microsoft.com/office/drawing/2014/main" id="{3874E45B-D495-4E9D-8434-10943EA04DE8}"/>
+                <a16:creationId xmlns:a16="http://schemas.microsoft.com/office/drawing/2014/main" id="{453ED001-5537-4B29-B2DB-6F698046377E}"/>
               </a:ext>
             </a:extLst>
           </p:cNvPr>
@@ -15310,7 +15310,7 @@
           <p:cNvPr id="18" name="">
             <a:extLst xmlns:a="http://schemas.openxmlformats.org/drawingml/2006/main">
               <a:ext uri="{FF2B5EF4-FFF2-40B4-BE49-F238E27FC236}">
-                <a16:creationId xmlns:a16="http://schemas.microsoft.com/office/drawing/2014/main" id="{A9289DDF-2DE4-44BB-B1E5-2EB4E310EBF9}"/>
+                <a16:creationId xmlns:a16="http://schemas.microsoft.com/office/drawing/2014/main" id="{67935473-847E-404B-A302-BA3B50D81432}"/>
               </a:ext>
             </a:extLst>
           </p:cNvPr>
@@ -15360,7 +15360,7 @@
           <p:cNvPr id="19" name="">
             <a:extLst xmlns:a="http://schemas.openxmlformats.org/drawingml/2006/main">
               <a:ext uri="{FF2B5EF4-FFF2-40B4-BE49-F238E27FC236}">
-                <a16:creationId xmlns:a16="http://schemas.microsoft.com/office/drawing/2014/main" id="{00AEB120-13F9-471D-8241-1A4385C01200}"/>
+                <a16:creationId xmlns:a16="http://schemas.microsoft.com/office/drawing/2014/main" id="{E9CB9E12-86E4-4D67-B840-1D21C9D7385C}"/>
               </a:ext>
             </a:extLst>
           </p:cNvPr>
@@ -15391,7 +15391,7 @@
           <p:cNvPr id="20" name="">
             <a:extLst xmlns:a="http://schemas.openxmlformats.org/drawingml/2006/main">
               <a:ext uri="{FF2B5EF4-FFF2-40B4-BE49-F238E27FC236}">
-                <a16:creationId xmlns:a16="http://schemas.microsoft.com/office/drawing/2014/main" id="{8F1F12EE-7E7D-4876-8780-693FE672865C}"/>
+                <a16:creationId xmlns:a16="http://schemas.microsoft.com/office/drawing/2014/main" id="{0B1189F9-E716-4D8F-8781-E8ADC7E981F3}"/>
               </a:ext>
             </a:extLst>
           </p:cNvPr>
@@ -15441,7 +15441,7 @@
           <p:cNvPr id="21" name="">
             <a:extLst xmlns:a="http://schemas.openxmlformats.org/drawingml/2006/main">
               <a:ext uri="{FF2B5EF4-FFF2-40B4-BE49-F238E27FC236}">
-                <a16:creationId xmlns:a16="http://schemas.microsoft.com/office/drawing/2014/main" id="{63A0B12C-35FD-4C4D-BACC-D8838B78FB94}"/>
+                <a16:creationId xmlns:a16="http://schemas.microsoft.com/office/drawing/2014/main" id="{3569D6AE-C48B-484A-9DA5-CC70CE961090}"/>
               </a:ext>
             </a:extLst>
           </p:cNvPr>
@@ -15472,7 +15472,7 @@
           <p:cNvPr id="22" name="">
             <a:extLst xmlns:a="http://schemas.openxmlformats.org/drawingml/2006/main">
               <a:ext uri="{FF2B5EF4-FFF2-40B4-BE49-F238E27FC236}">
-                <a16:creationId xmlns:a16="http://schemas.microsoft.com/office/drawing/2014/main" id="{55678F79-5D8E-4C08-9E56-603B50035179}"/>
+                <a16:creationId xmlns:a16="http://schemas.microsoft.com/office/drawing/2014/main" id="{EA574023-3D18-404B-B353-F30841C3D151}"/>
               </a:ext>
             </a:extLst>
           </p:cNvPr>
@@ -15522,7 +15522,7 @@
           <p:cNvPr id="23" name="">
             <a:extLst xmlns:a="http://schemas.openxmlformats.org/drawingml/2006/main">
               <a:ext uri="{FF2B5EF4-FFF2-40B4-BE49-F238E27FC236}">
-                <a16:creationId xmlns:a16="http://schemas.microsoft.com/office/drawing/2014/main" id="{EA18C900-744D-4EC3-B774-00686A7032F1}"/>
+                <a16:creationId xmlns:a16="http://schemas.microsoft.com/office/drawing/2014/main" id="{77A39309-4948-45B3-8D1C-01541455B47E}"/>
               </a:ext>
             </a:extLst>
           </p:cNvPr>
@@ -15555,7 +15555,7 @@
           <p:cNvPr id="24" name="">
             <a:extLst xmlns:a="http://schemas.openxmlformats.org/drawingml/2006/main">
               <a:ext uri="{FF2B5EF4-FFF2-40B4-BE49-F238E27FC236}">
-                <a16:creationId xmlns:a16="http://schemas.microsoft.com/office/drawing/2014/main" id="{34C3ED8D-897A-4C26-BDB0-BBD4D1385A37}"/>
+                <a16:creationId xmlns:a16="http://schemas.microsoft.com/office/drawing/2014/main" id="{6FDFDAAE-66BA-494B-90D8-2C0A6018392A}"/>
               </a:ext>
             </a:extLst>
           </p:cNvPr>
@@ -15605,7 +15605,7 @@
           <p:cNvPr id="25" name="">
             <a:extLst xmlns:a="http://schemas.openxmlformats.org/drawingml/2006/main">
               <a:ext uri="{FF2B5EF4-FFF2-40B4-BE49-F238E27FC236}">
-                <a16:creationId xmlns:a16="http://schemas.microsoft.com/office/drawing/2014/main" id="{15BA2986-B149-46C4-8A3B-7FD691DBEE3E}"/>
+                <a16:creationId xmlns:a16="http://schemas.microsoft.com/office/drawing/2014/main" id="{DB0F5690-32B2-4E73-BCFC-65F14EEA872C}"/>
               </a:ext>
             </a:extLst>
           </p:cNvPr>
@@ -15636,7 +15636,7 @@
           <p:cNvPr id="26" name="">
             <a:extLst xmlns:a="http://schemas.openxmlformats.org/drawingml/2006/main">
               <a:ext uri="{FF2B5EF4-FFF2-40B4-BE49-F238E27FC236}">
-                <a16:creationId xmlns:a16="http://schemas.microsoft.com/office/drawing/2014/main" id="{89892A8E-2F9C-40CB-B8F0-5F54B368D120}"/>
+                <a16:creationId xmlns:a16="http://schemas.microsoft.com/office/drawing/2014/main" id="{C2BF3D16-C258-4489-8EFC-07D4EC393A06}"/>
               </a:ext>
             </a:extLst>
           </p:cNvPr>
@@ -15686,7 +15686,7 @@
           <p:cNvPr id="27" name="">
             <a:extLst xmlns:a="http://schemas.openxmlformats.org/drawingml/2006/main">
               <a:ext uri="{FF2B5EF4-FFF2-40B4-BE49-F238E27FC236}">
-                <a16:creationId xmlns:a16="http://schemas.microsoft.com/office/drawing/2014/main" id="{58C53FAD-91BE-4632-ACFC-B8EF61AC4BBE}"/>
+                <a16:creationId xmlns:a16="http://schemas.microsoft.com/office/drawing/2014/main" id="{723940C0-92F5-4544-97A8-D4CF85904B84}"/>
               </a:ext>
             </a:extLst>
           </p:cNvPr>
@@ -15717,7 +15717,7 @@
           <p:cNvPr id="28" name="">
             <a:extLst xmlns:a="http://schemas.openxmlformats.org/drawingml/2006/main">
               <a:ext uri="{FF2B5EF4-FFF2-40B4-BE49-F238E27FC236}">
-                <a16:creationId xmlns:a16="http://schemas.microsoft.com/office/drawing/2014/main" id="{84BBC913-B249-46DF-AA9F-0F34973F4795}"/>
+                <a16:creationId xmlns:a16="http://schemas.microsoft.com/office/drawing/2014/main" id="{51C358B3-E423-41E8-B4A5-651CE4A5052B}"/>
               </a:ext>
             </a:extLst>
           </p:cNvPr>
@@ -15767,7 +15767,7 @@
           <p:cNvPr id="29" name="">
             <a:extLst xmlns:a="http://schemas.openxmlformats.org/drawingml/2006/main">
               <a:ext uri="{FF2B5EF4-FFF2-40B4-BE49-F238E27FC236}">
-                <a16:creationId xmlns:a16="http://schemas.microsoft.com/office/drawing/2014/main" id="{3A7FB69E-C0BD-4C56-86F1-DB898C1CFF04}"/>
+                <a16:creationId xmlns:a16="http://schemas.microsoft.com/office/drawing/2014/main" id="{CA9E5744-D33F-4804-ABCC-C4452FCA39DD}"/>
               </a:ext>
             </a:extLst>
           </p:cNvPr>
@@ -15798,7 +15798,7 @@
           <p:cNvPr id="30" name="">
             <a:extLst xmlns:a="http://schemas.openxmlformats.org/drawingml/2006/main">
               <a:ext uri="{FF2B5EF4-FFF2-40B4-BE49-F238E27FC236}">
-                <a16:creationId xmlns:a16="http://schemas.microsoft.com/office/drawing/2014/main" id="{4428105B-79AF-44EF-80F6-5296CF97A01F}"/>
+                <a16:creationId xmlns:a16="http://schemas.microsoft.com/office/drawing/2014/main" id="{9DB1A701-D8B8-419D-8EFC-2502D18D6C0D}"/>
               </a:ext>
             </a:extLst>
           </p:cNvPr>
@@ -15848,7 +15848,7 @@
           <p:cNvPr id="31" name="">
             <a:extLst xmlns:a="http://schemas.openxmlformats.org/drawingml/2006/main">
               <a:ext uri="{FF2B5EF4-FFF2-40B4-BE49-F238E27FC236}">
-                <a16:creationId xmlns:a16="http://schemas.microsoft.com/office/drawing/2014/main" id="{EE778D06-48F0-4BCE-A889-2ACC1659FA8E}"/>
+                <a16:creationId xmlns:a16="http://schemas.microsoft.com/office/drawing/2014/main" id="{950598EB-DA64-4D17-8B8E-2D9CF466FB16}"/>
               </a:ext>
             </a:extLst>
           </p:cNvPr>
@@ -15881,7 +15881,7 @@
           <p:cNvPr id="32" name="">
             <a:extLst xmlns:a="http://schemas.openxmlformats.org/drawingml/2006/main">
               <a:ext uri="{FF2B5EF4-FFF2-40B4-BE49-F238E27FC236}">
-                <a16:creationId xmlns:a16="http://schemas.microsoft.com/office/drawing/2014/main" id="{7F45402D-B856-448F-A0CF-499E2E892663}"/>
+                <a16:creationId xmlns:a16="http://schemas.microsoft.com/office/drawing/2014/main" id="{61C39E4B-F241-476C-A137-CAAFAA6B785B}"/>
               </a:ext>
             </a:extLst>
           </p:cNvPr>
@@ -15931,7 +15931,7 @@
           <p:cNvPr id="33" name="">
             <a:extLst xmlns:a="http://schemas.openxmlformats.org/drawingml/2006/main">
               <a:ext uri="{FF2B5EF4-FFF2-40B4-BE49-F238E27FC236}">
-                <a16:creationId xmlns:a16="http://schemas.microsoft.com/office/drawing/2014/main" id="{4E92B1D2-7F15-40F4-8D79-0A9126CA0C3B}"/>
+                <a16:creationId xmlns:a16="http://schemas.microsoft.com/office/drawing/2014/main" id="{43DCF9E5-1D91-4240-992F-EF242BD4FC1B}"/>
               </a:ext>
             </a:extLst>
           </p:cNvPr>
@@ -15962,7 +15962,7 @@
           <p:cNvPr id="34" name="">
             <a:extLst xmlns:a="http://schemas.openxmlformats.org/drawingml/2006/main">
               <a:ext uri="{FF2B5EF4-FFF2-40B4-BE49-F238E27FC236}">
-                <a16:creationId xmlns:a16="http://schemas.microsoft.com/office/drawing/2014/main" id="{EE4355B5-8044-4BB0-AE10-0262884B0632}"/>
+                <a16:creationId xmlns:a16="http://schemas.microsoft.com/office/drawing/2014/main" id="{CAB8C4CD-124B-423A-B8F2-83E8E5D2A256}"/>
               </a:ext>
             </a:extLst>
           </p:cNvPr>
@@ -16012,7 +16012,7 @@
           <p:cNvPr id="35" name="">
             <a:extLst xmlns:a="http://schemas.openxmlformats.org/drawingml/2006/main">
               <a:ext uri="{FF2B5EF4-FFF2-40B4-BE49-F238E27FC236}">
-                <a16:creationId xmlns:a16="http://schemas.microsoft.com/office/drawing/2014/main" id="{1FAC11C5-F0FA-47B3-A461-D2CFEF2F67F5}"/>
+                <a16:creationId xmlns:a16="http://schemas.microsoft.com/office/drawing/2014/main" id="{8E151CB7-6D3D-465A-B902-D1424DE4155E}"/>
               </a:ext>
             </a:extLst>
           </p:cNvPr>
@@ -16043,7 +16043,7 @@
           <p:cNvPr id="36" name="">
             <a:extLst xmlns:a="http://schemas.openxmlformats.org/drawingml/2006/main">
               <a:ext uri="{FF2B5EF4-FFF2-40B4-BE49-F238E27FC236}">
-                <a16:creationId xmlns:a16="http://schemas.microsoft.com/office/drawing/2014/main" id="{0CF291C0-F70F-42AB-946F-1FED97F07B93}"/>
+                <a16:creationId xmlns:a16="http://schemas.microsoft.com/office/drawing/2014/main" id="{7A10FA40-83E1-4D27-B92A-188734C4EDC4}"/>
               </a:ext>
             </a:extLst>
           </p:cNvPr>
@@ -16093,7 +16093,7 @@
           <p:cNvPr id="37" name="">
             <a:extLst xmlns:a="http://schemas.openxmlformats.org/drawingml/2006/main">
               <a:ext uri="{FF2B5EF4-FFF2-40B4-BE49-F238E27FC236}">
-                <a16:creationId xmlns:a16="http://schemas.microsoft.com/office/drawing/2014/main" id="{39057947-7C2B-4F29-8E3C-85DFB51F3D49}"/>
+                <a16:creationId xmlns:a16="http://schemas.microsoft.com/office/drawing/2014/main" id="{40149701-1C50-40FD-82D9-0F5B8B600D3F}"/>
               </a:ext>
             </a:extLst>
           </p:cNvPr>
@@ -16124,7 +16124,7 @@
           <p:cNvPr id="38" name="">
             <a:extLst xmlns:a="http://schemas.openxmlformats.org/drawingml/2006/main">
               <a:ext uri="{FF2B5EF4-FFF2-40B4-BE49-F238E27FC236}">
-                <a16:creationId xmlns:a16="http://schemas.microsoft.com/office/drawing/2014/main" id="{BAAB6720-40E5-4231-99DA-D2D2F6165650}"/>
+                <a16:creationId xmlns:a16="http://schemas.microsoft.com/office/drawing/2014/main" id="{1C2653C1-6A44-48BA-8DC9-49F7216529C5}"/>
               </a:ext>
             </a:extLst>
           </p:cNvPr>
@@ -16174,7 +16174,7 @@
           <p:cNvPr id="39" name="">
             <a:extLst xmlns:a="http://schemas.openxmlformats.org/drawingml/2006/main">
               <a:ext uri="{FF2B5EF4-FFF2-40B4-BE49-F238E27FC236}">
-                <a16:creationId xmlns:a16="http://schemas.microsoft.com/office/drawing/2014/main" id="{A541BA5D-8D27-48B7-8AD2-FC6EB6533926}"/>
+                <a16:creationId xmlns:a16="http://schemas.microsoft.com/office/drawing/2014/main" id="{4CA9061F-0A0E-4EB7-9ED5-53C6C1136F1A}"/>
               </a:ext>
             </a:extLst>
           </p:cNvPr>
@@ -16207,7 +16207,7 @@
           <p:cNvPr id="40" name="">
             <a:extLst xmlns:a="http://schemas.openxmlformats.org/drawingml/2006/main">
               <a:ext uri="{FF2B5EF4-FFF2-40B4-BE49-F238E27FC236}">
-                <a16:creationId xmlns:a16="http://schemas.microsoft.com/office/drawing/2014/main" id="{E1DDC2D5-0388-4B46-912E-BE291F9D45AC}"/>
+                <a16:creationId xmlns:a16="http://schemas.microsoft.com/office/drawing/2014/main" id="{2C4B225E-E3BF-442D-AB7B-6F15B140FE42}"/>
               </a:ext>
             </a:extLst>
           </p:cNvPr>
@@ -16257,7 +16257,7 @@
           <p:cNvPr id="41" name="">
             <a:extLst xmlns:a="http://schemas.openxmlformats.org/drawingml/2006/main">
               <a:ext uri="{FF2B5EF4-FFF2-40B4-BE49-F238E27FC236}">
-                <a16:creationId xmlns:a16="http://schemas.microsoft.com/office/drawing/2014/main" id="{94F748D4-AF3A-4CFE-BF22-1652CE219183}"/>
+                <a16:creationId xmlns:a16="http://schemas.microsoft.com/office/drawing/2014/main" id="{2CD3DFE5-CE4D-4E82-840C-A330410D6713}"/>
               </a:ext>
             </a:extLst>
           </p:cNvPr>
@@ -16288,7 +16288,7 @@
           <p:cNvPr id="42" name="">
             <a:extLst xmlns:a="http://schemas.openxmlformats.org/drawingml/2006/main">
               <a:ext uri="{FF2B5EF4-FFF2-40B4-BE49-F238E27FC236}">
-                <a16:creationId xmlns:a16="http://schemas.microsoft.com/office/drawing/2014/main" id="{5F627E27-53C4-4E9D-B9C3-C07DAE16EC7D}"/>
+                <a16:creationId xmlns:a16="http://schemas.microsoft.com/office/drawing/2014/main" id="{B9AB7C7C-FAD6-4C96-B6BA-2C07131D1240}"/>
               </a:ext>
             </a:extLst>
           </p:cNvPr>
@@ -16338,7 +16338,7 @@
           <p:cNvPr id="43" name="">
             <a:extLst xmlns:a="http://schemas.openxmlformats.org/drawingml/2006/main">
               <a:ext uri="{FF2B5EF4-FFF2-40B4-BE49-F238E27FC236}">
-                <a16:creationId xmlns:a16="http://schemas.microsoft.com/office/drawing/2014/main" id="{94EE4C75-3C8B-46AD-9591-3F04462250B4}"/>
+                <a16:creationId xmlns:a16="http://schemas.microsoft.com/office/drawing/2014/main" id="{4191188E-E87B-4CE5-B801-4167A8DBB66B}"/>
               </a:ext>
             </a:extLst>
           </p:cNvPr>
@@ -16369,7 +16369,7 @@
           <p:cNvPr id="44" name="">
             <a:extLst xmlns:a="http://schemas.openxmlformats.org/drawingml/2006/main">
               <a:ext uri="{FF2B5EF4-FFF2-40B4-BE49-F238E27FC236}">
-                <a16:creationId xmlns:a16="http://schemas.microsoft.com/office/drawing/2014/main" id="{56A545E9-A550-4863-8F50-6463DF74B8FE}"/>
+                <a16:creationId xmlns:a16="http://schemas.microsoft.com/office/drawing/2014/main" id="{C8E479F3-EAA2-45F4-A2E4-CDB7D5ED7F3E}"/>
               </a:ext>
             </a:extLst>
           </p:cNvPr>
@@ -16419,7 +16419,7 @@
           <p:cNvPr id="45" name="">
             <a:extLst xmlns:a="http://schemas.openxmlformats.org/drawingml/2006/main">
               <a:ext uri="{FF2B5EF4-FFF2-40B4-BE49-F238E27FC236}">
-                <a16:creationId xmlns:a16="http://schemas.microsoft.com/office/drawing/2014/main" id="{A07AF7B7-A107-4871-92D5-C267D1C63F54}"/>
+                <a16:creationId xmlns:a16="http://schemas.microsoft.com/office/drawing/2014/main" id="{733AF275-DA17-4D84-B336-070432A9DB6A}"/>
               </a:ext>
             </a:extLst>
           </p:cNvPr>
@@ -16450,7 +16450,7 @@
           <p:cNvPr id="46" name="">
             <a:extLst xmlns:a="http://schemas.openxmlformats.org/drawingml/2006/main">
               <a:ext uri="{FF2B5EF4-FFF2-40B4-BE49-F238E27FC236}">
-                <a16:creationId xmlns:a16="http://schemas.microsoft.com/office/drawing/2014/main" id="{2E644005-4996-40DE-82E0-7B965C5A37EF}"/>
+                <a16:creationId xmlns:a16="http://schemas.microsoft.com/office/drawing/2014/main" id="{D43F5FB2-1CDD-42B6-8596-3338CBC133DC}"/>
               </a:ext>
             </a:extLst>
           </p:cNvPr>
@@ -16500,7 +16500,7 @@
           <p:cNvPr id="47" name="">
             <a:extLst xmlns:a="http://schemas.openxmlformats.org/drawingml/2006/main">
               <a:ext uri="{FF2B5EF4-FFF2-40B4-BE49-F238E27FC236}">
-                <a16:creationId xmlns:a16="http://schemas.microsoft.com/office/drawing/2014/main" id="{1282B31C-20EE-4324-AF11-AF185A4273AF}"/>
+                <a16:creationId xmlns:a16="http://schemas.microsoft.com/office/drawing/2014/main" id="{D2E190EC-ACF1-417F-80F8-B308A258A2D4}"/>
               </a:ext>
             </a:extLst>
           </p:cNvPr>
@@ -16707,7 +16707,7 @@
         </p:xfrm>
         <a:graphic xmlns:a="http://schemas.openxmlformats.org/drawingml/2006/main">
           <a:graphicData uri="http://schemas.openxmlformats.org/drawingml/2006/chart">
-            <c:chart xmlns:r="http://schemas.openxmlformats.org/officeDocument/2006/relationships" xmlns:c="http://schemas.openxmlformats.org/drawingml/2006/chart" r:id="Rbb2415458dfa472a"/>
+            <c:chart xmlns:r="http://schemas.openxmlformats.org/officeDocument/2006/relationships" xmlns:c="http://schemas.openxmlformats.org/drawingml/2006/chart" r:id="Rc63073dc0ac84d8e"/>
           </a:graphicData>
         </a:graphic>
       </p:graphicFrame>
@@ -16716,7 +16716,7 @@
           <p:cNvPr id="8" name="">
             <a:extLst xmlns:a="http://schemas.openxmlformats.org/drawingml/2006/main">
               <a:ext uri="{FF2B5EF4-FFF2-40B4-BE49-F238E27FC236}">
-                <a16:creationId xmlns:a16="http://schemas.microsoft.com/office/drawing/2014/main" id="{D0D53B40-0FF3-4CD7-A264-A125A01ED587}"/>
+                <a16:creationId xmlns:a16="http://schemas.microsoft.com/office/drawing/2014/main" id="{7ABE2744-2123-4663-8934-1DC8DFE92A4A}"/>
               </a:ext>
             </a:extLst>
           </p:cNvPr>

</xml_diff>

<commit_message>
Document local data deliverables
</commit_message>
<xml_diff>
--- a/report/ebay_anchoring_rl_presentation.pptx
+++ b/report/ebay_anchoring_rl_presentation.pptx
@@ -2,26 +2,27 @@
 <file path=ppt/presentation.xml><?xml version="1.0" encoding="utf-8"?>
 <p:presentation xmlns:p="http://schemas.openxmlformats.org/presentationml/2006/main">
   <p:sldMasterIdLst>
-    <p:sldMasterId xmlns:r="http://schemas.openxmlformats.org/officeDocument/2006/relationships" id="2147483648" r:id="Reccd2d69562a4e10"/>
+    <p:sldMasterId xmlns:r="http://schemas.openxmlformats.org/officeDocument/2006/relationships" id="2147483648" r:id="Rb18b11d49b1a4a87"/>
   </p:sldMasterIdLst>
   <p:notesMasterIdLst>
-    <p:notesMasterId xmlns:r="http://schemas.openxmlformats.org/officeDocument/2006/relationships" r:id="R965cc9f0266148aa"/>
+    <p:notesMasterId xmlns:r="http://schemas.openxmlformats.org/officeDocument/2006/relationships" r:id="R17906ce6c9864ee5"/>
   </p:notesMasterIdLst>
   <p:sldIdLst>
-    <p:sldId xmlns:r="http://schemas.openxmlformats.org/officeDocument/2006/relationships" id="256" r:id="R6465e1d50e874c7a"/>
-    <p:sldId xmlns:r="http://schemas.openxmlformats.org/officeDocument/2006/relationships" id="257" r:id="R00f1fd69f23c49ea"/>
-    <p:sldId xmlns:r="http://schemas.openxmlformats.org/officeDocument/2006/relationships" id="258" r:id="R09079d0f1a754969"/>
-    <p:sldId xmlns:r="http://schemas.openxmlformats.org/officeDocument/2006/relationships" id="259" r:id="R9f5f854875eb4ea7"/>
-    <p:sldId xmlns:r="http://schemas.openxmlformats.org/officeDocument/2006/relationships" id="260" r:id="R919a38ba02244ee6"/>
-    <p:sldId xmlns:r="http://schemas.openxmlformats.org/officeDocument/2006/relationships" id="261" r:id="Raa286811c9254357"/>
-    <p:sldId xmlns:r="http://schemas.openxmlformats.org/officeDocument/2006/relationships" id="262" r:id="Rde3b2e9df5e14158"/>
-    <p:sldId xmlns:r="http://schemas.openxmlformats.org/officeDocument/2006/relationships" id="263" r:id="Ra97f4e6368ef495d"/>
-    <p:sldId xmlns:r="http://schemas.openxmlformats.org/officeDocument/2006/relationships" id="264" r:id="R68a49ff8c93f48fa"/>
-    <p:sldId xmlns:r="http://schemas.openxmlformats.org/officeDocument/2006/relationships" id="265" r:id="Rb582f0b3b00445fd"/>
-    <p:sldId xmlns:r="http://schemas.openxmlformats.org/officeDocument/2006/relationships" id="266" r:id="Rff90bfd289d1479e"/>
-    <p:sldId xmlns:r="http://schemas.openxmlformats.org/officeDocument/2006/relationships" id="267" r:id="Rec8132d5927a4923"/>
-    <p:sldId xmlns:r="http://schemas.openxmlformats.org/officeDocument/2006/relationships" id="268" r:id="R6f293f64b8f4443f"/>
-    <p:sldId xmlns:r="http://schemas.openxmlformats.org/officeDocument/2006/relationships" id="269" r:id="Rb46a4f1c97d34894"/>
+    <p:sldId xmlns:r="http://schemas.openxmlformats.org/officeDocument/2006/relationships" id="256" r:id="R06e1c4abb53c4108"/>
+    <p:sldId xmlns:r="http://schemas.openxmlformats.org/officeDocument/2006/relationships" id="257" r:id="R71e60174eb224aee"/>
+    <p:sldId xmlns:r="http://schemas.openxmlformats.org/officeDocument/2006/relationships" id="258" r:id="R9ccebb2805cb420d"/>
+    <p:sldId xmlns:r="http://schemas.openxmlformats.org/officeDocument/2006/relationships" id="259" r:id="R914bc5981272473e"/>
+    <p:sldId xmlns:r="http://schemas.openxmlformats.org/officeDocument/2006/relationships" id="260" r:id="R23ee085260d04396"/>
+    <p:sldId xmlns:r="http://schemas.openxmlformats.org/officeDocument/2006/relationships" id="261" r:id="R437251f166274495"/>
+    <p:sldId xmlns:r="http://schemas.openxmlformats.org/officeDocument/2006/relationships" id="262" r:id="R4f75eb74ff684624"/>
+    <p:sldId xmlns:r="http://schemas.openxmlformats.org/officeDocument/2006/relationships" id="263" r:id="Re4cc04a768f5454c"/>
+    <p:sldId xmlns:r="http://schemas.openxmlformats.org/officeDocument/2006/relationships" id="264" r:id="R39779d0770234719"/>
+    <p:sldId xmlns:r="http://schemas.openxmlformats.org/officeDocument/2006/relationships" id="265" r:id="Rf0851880686d40ec"/>
+    <p:sldId xmlns:r="http://schemas.openxmlformats.org/officeDocument/2006/relationships" id="266" r:id="R46a1eed907394a3e"/>
+    <p:sldId xmlns:r="http://schemas.openxmlformats.org/officeDocument/2006/relationships" id="267" r:id="Re00eddf80dda4df9"/>
+    <p:sldId xmlns:r="http://schemas.openxmlformats.org/officeDocument/2006/relationships" id="268" r:id="R86524e7d278e40cc"/>
+    <p:sldId xmlns:r="http://schemas.openxmlformats.org/officeDocument/2006/relationships" id="269" r:id="R6814c36df9404a80"/>
+    <p:sldId xmlns:r="http://schemas.openxmlformats.org/officeDocument/2006/relationships" id="270" r:id="Ra8a45ae55f9646c8"/>
   </p:sldIdLst>
   <p:sldSz cx="9144000" cy="5143500"/>
   <p:notesSz cx="6858000" cy="9144000"/>
@@ -949,6 +950,72 @@
 </p:notes>
 </file>
 
+<file path=ppt/notesSlides/notesSlide15.xml><?xml version="1.0" encoding="utf-8"?>
+<p:notes xmlns:p="http://schemas.openxmlformats.org/presentationml/2006/main">
+  <p:cSld>
+    <p:spTree>
+      <p:nvGrpSpPr>
+        <p:cNvPr id="1" name=""/>
+        <p:cNvGrpSpPr/>
+        <p:nvPr/>
+      </p:nvGrpSpPr>
+      <p:grpSpPr>
+        <a:xfrm xmlns:a="http://schemas.openxmlformats.org/drawingml/2006/main"/>
+      </p:grpSpPr>
+      <p:sp>
+        <p:nvSpPr>
+          <p:cNvPr id="2" name="Slide Image Placeholder 1"/>
+          <p:cNvSpPr>
+            <a:spLocks xmlns:a="http://schemas.openxmlformats.org/drawingml/2006/main" noGrp="1"/>
+          </p:cNvSpPr>
+          <p:nvPr>
+            <p:ph type="sldImg" idx="0"/>
+          </p:nvPr>
+        </p:nvSpPr>
+        <p:spPr/>
+      </p:sp>
+      <p:sp>
+        <p:nvSpPr>
+          <p:cNvPr id="3" name="Notes Placeholder 2"/>
+          <p:cNvSpPr>
+            <a:spLocks xmlns:a="http://schemas.openxmlformats.org/drawingml/2006/main" noGrp="1"/>
+          </p:cNvSpPr>
+          <p:nvPr>
+            <p:ph type="body" idx="1"/>
+          </p:nvPr>
+        </p:nvSpPr>
+        <p:spPr/>
+        <p:txBody>
+          <a:bodyPr xmlns:a="http://schemas.openxmlformats.org/drawingml/2006/main"/>
+          <a:lstStyle xmlns:a="http://schemas.openxmlformats.org/drawingml/2006/main"/>
+          <a:p xmlns:a="http://schemas.openxmlformats.org/drawingml/2006/main"/>
+        </p:txBody>
+      </p:sp>
+      <p:sp>
+        <p:nvSpPr>
+          <p:cNvPr id="4" name="Slide Number Placeholder 3"/>
+          <p:cNvSpPr>
+            <a:spLocks xmlns:a="http://schemas.openxmlformats.org/drawingml/2006/main" noGrp="1"/>
+          </p:cNvSpPr>
+          <p:nvPr>
+            <p:ph type="sldNum" idx="5"/>
+          </p:nvPr>
+        </p:nvSpPr>
+        <p:spPr/>
+        <p:txBody>
+          <a:bodyPr xmlns:a="http://schemas.openxmlformats.org/drawingml/2006/main"/>
+          <a:lstStyle xmlns:a="http://schemas.openxmlformats.org/drawingml/2006/main"/>
+          <a:p xmlns:a="http://schemas.openxmlformats.org/drawingml/2006/main"/>
+        </p:txBody>
+      </p:sp>
+    </p:spTree>
+  </p:cSld>
+  <p:clrMapOvr>
+    <a:masterClrMapping xmlns:a="http://schemas.openxmlformats.org/drawingml/2006/main"/>
+  </p:clrMapOvr>
+</p:notes>
+</file>
+
 <file path=ppt/notesSlides/notesSlide2.xml><?xml version="1.0" encoding="utf-8"?>
 <p:notes xmlns:p="http://schemas.openxmlformats.org/presentationml/2006/main">
   <p:cSld>
@@ -4435,17 +4502,17 @@
   </p:cSld>
   <p:clrMap bg1="lt1" tx1="dk1" bg2="lt2" tx2="dk2" accent1="accent1" accent2="accent2" accent3="accent3" accent4="accent4" accent5="accent5" accent6="accent6" hlink="hlink" folHlink="folHlink"/>
   <p:sldLayoutIdLst>
-    <p:sldLayoutId xmlns:r="http://schemas.openxmlformats.org/officeDocument/2006/relationships" id="2147483649" r:id="R90fdd8cd5cdc4f3d"/>
-    <p:sldLayoutId xmlns:r="http://schemas.openxmlformats.org/officeDocument/2006/relationships" id="2147483650" r:id="Rf44d275cb39349b2"/>
-    <p:sldLayoutId xmlns:r="http://schemas.openxmlformats.org/officeDocument/2006/relationships" id="2147483651" r:id="Rf4bfd9db91184d82"/>
-    <p:sldLayoutId xmlns:r="http://schemas.openxmlformats.org/officeDocument/2006/relationships" id="2147483652" r:id="R24c3c3f209764c26"/>
-    <p:sldLayoutId xmlns:r="http://schemas.openxmlformats.org/officeDocument/2006/relationships" id="2147483653" r:id="Rd374eccfa321482c"/>
-    <p:sldLayoutId xmlns:r="http://schemas.openxmlformats.org/officeDocument/2006/relationships" id="2147483654" r:id="R767cd620b42b4d76"/>
-    <p:sldLayoutId xmlns:r="http://schemas.openxmlformats.org/officeDocument/2006/relationships" id="2147483655" r:id="R4b87c222a39547b3"/>
-    <p:sldLayoutId xmlns:r="http://schemas.openxmlformats.org/officeDocument/2006/relationships" id="2147483656" r:id="Rb00fb10d8e3d45c4"/>
-    <p:sldLayoutId xmlns:r="http://schemas.openxmlformats.org/officeDocument/2006/relationships" id="2147483657" r:id="R0d2102cb5d07499d"/>
-    <p:sldLayoutId xmlns:r="http://schemas.openxmlformats.org/officeDocument/2006/relationships" id="2147483658" r:id="R58b7b80cdfee4adb"/>
-    <p:sldLayoutId xmlns:r="http://schemas.openxmlformats.org/officeDocument/2006/relationships" id="2147483659" r:id="Rcc2a293c09dc4792"/>
+    <p:sldLayoutId xmlns:r="http://schemas.openxmlformats.org/officeDocument/2006/relationships" id="2147483649" r:id="R83e70888bb23499e"/>
+    <p:sldLayoutId xmlns:r="http://schemas.openxmlformats.org/officeDocument/2006/relationships" id="2147483650" r:id="R1767977c581d4835"/>
+    <p:sldLayoutId xmlns:r="http://schemas.openxmlformats.org/officeDocument/2006/relationships" id="2147483651" r:id="Red5587056e884629"/>
+    <p:sldLayoutId xmlns:r="http://schemas.openxmlformats.org/officeDocument/2006/relationships" id="2147483652" r:id="Ra41f1bdad1e04776"/>
+    <p:sldLayoutId xmlns:r="http://schemas.openxmlformats.org/officeDocument/2006/relationships" id="2147483653" r:id="R00b7778e8b6d4f1a"/>
+    <p:sldLayoutId xmlns:r="http://schemas.openxmlformats.org/officeDocument/2006/relationships" id="2147483654" r:id="R5f7ac345e5a948df"/>
+    <p:sldLayoutId xmlns:r="http://schemas.openxmlformats.org/officeDocument/2006/relationships" id="2147483655" r:id="Re27b9ef12f994ceb"/>
+    <p:sldLayoutId xmlns:r="http://schemas.openxmlformats.org/officeDocument/2006/relationships" id="2147483656" r:id="R85a04191d6064dc9"/>
+    <p:sldLayoutId xmlns:r="http://schemas.openxmlformats.org/officeDocument/2006/relationships" id="2147483657" r:id="Rdf2685746d1243e1"/>
+    <p:sldLayoutId xmlns:r="http://schemas.openxmlformats.org/officeDocument/2006/relationships" id="2147483658" r:id="Rc5053c11f2384d6d"/>
+    <p:sldLayoutId xmlns:r="http://schemas.openxmlformats.org/officeDocument/2006/relationships" id="2147483659" r:id="R7e122ed921414cf0"/>
   </p:sldLayoutIdLst>
   <p:txStyles>
     <p:titleStyle>
@@ -6026,7 +6093,7 @@
           <p:nvPr/>
         </p:nvPicPr>
         <p:blipFill>
-          <a:blip xmlns:r="http://schemas.openxmlformats.org/officeDocument/2006/relationships" xmlns:a="http://schemas.openxmlformats.org/drawingml/2006/main" r:embed="Rf9b3417492414603"/>
+          <a:blip xmlns:r="http://schemas.openxmlformats.org/officeDocument/2006/relationships" xmlns:a="http://schemas.openxmlformats.org/drawingml/2006/main" r:embed="R920131b0e46b4504"/>
           <a:stretch xmlns:a="http://schemas.openxmlformats.org/drawingml/2006/main">
             <a:fillRect l="0" t="0" r="0" b="0"/>
           </a:stretch>
@@ -6329,7 +6396,7 @@
           <p:nvPr/>
         </p:nvPicPr>
         <p:blipFill>
-          <a:blip xmlns:r="http://schemas.openxmlformats.org/officeDocument/2006/relationships" xmlns:a="http://schemas.openxmlformats.org/drawingml/2006/main" r:embed="R676b2d4cf30c402a"/>
+          <a:blip xmlns:r="http://schemas.openxmlformats.org/officeDocument/2006/relationships" xmlns:a="http://schemas.openxmlformats.org/drawingml/2006/main" r:embed="R13c728c21e4f46a2"/>
           <a:stretch xmlns:a="http://schemas.openxmlformats.org/drawingml/2006/main">
             <a:fillRect l="0" t="0" r="0" b="0"/>
           </a:stretch>
@@ -6625,7 +6692,7 @@
           <p:nvPr/>
         </p:nvPicPr>
         <p:blipFill>
-          <a:blip xmlns:r="http://schemas.openxmlformats.org/officeDocument/2006/relationships" xmlns:a="http://schemas.openxmlformats.org/drawingml/2006/main" r:embed="R54c9799cf1ec4b9f"/>
+          <a:blip xmlns:r="http://schemas.openxmlformats.org/officeDocument/2006/relationships" xmlns:a="http://schemas.openxmlformats.org/drawingml/2006/main" r:embed="R96f9dbd99e8f4684"/>
           <a:stretch xmlns:a="http://schemas.openxmlformats.org/drawingml/2006/main">
             <a:fillRect l="0" t="0" r="0" b="0"/>
           </a:stretch>
@@ -7543,7 +7610,7 @@
           <p:nvPr/>
         </p:nvPicPr>
         <p:blipFill>
-          <a:blip xmlns:r="http://schemas.openxmlformats.org/officeDocument/2006/relationships" xmlns:a="http://schemas.openxmlformats.org/drawingml/2006/main" r:embed="Rb117954d25944c30"/>
+          <a:blip xmlns:r="http://schemas.openxmlformats.org/officeDocument/2006/relationships" xmlns:a="http://schemas.openxmlformats.org/drawingml/2006/main" r:embed="R9b40bd527ba242e2"/>
           <a:stretch xmlns:a="http://schemas.openxmlformats.org/drawingml/2006/main">
             <a:fillRect l="0" t="0" r="0" b="0"/>
           </a:stretch>
@@ -8139,7 +8206,7 @@
           <p:nvPr/>
         </p:nvPicPr>
         <p:blipFill>
-          <a:blip xmlns:r="http://schemas.openxmlformats.org/officeDocument/2006/relationships" xmlns:a="http://schemas.openxmlformats.org/drawingml/2006/main" r:embed="R17027f840cb949c3"/>
+          <a:blip xmlns:r="http://schemas.openxmlformats.org/officeDocument/2006/relationships" xmlns:a="http://schemas.openxmlformats.org/drawingml/2006/main" r:embed="R88f30944e7a54d84"/>
           <a:stretch xmlns:a="http://schemas.openxmlformats.org/drawingml/2006/main">
             <a:fillRect l="0" t="0" r="0" b="0"/>
           </a:stretch>
@@ -8535,6 +8602,7 @@
           <a:lstStyle xmlns:a="http://schemas.openxmlformats.org/drawingml/2006/main"/>
           <a:p xmlns:a="http://schemas.openxmlformats.org/drawingml/2006/main">
             <a:pPr algn="l">
+              <a:buNone/>
               <a:defRPr sz="2175" b="1" i="0">
                 <a:solidFill>
                   <a:srgbClr val="000000"/>
@@ -8616,6 +8684,7 @@
           <a:lstStyle xmlns:a="http://schemas.openxmlformats.org/drawingml/2006/main"/>
           <a:p xmlns:a="http://schemas.openxmlformats.org/drawingml/2006/main">
             <a:pPr algn="l">
+              <a:buNone/>
               <a:defRPr sz="1238" b="0" i="0">
                 <a:solidFill>
                   <a:srgbClr val="6B6B6B"/>
@@ -8730,6 +8799,7 @@
           <a:lstStyle xmlns:a="http://schemas.openxmlformats.org/drawingml/2006/main"/>
           <a:p xmlns:a="http://schemas.openxmlformats.org/drawingml/2006/main">
             <a:pPr algn="l">
+              <a:buNone/>
               <a:defRPr sz="1350" b="1" i="0">
                 <a:solidFill>
                   <a:srgbClr val="005293"/>
@@ -8780,6 +8850,7 @@
           <a:lstStyle xmlns:a="http://schemas.openxmlformats.org/drawingml/2006/main"/>
           <a:p xmlns:a="http://schemas.openxmlformats.org/drawingml/2006/main">
             <a:pPr algn="l">
+              <a:buNone/>
               <a:defRPr sz="1088" b="0" i="0">
                 <a:solidFill>
                   <a:srgbClr val="000000"/>
@@ -8894,6 +8965,7 @@
           <a:lstStyle xmlns:a="http://schemas.openxmlformats.org/drawingml/2006/main"/>
           <a:p xmlns:a="http://schemas.openxmlformats.org/drawingml/2006/main">
             <a:pPr algn="l">
+              <a:buNone/>
               <a:defRPr sz="1350" b="1" i="0">
                 <a:solidFill>
                   <a:srgbClr val="005293"/>
@@ -8944,6 +9016,7 @@
           <a:lstStyle xmlns:a="http://schemas.openxmlformats.org/drawingml/2006/main"/>
           <a:p xmlns:a="http://schemas.openxmlformats.org/drawingml/2006/main">
             <a:pPr algn="l">
+              <a:buNone/>
               <a:defRPr sz="1088" b="0" i="0">
                 <a:solidFill>
                   <a:srgbClr val="000000"/>
@@ -8961,6 +9034,7 @@
           </a:p>
           <a:p xmlns:a="http://schemas.openxmlformats.org/drawingml/2006/main">
             <a:pPr algn="l">
+              <a:buNone/>
               <a:defRPr sz="1088" b="0" i="0">
                 <a:solidFill>
                   <a:srgbClr val="000000"/>
@@ -9075,6 +9149,7 @@
           <a:lstStyle xmlns:a="http://schemas.openxmlformats.org/drawingml/2006/main"/>
           <a:p xmlns:a="http://schemas.openxmlformats.org/drawingml/2006/main">
             <a:pPr algn="l">
+              <a:buNone/>
               <a:defRPr sz="1350" b="1" i="0">
                 <a:solidFill>
                   <a:srgbClr val="005293"/>
@@ -9125,6 +9200,7 @@
           <a:lstStyle xmlns:a="http://schemas.openxmlformats.org/drawingml/2006/main"/>
           <a:p xmlns:a="http://schemas.openxmlformats.org/drawingml/2006/main">
             <a:pPr algn="l">
+              <a:buNone/>
               <a:defRPr sz="1088" b="0" i="0">
                 <a:solidFill>
                   <a:srgbClr val="000000"/>
@@ -9208,6 +9284,7 @@
           <a:lstStyle xmlns:a="http://schemas.openxmlformats.org/drawingml/2006/main"/>
           <a:p xmlns:a="http://schemas.openxmlformats.org/drawingml/2006/main">
             <a:pPr algn="ctr">
+              <a:buNone/>
               <a:defRPr sz="1140" b="1" i="0">
                 <a:solidFill>
                   <a:srgbClr val="005293"/>
@@ -9258,6 +9335,7 @@
           <a:lstStyle xmlns:a="http://schemas.openxmlformats.org/drawingml/2006/main"/>
           <a:p xmlns:a="http://schemas.openxmlformats.org/drawingml/2006/main">
             <a:pPr algn="l">
+              <a:buNone/>
               <a:defRPr sz="1102" b="0" i="0">
                 <a:solidFill>
                   <a:srgbClr val="000000"/>
@@ -9308,6 +9386,7 @@
           <a:lstStyle xmlns:a="http://schemas.openxmlformats.org/drawingml/2006/main"/>
           <a:p xmlns:a="http://schemas.openxmlformats.org/drawingml/2006/main">
             <a:pPr algn="r">
+              <a:buNone/>
               <a:defRPr sz="1102" b="0" i="0">
                 <a:solidFill>
                   <a:srgbClr val="000000"/>
@@ -9329,6 +9408,1237 @@
     <p:extLst>
       <p:ext uri="{BB962C8B-B14F-4D97-AF65-F5344CB8AC3E}">
         <p14:creationId xmlns:p14="http://schemas.microsoft.com/office/powerpoint/2010/main" val="985585785"/>
+      </p:ext>
+    </p:extLst>
+  </p:cSld>
+</p:sld>
+</file>
+
+<file path=ppt/slides/slide15.xml><?xml version="1.0" encoding="utf-8"?>
+<p:sld xmlns:p="http://schemas.openxmlformats.org/presentationml/2006/main">
+  <p:cSld>
+    <p:bg>
+      <p:bgPr>
+        <a:solidFill xmlns:a="http://schemas.openxmlformats.org/drawingml/2006/main">
+          <a:srgbClr val="FFFFFF"/>
+        </a:solidFill>
+      </p:bgPr>
+    </p:bg>
+    <p:spTree>
+      <p:nvGrpSpPr>
+        <p:cNvPr id="1" name=""/>
+        <p:cNvGrpSpPr/>
+        <p:nvPr/>
+      </p:nvGrpSpPr>
+      <p:grpSpPr>
+        <a:xfrm xmlns:a="http://schemas.openxmlformats.org/drawingml/2006/main"/>
+      </p:grpSpPr>
+      <p:sp>
+        <p:nvSpPr>
+          <p:cNvPr id="1" name="">
+            <a:extLst xmlns:a="http://schemas.openxmlformats.org/drawingml/2006/main">
+              <a:ext uri="{FF2B5EF4-FFF2-40B4-BE49-F238E27FC236}">
+                <a16:creationId xmlns:a16="http://schemas.microsoft.com/office/drawing/2014/main" id="{222E4CEA-A60B-4B78-BEE9-F39BC428FDD4}"/>
+              </a:ext>
+            </a:extLst>
+          </p:cNvPr>
+          <p:cNvSpPr>
+            <a:spLocks xmlns:a="http://schemas.openxmlformats.org/drawingml/2006/main" noGrp="1"/>
+          </p:cNvSpPr>
+          <p:nvPr/>
+        </p:nvSpPr>
+        <p:spPr>
+          <a:xfrm xmlns:a="http://schemas.openxmlformats.org/drawingml/2006/main">
+            <a:off x="514350" y="381000"/>
+            <a:ext cx="8048625" cy="409575"/>
+          </a:xfrm>
+          <a:prstGeom xmlns:a="http://schemas.openxmlformats.org/drawingml/2006/main" prst="rect">
+            <a:avLst/>
+          </a:prstGeom>
+          <a:noFill xmlns:a="http://schemas.openxmlformats.org/drawingml/2006/main"/>
+          <a:ln xmlns:a="http://schemas.openxmlformats.org/drawingml/2006/main" w="0">
+            <a:noFill/>
+            <a:prstDash val="solid"/>
+          </a:ln>
+        </p:spPr>
+        <p:txBody>
+          <a:bodyPr xmlns:a="http://schemas.openxmlformats.org/drawingml/2006/main"/>
+          <a:lstStyle xmlns:a="http://schemas.openxmlformats.org/drawingml/2006/main"/>
+          <a:p xmlns:a="http://schemas.openxmlformats.org/drawingml/2006/main">
+            <a:pPr algn="l">
+              <a:defRPr sz="2175" b="1">
+                <a:solidFill>
+                  <a:srgbClr val="000000"/>
+                </a:solidFill>
+              </a:defRPr>
+            </a:pPr>
+            <a:r>
+              <a:rPr sz="2175" b="1">
+                <a:solidFill>
+                  <a:srgbClr val="000000"/>
+                </a:solidFill>
+              </a:rPr>
+              <a:t>Appendix: real data deliverables are local, not tracked</a:t>
+            </a:r>
+          </a:p>
+        </p:txBody>
+      </p:sp>
+      <p:sp>
+        <p:nvSpPr>
+          <p:cNvPr id="2" name="">
+            <a:extLst xmlns:a="http://schemas.openxmlformats.org/drawingml/2006/main">
+              <a:ext uri="{FF2B5EF4-FFF2-40B4-BE49-F238E27FC236}">
+                <a16:creationId xmlns:a16="http://schemas.microsoft.com/office/drawing/2014/main" id="{0FDD08E2-31FA-4D31-A546-F99EBFA4424F}"/>
+              </a:ext>
+            </a:extLst>
+          </p:cNvPr>
+          <p:cNvSpPr>
+            <a:spLocks xmlns:a="http://schemas.openxmlformats.org/drawingml/2006/main" noGrp="1"/>
+          </p:cNvSpPr>
+          <p:nvPr/>
+        </p:nvSpPr>
+        <p:spPr>
+          <a:xfrm xmlns:a="http://schemas.openxmlformats.org/drawingml/2006/main">
+            <a:off x="514350" y="876300"/>
+            <a:ext cx="1524000" cy="28575"/>
+          </a:xfrm>
+          <a:prstGeom xmlns:a="http://schemas.openxmlformats.org/drawingml/2006/main" prst="rect">
+            <a:avLst/>
+          </a:prstGeom>
+          <a:solidFill xmlns:a="http://schemas.openxmlformats.org/drawingml/2006/main">
+            <a:srgbClr val="005293"/>
+          </a:solidFill>
+          <a:ln xmlns:a="http://schemas.openxmlformats.org/drawingml/2006/main" w="0">
+            <a:noFill/>
+            <a:prstDash val="solid"/>
+          </a:ln>
+        </p:spPr>
+      </p:sp>
+      <p:sp>
+        <p:nvSpPr>
+          <p:cNvPr id="3" name="">
+            <a:extLst xmlns:a="http://schemas.openxmlformats.org/drawingml/2006/main">
+              <a:ext uri="{FF2B5EF4-FFF2-40B4-BE49-F238E27FC236}">
+                <a16:creationId xmlns:a16="http://schemas.microsoft.com/office/drawing/2014/main" id="{CD08FDA4-C2E3-4353-AED5-49F87F5E082E}"/>
+              </a:ext>
+            </a:extLst>
+          </p:cNvPr>
+          <p:cNvSpPr>
+            <a:spLocks xmlns:a="http://schemas.openxmlformats.org/drawingml/2006/main" noGrp="1"/>
+          </p:cNvSpPr>
+          <p:nvPr/>
+        </p:nvSpPr>
+        <p:spPr>
+          <a:xfrm xmlns:a="http://schemas.openxmlformats.org/drawingml/2006/main">
+            <a:off x="514350" y="1104900"/>
+            <a:ext cx="7810500" cy="304800"/>
+          </a:xfrm>
+          <a:prstGeom xmlns:a="http://schemas.openxmlformats.org/drawingml/2006/main" prst="rect">
+            <a:avLst/>
+          </a:prstGeom>
+          <a:noFill xmlns:a="http://schemas.openxmlformats.org/drawingml/2006/main"/>
+          <a:ln xmlns:a="http://schemas.openxmlformats.org/drawingml/2006/main" w="0">
+            <a:noFill/>
+            <a:prstDash val="solid"/>
+          </a:ln>
+        </p:spPr>
+        <p:txBody>
+          <a:bodyPr xmlns:a="http://schemas.openxmlformats.org/drawingml/2006/main"/>
+          <a:lstStyle xmlns:a="http://schemas.openxmlformats.org/drawingml/2006/main"/>
+          <a:p xmlns:a="http://schemas.openxmlformats.org/drawingml/2006/main">
+            <a:pPr algn="l">
+              <a:defRPr sz="1238" b="0">
+                <a:solidFill>
+                  <a:srgbClr val="666666"/>
+                </a:solidFill>
+              </a:defRPr>
+            </a:pPr>
+            <a:r>
+              <a:rPr sz="1238" b="0">
+                <a:solidFill>
+                  <a:srgbClr val="666666"/>
+                </a:solidFill>
+              </a:rPr>
+              <a:t>The repository tracks code and final report assets; production reruns recreate these ignored local files.</a:t>
+            </a:r>
+          </a:p>
+        </p:txBody>
+      </p:sp>
+      <p:sp>
+        <p:nvSpPr>
+          <p:cNvPr id="4" name="">
+            <a:extLst xmlns:a="http://schemas.openxmlformats.org/drawingml/2006/main">
+              <a:ext uri="{FF2B5EF4-FFF2-40B4-BE49-F238E27FC236}">
+                <a16:creationId xmlns:a16="http://schemas.microsoft.com/office/drawing/2014/main" id="{C3118999-1055-4853-B7D2-1B330F733539}"/>
+              </a:ext>
+            </a:extLst>
+          </p:cNvPr>
+          <p:cNvSpPr>
+            <a:spLocks xmlns:a="http://schemas.openxmlformats.org/drawingml/2006/main" noGrp="1"/>
+          </p:cNvSpPr>
+          <p:nvPr/>
+        </p:nvSpPr>
+        <p:spPr>
+          <a:xfrm xmlns:a="http://schemas.openxmlformats.org/drawingml/2006/main">
+            <a:off x="514350" y="1676400"/>
+            <a:ext cx="2457450" cy="790575"/>
+          </a:xfrm>
+          <a:prstGeom xmlns:a="http://schemas.openxmlformats.org/drawingml/2006/main" prst="rect">
+            <a:avLst/>
+          </a:prstGeom>
+          <a:solidFill xmlns:a="http://schemas.openxmlformats.org/drawingml/2006/main">
+            <a:srgbClr val="FFFFFF"/>
+          </a:solidFill>
+          <a:ln xmlns:a="http://schemas.openxmlformats.org/drawingml/2006/main" w="9525">
+            <a:solidFill>
+              <a:srgbClr val="D7E6F2"/>
+            </a:solidFill>
+            <a:prstDash val="solid"/>
+          </a:ln>
+        </p:spPr>
+      </p:sp>
+      <p:sp>
+        <p:nvSpPr>
+          <p:cNvPr id="5" name="">
+            <a:extLst xmlns:a="http://schemas.openxmlformats.org/drawingml/2006/main">
+              <a:ext uri="{FF2B5EF4-FFF2-40B4-BE49-F238E27FC236}">
+                <a16:creationId xmlns:a16="http://schemas.microsoft.com/office/drawing/2014/main" id="{DE9F2EC6-BD0F-4DA0-A85B-747D2400BE62}"/>
+              </a:ext>
+            </a:extLst>
+          </p:cNvPr>
+          <p:cNvSpPr>
+            <a:spLocks xmlns:a="http://schemas.openxmlformats.org/drawingml/2006/main" noGrp="1"/>
+          </p:cNvSpPr>
+          <p:nvPr/>
+        </p:nvSpPr>
+        <p:spPr>
+          <a:xfrm xmlns:a="http://schemas.openxmlformats.org/drawingml/2006/main">
+            <a:off x="514350" y="1676400"/>
+            <a:ext cx="66675" cy="790575"/>
+          </a:xfrm>
+          <a:prstGeom xmlns:a="http://schemas.openxmlformats.org/drawingml/2006/main" prst="rect">
+            <a:avLst/>
+          </a:prstGeom>
+          <a:solidFill xmlns:a="http://schemas.openxmlformats.org/drawingml/2006/main">
+            <a:srgbClr val="005293"/>
+          </a:solidFill>
+          <a:ln xmlns:a="http://schemas.openxmlformats.org/drawingml/2006/main" w="0">
+            <a:noFill/>
+            <a:prstDash val="solid"/>
+          </a:ln>
+        </p:spPr>
+      </p:sp>
+      <p:sp>
+        <p:nvSpPr>
+          <p:cNvPr id="6" name="">
+            <a:extLst xmlns:a="http://schemas.openxmlformats.org/drawingml/2006/main">
+              <a:ext uri="{FF2B5EF4-FFF2-40B4-BE49-F238E27FC236}">
+                <a16:creationId xmlns:a16="http://schemas.microsoft.com/office/drawing/2014/main" id="{5666912E-8C27-4C8E-8DA6-C7F64826AC07}"/>
+              </a:ext>
+            </a:extLst>
+          </p:cNvPr>
+          <p:cNvSpPr>
+            <a:spLocks xmlns:a="http://schemas.openxmlformats.org/drawingml/2006/main" noGrp="1"/>
+          </p:cNvSpPr>
+          <p:nvPr/>
+        </p:nvSpPr>
+        <p:spPr>
+          <a:xfrm xmlns:a="http://schemas.openxmlformats.org/drawingml/2006/main">
+            <a:off x="676275" y="1771650"/>
+            <a:ext cx="2190750" cy="190500"/>
+          </a:xfrm>
+          <a:prstGeom xmlns:a="http://schemas.openxmlformats.org/drawingml/2006/main" prst="rect">
+            <a:avLst/>
+          </a:prstGeom>
+          <a:noFill xmlns:a="http://schemas.openxmlformats.org/drawingml/2006/main"/>
+          <a:ln xmlns:a="http://schemas.openxmlformats.org/drawingml/2006/main" w="0">
+            <a:noFill/>
+            <a:prstDash val="solid"/>
+          </a:ln>
+        </p:spPr>
+        <p:txBody>
+          <a:bodyPr xmlns:a="http://schemas.openxmlformats.org/drawingml/2006/main"/>
+          <a:lstStyle xmlns:a="http://schemas.openxmlformats.org/drawingml/2006/main"/>
+          <a:p xmlns:a="http://schemas.openxmlformats.org/drawingml/2006/main">
+            <a:pPr algn="l">
+              <a:defRPr sz="1125" b="1">
+                <a:solidFill>
+                  <a:srgbClr val="005293"/>
+                </a:solidFill>
+              </a:defRPr>
+            </a:pPr>
+            <a:r>
+              <a:rPr sz="1125" b="1">
+                <a:solidFill>
+                  <a:srgbClr val="005293"/>
+                </a:solidFill>
+              </a:rPr>
+              <a:t>1. Raw input</a:t>
+            </a:r>
+          </a:p>
+        </p:txBody>
+      </p:sp>
+      <p:sp>
+        <p:nvSpPr>
+          <p:cNvPr id="7" name="">
+            <a:extLst xmlns:a="http://schemas.openxmlformats.org/drawingml/2006/main">
+              <a:ext uri="{FF2B5EF4-FFF2-40B4-BE49-F238E27FC236}">
+                <a16:creationId xmlns:a16="http://schemas.microsoft.com/office/drawing/2014/main" id="{828FF00F-F8CA-4C77-8162-C7BA561FA8AD}"/>
+              </a:ext>
+            </a:extLst>
+          </p:cNvPr>
+          <p:cNvSpPr>
+            <a:spLocks xmlns:a="http://schemas.openxmlformats.org/drawingml/2006/main" noGrp="1"/>
+          </p:cNvSpPr>
+          <p:nvPr/>
+        </p:nvSpPr>
+        <p:spPr>
+          <a:xfrm xmlns:a="http://schemas.openxmlformats.org/drawingml/2006/main">
+            <a:off x="676275" y="2009775"/>
+            <a:ext cx="2190750" cy="381000"/>
+          </a:xfrm>
+          <a:prstGeom xmlns:a="http://schemas.openxmlformats.org/drawingml/2006/main" prst="rect">
+            <a:avLst/>
+          </a:prstGeom>
+          <a:noFill xmlns:a="http://schemas.openxmlformats.org/drawingml/2006/main"/>
+          <a:ln xmlns:a="http://schemas.openxmlformats.org/drawingml/2006/main" w="0">
+            <a:noFill/>
+            <a:prstDash val="solid"/>
+          </a:ln>
+        </p:spPr>
+        <p:txBody>
+          <a:bodyPr xmlns:a="http://schemas.openxmlformats.org/drawingml/2006/main"/>
+          <a:lstStyle xmlns:a="http://schemas.openxmlformats.org/drawingml/2006/main"/>
+          <a:p xmlns:a="http://schemas.openxmlformats.org/drawingml/2006/main">
+            <a:pPr algn="l">
+              <a:defRPr sz="923" b="0">
+                <a:solidFill>
+                  <a:srgbClr val="000000"/>
+                </a:solidFill>
+              </a:defRPr>
+            </a:pPr>
+            <a:r>
+              <a:rPr sz="923" b="0">
+                <a:solidFill>
+                  <a:srgbClr val="000000"/>
+                </a:solidFill>
+              </a:rPr>
+              <a:t>clean_master_dataset.parquet</a:t>
+            </a:r>
+          </a:p>
+        </p:txBody>
+      </p:sp>
+      <p:sp>
+        <p:nvSpPr>
+          <p:cNvPr id="8" name="">
+            <a:extLst xmlns:a="http://schemas.openxmlformats.org/drawingml/2006/main">
+              <a:ext uri="{FF2B5EF4-FFF2-40B4-BE49-F238E27FC236}">
+                <a16:creationId xmlns:a16="http://schemas.microsoft.com/office/drawing/2014/main" id="{732120A8-16A4-4FAF-A90F-8B9D747D49DC}"/>
+              </a:ext>
+            </a:extLst>
+          </p:cNvPr>
+          <p:cNvSpPr>
+            <a:spLocks xmlns:a="http://schemas.openxmlformats.org/drawingml/2006/main" noGrp="1"/>
+          </p:cNvSpPr>
+          <p:nvPr/>
+        </p:nvSpPr>
+        <p:spPr>
+          <a:xfrm xmlns:a="http://schemas.openxmlformats.org/drawingml/2006/main">
+            <a:off x="3343275" y="1676400"/>
+            <a:ext cx="2457450" cy="790575"/>
+          </a:xfrm>
+          <a:prstGeom xmlns:a="http://schemas.openxmlformats.org/drawingml/2006/main" prst="rect">
+            <a:avLst/>
+          </a:prstGeom>
+          <a:solidFill xmlns:a="http://schemas.openxmlformats.org/drawingml/2006/main">
+            <a:srgbClr val="FFFFFF"/>
+          </a:solidFill>
+          <a:ln xmlns:a="http://schemas.openxmlformats.org/drawingml/2006/main" w="9525">
+            <a:solidFill>
+              <a:srgbClr val="D7E6F2"/>
+            </a:solidFill>
+            <a:prstDash val="solid"/>
+          </a:ln>
+        </p:spPr>
+      </p:sp>
+      <p:sp>
+        <p:nvSpPr>
+          <p:cNvPr id="9" name="">
+            <a:extLst xmlns:a="http://schemas.openxmlformats.org/drawingml/2006/main">
+              <a:ext uri="{FF2B5EF4-FFF2-40B4-BE49-F238E27FC236}">
+                <a16:creationId xmlns:a16="http://schemas.microsoft.com/office/drawing/2014/main" id="{AAF7B4B4-9963-4404-95AE-33D41EDE86BE}"/>
+              </a:ext>
+            </a:extLst>
+          </p:cNvPr>
+          <p:cNvSpPr>
+            <a:spLocks xmlns:a="http://schemas.openxmlformats.org/drawingml/2006/main" noGrp="1"/>
+          </p:cNvSpPr>
+          <p:nvPr/>
+        </p:nvSpPr>
+        <p:spPr>
+          <a:xfrm xmlns:a="http://schemas.openxmlformats.org/drawingml/2006/main">
+            <a:off x="3343275" y="1676400"/>
+            <a:ext cx="66675" cy="790575"/>
+          </a:xfrm>
+          <a:prstGeom xmlns:a="http://schemas.openxmlformats.org/drawingml/2006/main" prst="rect">
+            <a:avLst/>
+          </a:prstGeom>
+          <a:solidFill xmlns:a="http://schemas.openxmlformats.org/drawingml/2006/main">
+            <a:srgbClr val="64A0C8"/>
+          </a:solidFill>
+          <a:ln xmlns:a="http://schemas.openxmlformats.org/drawingml/2006/main" w="0">
+            <a:noFill/>
+            <a:prstDash val="solid"/>
+          </a:ln>
+        </p:spPr>
+      </p:sp>
+      <p:sp>
+        <p:nvSpPr>
+          <p:cNvPr id="10" name="">
+            <a:extLst xmlns:a="http://schemas.openxmlformats.org/drawingml/2006/main">
+              <a:ext uri="{FF2B5EF4-FFF2-40B4-BE49-F238E27FC236}">
+                <a16:creationId xmlns:a16="http://schemas.microsoft.com/office/drawing/2014/main" id="{C271639E-39B6-4A44-AD71-CF915DAFA671}"/>
+              </a:ext>
+            </a:extLst>
+          </p:cNvPr>
+          <p:cNvSpPr>
+            <a:spLocks xmlns:a="http://schemas.openxmlformats.org/drawingml/2006/main" noGrp="1"/>
+          </p:cNvSpPr>
+          <p:nvPr/>
+        </p:nvSpPr>
+        <p:spPr>
+          <a:xfrm xmlns:a="http://schemas.openxmlformats.org/drawingml/2006/main">
+            <a:off x="3505200" y="1771650"/>
+            <a:ext cx="2190750" cy="190500"/>
+          </a:xfrm>
+          <a:prstGeom xmlns:a="http://schemas.openxmlformats.org/drawingml/2006/main" prst="rect">
+            <a:avLst/>
+          </a:prstGeom>
+          <a:noFill xmlns:a="http://schemas.openxmlformats.org/drawingml/2006/main"/>
+          <a:ln xmlns:a="http://schemas.openxmlformats.org/drawingml/2006/main" w="0">
+            <a:noFill/>
+            <a:prstDash val="solid"/>
+          </a:ln>
+        </p:spPr>
+        <p:txBody>
+          <a:bodyPr xmlns:a="http://schemas.openxmlformats.org/drawingml/2006/main"/>
+          <a:lstStyle xmlns:a="http://schemas.openxmlformats.org/drawingml/2006/main"/>
+          <a:p xmlns:a="http://schemas.openxmlformats.org/drawingml/2006/main">
+            <a:pPr algn="l">
+              <a:defRPr sz="1125" b="1">
+                <a:solidFill>
+                  <a:srgbClr val="005293"/>
+                </a:solidFill>
+              </a:defRPr>
+            </a:pPr>
+            <a:r>
+              <a:rPr sz="1125" b="1">
+                <a:solidFill>
+                  <a:srgbClr val="005293"/>
+                </a:solidFill>
+              </a:rPr>
+              <a:t>2. MDP splits</a:t>
+            </a:r>
+          </a:p>
+        </p:txBody>
+      </p:sp>
+      <p:sp>
+        <p:nvSpPr>
+          <p:cNvPr id="11" name="">
+            <a:extLst xmlns:a="http://schemas.openxmlformats.org/drawingml/2006/main">
+              <a:ext uri="{FF2B5EF4-FFF2-40B4-BE49-F238E27FC236}">
+                <a16:creationId xmlns:a16="http://schemas.microsoft.com/office/drawing/2014/main" id="{821614BE-AC71-4240-947A-51075B976E99}"/>
+              </a:ext>
+            </a:extLst>
+          </p:cNvPr>
+          <p:cNvSpPr>
+            <a:spLocks xmlns:a="http://schemas.openxmlformats.org/drawingml/2006/main" noGrp="1"/>
+          </p:cNvSpPr>
+          <p:nvPr/>
+        </p:nvSpPr>
+        <p:spPr>
+          <a:xfrm xmlns:a="http://schemas.openxmlformats.org/drawingml/2006/main">
+            <a:off x="3505200" y="2009775"/>
+            <a:ext cx="2190750" cy="381000"/>
+          </a:xfrm>
+          <a:prstGeom xmlns:a="http://schemas.openxmlformats.org/drawingml/2006/main" prst="rect">
+            <a:avLst/>
+          </a:prstGeom>
+          <a:noFill xmlns:a="http://schemas.openxmlformats.org/drawingml/2006/main"/>
+          <a:ln xmlns:a="http://schemas.openxmlformats.org/drawingml/2006/main" w="0">
+            <a:noFill/>
+            <a:prstDash val="solid"/>
+          </a:ln>
+        </p:spPr>
+        <p:txBody>
+          <a:bodyPr xmlns:a="http://schemas.openxmlformats.org/drawingml/2006/main"/>
+          <a:lstStyle xmlns:a="http://schemas.openxmlformats.org/drawingml/2006/main"/>
+          <a:p xmlns:a="http://schemas.openxmlformats.org/drawingml/2006/main">
+            <a:pPr algn="l">
+              <a:defRPr sz="923" b="0">
+                <a:solidFill>
+                  <a:srgbClr val="000000"/>
+                </a:solidFill>
+              </a:defRPr>
+            </a:pPr>
+            <a:r>
+              <a:rPr sz="923" b="0">
+                <a:solidFill>
+                  <a:srgbClr val="000000"/>
+                </a:solidFill>
+              </a:rPr>
+              <a:t>data/train.parquet, val.parquet, test.parquet</a:t>
+            </a:r>
+          </a:p>
+          <a:p xmlns:a="http://schemas.openxmlformats.org/drawingml/2006/main">
+            <a:pPr algn="l">
+              <a:defRPr sz="923" b="0">
+                <a:solidFill>
+                  <a:srgbClr val="000000"/>
+                </a:solidFill>
+              </a:defRPr>
+            </a:pPr>
+            <a:r>
+              <a:rPr sz="923" b="0">
+                <a:solidFill>
+                  <a:srgbClr val="000000"/>
+                </a:solidFill>
+              </a:rPr>
+              <a:t>split_summary.csv, preprocess_stats.json</a:t>
+            </a:r>
+          </a:p>
+        </p:txBody>
+      </p:sp>
+      <p:sp>
+        <p:nvSpPr>
+          <p:cNvPr id="12" name="">
+            <a:extLst xmlns:a="http://schemas.openxmlformats.org/drawingml/2006/main">
+              <a:ext uri="{FF2B5EF4-FFF2-40B4-BE49-F238E27FC236}">
+                <a16:creationId xmlns:a16="http://schemas.microsoft.com/office/drawing/2014/main" id="{9BA012F1-6A8A-47C2-9FBD-A9D033017807}"/>
+              </a:ext>
+            </a:extLst>
+          </p:cNvPr>
+          <p:cNvSpPr>
+            <a:spLocks xmlns:a="http://schemas.openxmlformats.org/drawingml/2006/main" noGrp="1"/>
+          </p:cNvSpPr>
+          <p:nvPr/>
+        </p:nvSpPr>
+        <p:spPr>
+          <a:xfrm xmlns:a="http://schemas.openxmlformats.org/drawingml/2006/main">
+            <a:off x="6172200" y="1676400"/>
+            <a:ext cx="2457450" cy="790575"/>
+          </a:xfrm>
+          <a:prstGeom xmlns:a="http://schemas.openxmlformats.org/drawingml/2006/main" prst="rect">
+            <a:avLst/>
+          </a:prstGeom>
+          <a:solidFill xmlns:a="http://schemas.openxmlformats.org/drawingml/2006/main">
+            <a:srgbClr val="FFFFFF"/>
+          </a:solidFill>
+          <a:ln xmlns:a="http://schemas.openxmlformats.org/drawingml/2006/main" w="9525">
+            <a:solidFill>
+              <a:srgbClr val="D7E6F2"/>
+            </a:solidFill>
+            <a:prstDash val="solid"/>
+          </a:ln>
+        </p:spPr>
+      </p:sp>
+      <p:sp>
+        <p:nvSpPr>
+          <p:cNvPr id="13" name="">
+            <a:extLst xmlns:a="http://schemas.openxmlformats.org/drawingml/2006/main">
+              <a:ext uri="{FF2B5EF4-FFF2-40B4-BE49-F238E27FC236}">
+                <a16:creationId xmlns:a16="http://schemas.microsoft.com/office/drawing/2014/main" id="{B215D18D-3942-465F-87D6-A40659A0F721}"/>
+              </a:ext>
+            </a:extLst>
+          </p:cNvPr>
+          <p:cNvSpPr>
+            <a:spLocks xmlns:a="http://schemas.openxmlformats.org/drawingml/2006/main" noGrp="1"/>
+          </p:cNvSpPr>
+          <p:nvPr/>
+        </p:nvSpPr>
+        <p:spPr>
+          <a:xfrm xmlns:a="http://schemas.openxmlformats.org/drawingml/2006/main">
+            <a:off x="6172200" y="1676400"/>
+            <a:ext cx="66675" cy="790575"/>
+          </a:xfrm>
+          <a:prstGeom xmlns:a="http://schemas.openxmlformats.org/drawingml/2006/main" prst="rect">
+            <a:avLst/>
+          </a:prstGeom>
+          <a:solidFill xmlns:a="http://schemas.openxmlformats.org/drawingml/2006/main">
+            <a:srgbClr val="A2AD00"/>
+          </a:solidFill>
+          <a:ln xmlns:a="http://schemas.openxmlformats.org/drawingml/2006/main" w="0">
+            <a:noFill/>
+            <a:prstDash val="solid"/>
+          </a:ln>
+        </p:spPr>
+      </p:sp>
+      <p:sp>
+        <p:nvSpPr>
+          <p:cNvPr id="14" name="">
+            <a:extLst xmlns:a="http://schemas.openxmlformats.org/drawingml/2006/main">
+              <a:ext uri="{FF2B5EF4-FFF2-40B4-BE49-F238E27FC236}">
+                <a16:creationId xmlns:a16="http://schemas.microsoft.com/office/drawing/2014/main" id="{BCD2BC1A-380E-433A-BAA1-330907A4C86C}"/>
+              </a:ext>
+            </a:extLst>
+          </p:cNvPr>
+          <p:cNvSpPr>
+            <a:spLocks xmlns:a="http://schemas.openxmlformats.org/drawingml/2006/main" noGrp="1"/>
+          </p:cNvSpPr>
+          <p:nvPr/>
+        </p:nvSpPr>
+        <p:spPr>
+          <a:xfrm xmlns:a="http://schemas.openxmlformats.org/drawingml/2006/main">
+            <a:off x="6334125" y="1771650"/>
+            <a:ext cx="2190750" cy="190500"/>
+          </a:xfrm>
+          <a:prstGeom xmlns:a="http://schemas.openxmlformats.org/drawingml/2006/main" prst="rect">
+            <a:avLst/>
+          </a:prstGeom>
+          <a:noFill xmlns:a="http://schemas.openxmlformats.org/drawingml/2006/main"/>
+          <a:ln xmlns:a="http://schemas.openxmlformats.org/drawingml/2006/main" w="0">
+            <a:noFill/>
+            <a:prstDash val="solid"/>
+          </a:ln>
+        </p:spPr>
+        <p:txBody>
+          <a:bodyPr xmlns:a="http://schemas.openxmlformats.org/drawingml/2006/main"/>
+          <a:lstStyle xmlns:a="http://schemas.openxmlformats.org/drawingml/2006/main"/>
+          <a:p xmlns:a="http://schemas.openxmlformats.org/drawingml/2006/main">
+            <a:pPr algn="l">
+              <a:defRPr sz="1125" b="1">
+                <a:solidFill>
+                  <a:srgbClr val="005293"/>
+                </a:solidFill>
+              </a:defRPr>
+            </a:pPr>
+            <a:r>
+              <a:rPr sz="1125" b="1">
+                <a:solidFill>
+                  <a:srgbClr val="005293"/>
+                </a:solidFill>
+              </a:rPr>
+              <a:t>3. Trained models</a:t>
+            </a:r>
+          </a:p>
+        </p:txBody>
+      </p:sp>
+      <p:sp>
+        <p:nvSpPr>
+          <p:cNvPr id="15" name="">
+            <a:extLst xmlns:a="http://schemas.openxmlformats.org/drawingml/2006/main">
+              <a:ext uri="{FF2B5EF4-FFF2-40B4-BE49-F238E27FC236}">
+                <a16:creationId xmlns:a16="http://schemas.microsoft.com/office/drawing/2014/main" id="{E7EEBE91-7615-4423-8838-3FF0E394C5EB}"/>
+              </a:ext>
+            </a:extLst>
+          </p:cNvPr>
+          <p:cNvSpPr>
+            <a:spLocks xmlns:a="http://schemas.openxmlformats.org/drawingml/2006/main" noGrp="1"/>
+          </p:cNvSpPr>
+          <p:nvPr/>
+        </p:nvSpPr>
+        <p:spPr>
+          <a:xfrm xmlns:a="http://schemas.openxmlformats.org/drawingml/2006/main">
+            <a:off x="6334125" y="2009775"/>
+            <a:ext cx="2190750" cy="381000"/>
+          </a:xfrm>
+          <a:prstGeom xmlns:a="http://schemas.openxmlformats.org/drawingml/2006/main" prst="rect">
+            <a:avLst/>
+          </a:prstGeom>
+          <a:noFill xmlns:a="http://schemas.openxmlformats.org/drawingml/2006/main"/>
+          <a:ln xmlns:a="http://schemas.openxmlformats.org/drawingml/2006/main" w="0">
+            <a:noFill/>
+            <a:prstDash val="solid"/>
+          </a:ln>
+        </p:spPr>
+        <p:txBody>
+          <a:bodyPr xmlns:a="http://schemas.openxmlformats.org/drawingml/2006/main"/>
+          <a:lstStyle xmlns:a="http://schemas.openxmlformats.org/drawingml/2006/main"/>
+          <a:p xmlns:a="http://schemas.openxmlformats.org/drawingml/2006/main">
+            <a:pPr algn="l">
+              <a:defRPr sz="923" b="0">
+                <a:solidFill>
+                  <a:srgbClr val="000000"/>
+                </a:solidFill>
+              </a:defRPr>
+            </a:pPr>
+            <a:r>
+              <a:rPr sz="923" b="0">
+                <a:solidFill>
+                  <a:srgbClr val="000000"/>
+                </a:solidFill>
+              </a:rPr>
+              <a:t>deal_classifier.ubj, cql_best.pt,</a:t>
+            </a:r>
+          </a:p>
+          <a:p xmlns:a="http://schemas.openxmlformats.org/drawingml/2006/main">
+            <a:pPr algn="l">
+              <a:defRPr sz="923" b="0">
+                <a:solidFill>
+                  <a:srgbClr val="000000"/>
+                </a:solidFill>
+              </a:defRPr>
+            </a:pPr>
+            <a:r>
+              <a:rPr sz="923" b="0">
+                <a:solidFill>
+                  <a:srgbClr val="000000"/>
+                </a:solidFill>
+              </a:rPr>
+              <a:t>cql_scaler.pkl, ppo_best_faithful.pt</a:t>
+            </a:r>
+          </a:p>
+        </p:txBody>
+      </p:sp>
+      <p:sp>
+        <p:nvSpPr>
+          <p:cNvPr id="16" name="">
+            <a:extLst xmlns:a="http://schemas.openxmlformats.org/drawingml/2006/main">
+              <a:ext uri="{FF2B5EF4-FFF2-40B4-BE49-F238E27FC236}">
+                <a16:creationId xmlns:a16="http://schemas.microsoft.com/office/drawing/2014/main" id="{95EE70FD-D108-4183-9B99-F4E5D0B85DAF}"/>
+              </a:ext>
+            </a:extLst>
+          </p:cNvPr>
+          <p:cNvSpPr>
+            <a:spLocks xmlns:a="http://schemas.openxmlformats.org/drawingml/2006/main" noGrp="1"/>
+          </p:cNvSpPr>
+          <p:nvPr/>
+        </p:nvSpPr>
+        <p:spPr>
+          <a:xfrm xmlns:a="http://schemas.openxmlformats.org/drawingml/2006/main">
+            <a:off x="514350" y="2790825"/>
+            <a:ext cx="3876675" cy="790575"/>
+          </a:xfrm>
+          <a:prstGeom xmlns:a="http://schemas.openxmlformats.org/drawingml/2006/main" prst="rect">
+            <a:avLst/>
+          </a:prstGeom>
+          <a:solidFill xmlns:a="http://schemas.openxmlformats.org/drawingml/2006/main">
+            <a:srgbClr val="FFFFFF"/>
+          </a:solidFill>
+          <a:ln xmlns:a="http://schemas.openxmlformats.org/drawingml/2006/main" w="9525">
+            <a:solidFill>
+              <a:srgbClr val="D7E6F2"/>
+            </a:solidFill>
+            <a:prstDash val="solid"/>
+          </a:ln>
+        </p:spPr>
+      </p:sp>
+      <p:sp>
+        <p:nvSpPr>
+          <p:cNvPr id="17" name="">
+            <a:extLst xmlns:a="http://schemas.openxmlformats.org/drawingml/2006/main">
+              <a:ext uri="{FF2B5EF4-FFF2-40B4-BE49-F238E27FC236}">
+                <a16:creationId xmlns:a16="http://schemas.microsoft.com/office/drawing/2014/main" id="{78204229-7734-49C0-A3D0-D0777AACF37F}"/>
+              </a:ext>
+            </a:extLst>
+          </p:cNvPr>
+          <p:cNvSpPr>
+            <a:spLocks xmlns:a="http://schemas.openxmlformats.org/drawingml/2006/main" noGrp="1"/>
+          </p:cNvSpPr>
+          <p:nvPr/>
+        </p:nvSpPr>
+        <p:spPr>
+          <a:xfrm xmlns:a="http://schemas.openxmlformats.org/drawingml/2006/main">
+            <a:off x="514350" y="2790825"/>
+            <a:ext cx="66675" cy="790575"/>
+          </a:xfrm>
+          <a:prstGeom xmlns:a="http://schemas.openxmlformats.org/drawingml/2006/main" prst="rect">
+            <a:avLst/>
+          </a:prstGeom>
+          <a:solidFill xmlns:a="http://schemas.openxmlformats.org/drawingml/2006/main">
+            <a:srgbClr val="005293"/>
+          </a:solidFill>
+          <a:ln xmlns:a="http://schemas.openxmlformats.org/drawingml/2006/main" w="0">
+            <a:noFill/>
+            <a:prstDash val="solid"/>
+          </a:ln>
+        </p:spPr>
+      </p:sp>
+      <p:sp>
+        <p:nvSpPr>
+          <p:cNvPr id="18" name="">
+            <a:extLst xmlns:a="http://schemas.openxmlformats.org/drawingml/2006/main">
+              <a:ext uri="{FF2B5EF4-FFF2-40B4-BE49-F238E27FC236}">
+                <a16:creationId xmlns:a16="http://schemas.microsoft.com/office/drawing/2014/main" id="{1FA5A17F-EF36-42B0-B324-0AF725D10B78}"/>
+              </a:ext>
+            </a:extLst>
+          </p:cNvPr>
+          <p:cNvSpPr>
+            <a:spLocks xmlns:a="http://schemas.openxmlformats.org/drawingml/2006/main" noGrp="1"/>
+          </p:cNvSpPr>
+          <p:nvPr/>
+        </p:nvSpPr>
+        <p:spPr>
+          <a:xfrm xmlns:a="http://schemas.openxmlformats.org/drawingml/2006/main">
+            <a:off x="676275" y="2886075"/>
+            <a:ext cx="3609975" cy="190500"/>
+          </a:xfrm>
+          <a:prstGeom xmlns:a="http://schemas.openxmlformats.org/drawingml/2006/main" prst="rect">
+            <a:avLst/>
+          </a:prstGeom>
+          <a:noFill xmlns:a="http://schemas.openxmlformats.org/drawingml/2006/main"/>
+          <a:ln xmlns:a="http://schemas.openxmlformats.org/drawingml/2006/main" w="0">
+            <a:noFill/>
+            <a:prstDash val="solid"/>
+          </a:ln>
+        </p:spPr>
+        <p:txBody>
+          <a:bodyPr xmlns:a="http://schemas.openxmlformats.org/drawingml/2006/main"/>
+          <a:lstStyle xmlns:a="http://schemas.openxmlformats.org/drawingml/2006/main"/>
+          <a:p xmlns:a="http://schemas.openxmlformats.org/drawingml/2006/main">
+            <a:pPr algn="l">
+              <a:defRPr sz="1125" b="1">
+                <a:solidFill>
+                  <a:srgbClr val="005293"/>
+                </a:solidFill>
+              </a:defRPr>
+            </a:pPr>
+            <a:r>
+              <a:rPr sz="1125" b="1">
+                <a:solidFill>
+                  <a:srgbClr val="005293"/>
+                </a:solidFill>
+              </a:rPr>
+              <a:t>4. Evaluation outputs</a:t>
+            </a:r>
+          </a:p>
+        </p:txBody>
+      </p:sp>
+      <p:sp>
+        <p:nvSpPr>
+          <p:cNvPr id="19" name="">
+            <a:extLst xmlns:a="http://schemas.openxmlformats.org/drawingml/2006/main">
+              <a:ext uri="{FF2B5EF4-FFF2-40B4-BE49-F238E27FC236}">
+                <a16:creationId xmlns:a16="http://schemas.microsoft.com/office/drawing/2014/main" id="{71254B44-B0AB-4E33-83A1-E9EC5950D232}"/>
+              </a:ext>
+            </a:extLst>
+          </p:cNvPr>
+          <p:cNvSpPr>
+            <a:spLocks xmlns:a="http://schemas.openxmlformats.org/drawingml/2006/main" noGrp="1"/>
+          </p:cNvSpPr>
+          <p:nvPr/>
+        </p:nvSpPr>
+        <p:spPr>
+          <a:xfrm xmlns:a="http://schemas.openxmlformats.org/drawingml/2006/main">
+            <a:off x="676275" y="3124200"/>
+            <a:ext cx="3609975" cy="381000"/>
+          </a:xfrm>
+          <a:prstGeom xmlns:a="http://schemas.openxmlformats.org/drawingml/2006/main" prst="rect">
+            <a:avLst/>
+          </a:prstGeom>
+          <a:noFill xmlns:a="http://schemas.openxmlformats.org/drawingml/2006/main"/>
+          <a:ln xmlns:a="http://schemas.openxmlformats.org/drawingml/2006/main" w="0">
+            <a:noFill/>
+            <a:prstDash val="solid"/>
+          </a:ln>
+        </p:spPr>
+        <p:txBody>
+          <a:bodyPr xmlns:a="http://schemas.openxmlformats.org/drawingml/2006/main"/>
+          <a:lstStyle xmlns:a="http://schemas.openxmlformats.org/drawingml/2006/main"/>
+          <a:p xmlns:a="http://schemas.openxmlformats.org/drawingml/2006/main">
+            <a:pPr algn="l">
+              <a:defRPr sz="923" b="0">
+                <a:solidFill>
+                  <a:srgbClr val="000000"/>
+                </a:solidFill>
+              </a:defRPr>
+            </a:pPr>
+            <a:r>
+              <a:rPr sz="923" b="0">
+                <a:solidFill>
+                  <a:srgbClr val="000000"/>
+                </a:solidFill>
+              </a:rPr>
+              <a:t>policy_comparison.csv, ope_policy_eval.csv,</a:t>
+            </a:r>
+          </a:p>
+          <a:p xmlns:a="http://schemas.openxmlformats.org/drawingml/2006/main">
+            <a:pPr algn="l">
+              <a:defRPr sz="923" b="0">
+                <a:solidFill>
+                  <a:srgbClr val="000000"/>
+                </a:solidFill>
+              </a:defRPr>
+            </a:pPr>
+            <a:r>
+              <a:rPr sz="923" b="0">
+                <a:solidFill>
+                  <a:srgbClr val="000000"/>
+                </a:solidFill>
+              </a:rPr>
+              <a:t>ope_weight_diagnostics.csv, ope_summary.json</a:t>
+            </a:r>
+          </a:p>
+        </p:txBody>
+      </p:sp>
+      <p:sp>
+        <p:nvSpPr>
+          <p:cNvPr id="20" name="">
+            <a:extLst xmlns:a="http://schemas.openxmlformats.org/drawingml/2006/main">
+              <a:ext uri="{FF2B5EF4-FFF2-40B4-BE49-F238E27FC236}">
+                <a16:creationId xmlns:a16="http://schemas.microsoft.com/office/drawing/2014/main" id="{AF0B470A-BACA-42E6-BA82-9ACA56A61FDD}"/>
+              </a:ext>
+            </a:extLst>
+          </p:cNvPr>
+          <p:cNvSpPr>
+            <a:spLocks xmlns:a="http://schemas.openxmlformats.org/drawingml/2006/main" noGrp="1"/>
+          </p:cNvSpPr>
+          <p:nvPr/>
+        </p:nvSpPr>
+        <p:spPr>
+          <a:xfrm xmlns:a="http://schemas.openxmlformats.org/drawingml/2006/main">
+            <a:off x="4752975" y="2790825"/>
+            <a:ext cx="3876675" cy="790575"/>
+          </a:xfrm>
+          <a:prstGeom xmlns:a="http://schemas.openxmlformats.org/drawingml/2006/main" prst="rect">
+            <a:avLst/>
+          </a:prstGeom>
+          <a:solidFill xmlns:a="http://schemas.openxmlformats.org/drawingml/2006/main">
+            <a:srgbClr val="FFFFFF"/>
+          </a:solidFill>
+          <a:ln xmlns:a="http://schemas.openxmlformats.org/drawingml/2006/main" w="9525">
+            <a:solidFill>
+              <a:srgbClr val="D7E6F2"/>
+            </a:solidFill>
+            <a:prstDash val="solid"/>
+          </a:ln>
+        </p:spPr>
+      </p:sp>
+      <p:sp>
+        <p:nvSpPr>
+          <p:cNvPr id="21" name="">
+            <a:extLst xmlns:a="http://schemas.openxmlformats.org/drawingml/2006/main">
+              <a:ext uri="{FF2B5EF4-FFF2-40B4-BE49-F238E27FC236}">
+                <a16:creationId xmlns:a16="http://schemas.microsoft.com/office/drawing/2014/main" id="{FD07B89D-C885-4028-B11F-E6F05A918C96}"/>
+              </a:ext>
+            </a:extLst>
+          </p:cNvPr>
+          <p:cNvSpPr>
+            <a:spLocks xmlns:a="http://schemas.openxmlformats.org/drawingml/2006/main" noGrp="1"/>
+          </p:cNvSpPr>
+          <p:nvPr/>
+        </p:nvSpPr>
+        <p:spPr>
+          <a:xfrm xmlns:a="http://schemas.openxmlformats.org/drawingml/2006/main">
+            <a:off x="4752975" y="2790825"/>
+            <a:ext cx="66675" cy="790575"/>
+          </a:xfrm>
+          <a:prstGeom xmlns:a="http://schemas.openxmlformats.org/drawingml/2006/main" prst="rect">
+            <a:avLst/>
+          </a:prstGeom>
+          <a:solidFill xmlns:a="http://schemas.openxmlformats.org/drawingml/2006/main">
+            <a:srgbClr val="64A0C8"/>
+          </a:solidFill>
+          <a:ln xmlns:a="http://schemas.openxmlformats.org/drawingml/2006/main" w="0">
+            <a:noFill/>
+            <a:prstDash val="solid"/>
+          </a:ln>
+        </p:spPr>
+      </p:sp>
+      <p:sp>
+        <p:nvSpPr>
+          <p:cNvPr id="22" name="">
+            <a:extLst xmlns:a="http://schemas.openxmlformats.org/drawingml/2006/main">
+              <a:ext uri="{FF2B5EF4-FFF2-40B4-BE49-F238E27FC236}">
+                <a16:creationId xmlns:a16="http://schemas.microsoft.com/office/drawing/2014/main" id="{956AACE2-234F-4772-B555-9AF0DEC24015}"/>
+              </a:ext>
+            </a:extLst>
+          </p:cNvPr>
+          <p:cNvSpPr>
+            <a:spLocks xmlns:a="http://schemas.openxmlformats.org/drawingml/2006/main" noGrp="1"/>
+          </p:cNvSpPr>
+          <p:nvPr/>
+        </p:nvSpPr>
+        <p:spPr>
+          <a:xfrm xmlns:a="http://schemas.openxmlformats.org/drawingml/2006/main">
+            <a:off x="4914900" y="2886075"/>
+            <a:ext cx="3609975" cy="190500"/>
+          </a:xfrm>
+          <a:prstGeom xmlns:a="http://schemas.openxmlformats.org/drawingml/2006/main" prst="rect">
+            <a:avLst/>
+          </a:prstGeom>
+          <a:noFill xmlns:a="http://schemas.openxmlformats.org/drawingml/2006/main"/>
+          <a:ln xmlns:a="http://schemas.openxmlformats.org/drawingml/2006/main" w="0">
+            <a:noFill/>
+            <a:prstDash val="solid"/>
+          </a:ln>
+        </p:spPr>
+        <p:txBody>
+          <a:bodyPr xmlns:a="http://schemas.openxmlformats.org/drawingml/2006/main"/>
+          <a:lstStyle xmlns:a="http://schemas.openxmlformats.org/drawingml/2006/main"/>
+          <a:p xmlns:a="http://schemas.openxmlformats.org/drawingml/2006/main">
+            <a:pPr algn="l">
+              <a:defRPr sz="1125" b="1">
+                <a:solidFill>
+                  <a:srgbClr val="005293"/>
+                </a:solidFill>
+              </a:defRPr>
+            </a:pPr>
+            <a:r>
+              <a:rPr sz="1125" b="1">
+                <a:solidFill>
+                  <a:srgbClr val="005293"/>
+                </a:solidFill>
+              </a:rPr>
+              <a:t>5. Recommendation outputs</a:t>
+            </a:r>
+          </a:p>
+        </p:txBody>
+      </p:sp>
+      <p:sp>
+        <p:nvSpPr>
+          <p:cNvPr id="23" name="">
+            <a:extLst xmlns:a="http://schemas.openxmlformats.org/drawingml/2006/main">
+              <a:ext uri="{FF2B5EF4-FFF2-40B4-BE49-F238E27FC236}">
+                <a16:creationId xmlns:a16="http://schemas.microsoft.com/office/drawing/2014/main" id="{E600B103-4AA2-4A4C-8B26-C9BD014C830E}"/>
+              </a:ext>
+            </a:extLst>
+          </p:cNvPr>
+          <p:cNvSpPr>
+            <a:spLocks xmlns:a="http://schemas.openxmlformats.org/drawingml/2006/main" noGrp="1"/>
+          </p:cNvSpPr>
+          <p:nvPr/>
+        </p:nvSpPr>
+        <p:spPr>
+          <a:xfrm xmlns:a="http://schemas.openxmlformats.org/drawingml/2006/main">
+            <a:off x="4914900" y="3124200"/>
+            <a:ext cx="3609975" cy="381000"/>
+          </a:xfrm>
+          <a:prstGeom xmlns:a="http://schemas.openxmlformats.org/drawingml/2006/main" prst="rect">
+            <a:avLst/>
+          </a:prstGeom>
+          <a:noFill xmlns:a="http://schemas.openxmlformats.org/drawingml/2006/main"/>
+          <a:ln xmlns:a="http://schemas.openxmlformats.org/drawingml/2006/main" w="0">
+            <a:noFill/>
+            <a:prstDash val="solid"/>
+          </a:ln>
+        </p:spPr>
+        <p:txBody>
+          <a:bodyPr xmlns:a="http://schemas.openxmlformats.org/drawingml/2006/main"/>
+          <a:lstStyle xmlns:a="http://schemas.openxmlformats.org/drawingml/2006/main"/>
+          <a:p xmlns:a="http://schemas.openxmlformats.org/drawingml/2006/main">
+            <a:pPr algn="l">
+              <a:defRPr sz="923" b="0">
+                <a:solidFill>
+                  <a:srgbClr val="000000"/>
+                </a:solidFill>
+              </a:defRPr>
+            </a:pPr>
+            <a:r>
+              <a:rPr sz="923" b="0">
+                <a:solidFill>
+                  <a:srgbClr val="000000"/>
+                </a:solidFill>
+              </a:rPr>
+              <a:t>offer_recommendations.csv</a:t>
+            </a:r>
+          </a:p>
+          <a:p xmlns:a="http://schemas.openxmlformats.org/drawingml/2006/main">
+            <a:pPr algn="l">
+              <a:defRPr sz="923" b="0">
+                <a:solidFill>
+                  <a:srgbClr val="000000"/>
+                </a:solidFill>
+              </a:defRPr>
+            </a:pPr>
+            <a:r>
+              <a:rPr sz="923" b="0">
+                <a:solidFill>
+                  <a:srgbClr val="000000"/>
+                </a:solidFill>
+              </a:rPr>
+              <a:t>single-listing menus from recommend_one.py</a:t>
+            </a:r>
+          </a:p>
+        </p:txBody>
+      </p:sp>
+      <p:sp>
+        <p:nvSpPr>
+          <p:cNvPr id="24" name="">
+            <a:extLst xmlns:a="http://schemas.openxmlformats.org/drawingml/2006/main">
+              <a:ext uri="{FF2B5EF4-FFF2-40B4-BE49-F238E27FC236}">
+                <a16:creationId xmlns:a16="http://schemas.microsoft.com/office/drawing/2014/main" id="{CB6B5882-6416-4348-A869-AA11F8FFBC4F}"/>
+              </a:ext>
+            </a:extLst>
+          </p:cNvPr>
+          <p:cNvSpPr>
+            <a:spLocks xmlns:a="http://schemas.openxmlformats.org/drawingml/2006/main" noGrp="1"/>
+          </p:cNvSpPr>
+          <p:nvPr/>
+        </p:nvSpPr>
+        <p:spPr>
+          <a:xfrm xmlns:a="http://schemas.openxmlformats.org/drawingml/2006/main">
+            <a:off x="514350" y="4000500"/>
+            <a:ext cx="8115300" cy="590550"/>
+          </a:xfrm>
+          <a:prstGeom xmlns:a="http://schemas.openxmlformats.org/drawingml/2006/main" prst="rect">
+            <a:avLst/>
+          </a:prstGeom>
+          <a:solidFill xmlns:a="http://schemas.openxmlformats.org/drawingml/2006/main">
+            <a:srgbClr val="EAF3FA"/>
+          </a:solidFill>
+          <a:ln xmlns:a="http://schemas.openxmlformats.org/drawingml/2006/main" w="9525">
+            <a:solidFill>
+              <a:srgbClr val="C7DDEC"/>
+            </a:solidFill>
+            <a:prstDash val="solid"/>
+          </a:ln>
+        </p:spPr>
+      </p:sp>
+      <p:sp>
+        <p:nvSpPr>
+          <p:cNvPr id="25" name="">
+            <a:extLst xmlns:a="http://schemas.openxmlformats.org/drawingml/2006/main">
+              <a:ext uri="{FF2B5EF4-FFF2-40B4-BE49-F238E27FC236}">
+                <a16:creationId xmlns:a16="http://schemas.microsoft.com/office/drawing/2014/main" id="{D14C4C11-9F92-4663-B715-5767CDFE6282}"/>
+              </a:ext>
+            </a:extLst>
+          </p:cNvPr>
+          <p:cNvSpPr>
+            <a:spLocks xmlns:a="http://schemas.openxmlformats.org/drawingml/2006/main" noGrp="1"/>
+          </p:cNvSpPr>
+          <p:nvPr/>
+        </p:nvSpPr>
+        <p:spPr>
+          <a:xfrm xmlns:a="http://schemas.openxmlformats.org/drawingml/2006/main">
+            <a:off x="742950" y="4181475"/>
+            <a:ext cx="7658100" cy="247650"/>
+          </a:xfrm>
+          <a:prstGeom xmlns:a="http://schemas.openxmlformats.org/drawingml/2006/main" prst="rect">
+            <a:avLst/>
+          </a:prstGeom>
+          <a:noFill xmlns:a="http://schemas.openxmlformats.org/drawingml/2006/main"/>
+          <a:ln xmlns:a="http://schemas.openxmlformats.org/drawingml/2006/main" w="0">
+            <a:noFill/>
+            <a:prstDash val="solid"/>
+          </a:ln>
+        </p:spPr>
+        <p:txBody>
+          <a:bodyPr xmlns:a="http://schemas.openxmlformats.org/drawingml/2006/main"/>
+          <a:lstStyle xmlns:a="http://schemas.openxmlformats.org/drawingml/2006/main"/>
+          <a:p xmlns:a="http://schemas.openxmlformats.org/drawingml/2006/main">
+            <a:pPr algn="ctr">
+              <a:defRPr sz="1140" b="1">
+                <a:solidFill>
+                  <a:srgbClr val="005293"/>
+                </a:solidFill>
+              </a:defRPr>
+            </a:pPr>
+            <a:r>
+              <a:rPr sz="1140" b="1">
+                <a:solidFill>
+                  <a:srgbClr val="005293"/>
+                </a:solidFill>
+              </a:rPr>
+              <a:t>Tracked final deliverables: technical_report.md/.pdf, results dashboard figure, and this presentation deck.</a:t>
+            </a:r>
+          </a:p>
+        </p:txBody>
+      </p:sp>
+      <p:sp>
+        <p:nvSpPr>
+          <p:cNvPr id="26" name="">
+            <a:extLst xmlns:a="http://schemas.openxmlformats.org/drawingml/2006/main">
+              <a:ext uri="{FF2B5EF4-FFF2-40B4-BE49-F238E27FC236}">
+                <a16:creationId xmlns:a16="http://schemas.microsoft.com/office/drawing/2014/main" id="{D4ED4CC9-DC87-4666-8FD5-2061BB0338C3}"/>
+              </a:ext>
+            </a:extLst>
+          </p:cNvPr>
+          <p:cNvSpPr>
+            <a:spLocks xmlns:a="http://schemas.openxmlformats.org/drawingml/2006/main" noGrp="1"/>
+          </p:cNvSpPr>
+          <p:nvPr/>
+        </p:nvSpPr>
+        <p:spPr>
+          <a:xfrm xmlns:a="http://schemas.openxmlformats.org/drawingml/2006/main">
+            <a:off x="304800" y="4857750"/>
+            <a:ext cx="6191250" cy="228600"/>
+          </a:xfrm>
+          <a:prstGeom xmlns:a="http://schemas.openxmlformats.org/drawingml/2006/main" prst="rect">
+            <a:avLst/>
+          </a:prstGeom>
+          <a:noFill xmlns:a="http://schemas.openxmlformats.org/drawingml/2006/main"/>
+          <a:ln xmlns:a="http://schemas.openxmlformats.org/drawingml/2006/main" w="0">
+            <a:noFill/>
+            <a:prstDash val="solid"/>
+          </a:ln>
+        </p:spPr>
+        <p:txBody>
+          <a:bodyPr xmlns:a="http://schemas.openxmlformats.org/drawingml/2006/main"/>
+          <a:lstStyle xmlns:a="http://schemas.openxmlformats.org/drawingml/2006/main"/>
+          <a:p xmlns:a="http://schemas.openxmlformats.org/drawingml/2006/main">
+            <a:pPr algn="l">
+              <a:defRPr sz="1102" b="0">
+                <a:solidFill>
+                  <a:srgbClr val="000000"/>
+                </a:solidFill>
+              </a:defRPr>
+            </a:pPr>
+            <a:r>
+              <a:rPr sz="1102" b="0">
+                <a:solidFill>
+                  <a:srgbClr val="000000"/>
+                </a:solidFill>
+              </a:rPr>
+              <a:t>eBay Best Offer anchoring RL | Advanced Seminar (WIHN0043SE)</a:t>
+            </a:r>
+          </a:p>
+        </p:txBody>
+      </p:sp>
+      <p:sp>
+        <p:nvSpPr>
+          <p:cNvPr id="27" name="">
+            <a:extLst xmlns:a="http://schemas.openxmlformats.org/drawingml/2006/main">
+              <a:ext uri="{FF2B5EF4-FFF2-40B4-BE49-F238E27FC236}">
+                <a16:creationId xmlns:a16="http://schemas.microsoft.com/office/drawing/2014/main" id="{6C8C6AD7-06A6-4963-AD76-9CED3F4C5F84}"/>
+              </a:ext>
+            </a:extLst>
+          </p:cNvPr>
+          <p:cNvSpPr>
+            <a:spLocks xmlns:a="http://schemas.openxmlformats.org/drawingml/2006/main" noGrp="1"/>
+          </p:cNvSpPr>
+          <p:nvPr/>
+        </p:nvSpPr>
+        <p:spPr>
+          <a:xfrm xmlns:a="http://schemas.openxmlformats.org/drawingml/2006/main">
+            <a:off x="7810500" y="4857750"/>
+            <a:ext cx="1009650" cy="228600"/>
+          </a:xfrm>
+          <a:prstGeom xmlns:a="http://schemas.openxmlformats.org/drawingml/2006/main" prst="rect">
+            <a:avLst/>
+          </a:prstGeom>
+          <a:noFill xmlns:a="http://schemas.openxmlformats.org/drawingml/2006/main"/>
+          <a:ln xmlns:a="http://schemas.openxmlformats.org/drawingml/2006/main" w="0">
+            <a:noFill/>
+            <a:prstDash val="solid"/>
+          </a:ln>
+        </p:spPr>
+        <p:txBody>
+          <a:bodyPr xmlns:a="http://schemas.openxmlformats.org/drawingml/2006/main"/>
+          <a:lstStyle xmlns:a="http://schemas.openxmlformats.org/drawingml/2006/main"/>
+          <a:p xmlns:a="http://schemas.openxmlformats.org/drawingml/2006/main">
+            <a:pPr algn="r">
+              <a:defRPr sz="1102" b="0">
+                <a:solidFill>
+                  <a:srgbClr val="000000"/>
+                </a:solidFill>
+              </a:defRPr>
+            </a:pPr>
+            <a:r>
+              <a:rPr sz="1102" b="0">
+                <a:solidFill>
+                  <a:srgbClr val="000000"/>
+                </a:solidFill>
+              </a:rPr>
+              <a:t>15</a:t>
+            </a:r>
+          </a:p>
+        </p:txBody>
+      </p:sp>
+    </p:spTree>
+    <p:extLst>
+      <p:ext uri="{BB962C8B-B14F-4D97-AF65-F5344CB8AC3E}">
+        <p14:creationId xmlns:p14="http://schemas.microsoft.com/office/powerpoint/2010/main" val="1637574051"/>
       </p:ext>
     </p:extLst>
   </p:cSld>
@@ -9356,7 +10666,7 @@
           <p:nvPr/>
         </p:nvPicPr>
         <p:blipFill>
-          <a:blip xmlns:r="http://schemas.openxmlformats.org/officeDocument/2006/relationships" xmlns:a="http://schemas.openxmlformats.org/drawingml/2006/main" r:embed="R195e1fe9cd414522"/>
+          <a:blip xmlns:r="http://schemas.openxmlformats.org/officeDocument/2006/relationships" xmlns:a="http://schemas.openxmlformats.org/drawingml/2006/main" r:embed="Reb9b0537ef0841ec"/>
           <a:stretch xmlns:a="http://schemas.openxmlformats.org/drawingml/2006/main">
             <a:fillRect l="0" t="0" r="0" b="0"/>
           </a:stretch>
@@ -9652,7 +10962,7 @@
           <p:nvPr/>
         </p:nvPicPr>
         <p:blipFill>
-          <a:blip xmlns:r="http://schemas.openxmlformats.org/officeDocument/2006/relationships" xmlns:a="http://schemas.openxmlformats.org/drawingml/2006/main" r:embed="R8f8dae1148294c80"/>
+          <a:blip xmlns:r="http://schemas.openxmlformats.org/officeDocument/2006/relationships" xmlns:a="http://schemas.openxmlformats.org/drawingml/2006/main" r:embed="R8334ccdc9af64609"/>
           <a:stretch xmlns:a="http://schemas.openxmlformats.org/drawingml/2006/main">
             <a:fillRect l="0" t="0" r="0" b="0"/>
           </a:stretch>
@@ -9974,7 +11284,7 @@
         </p:xfrm>
         <a:graphic xmlns:a="http://schemas.openxmlformats.org/drawingml/2006/main">
           <a:graphicData uri="http://schemas.openxmlformats.org/drawingml/2006/chart">
-            <c:chart xmlns:r="http://schemas.openxmlformats.org/officeDocument/2006/relationships" xmlns:c="http://schemas.openxmlformats.org/drawingml/2006/chart" r:id="R6ee85f79c7134076"/>
+            <c:chart xmlns:r="http://schemas.openxmlformats.org/officeDocument/2006/relationships" xmlns:c="http://schemas.openxmlformats.org/drawingml/2006/chart" r:id="Re61742e8892b470e"/>
           </a:graphicData>
         </a:graphic>
       </p:graphicFrame>
@@ -10059,7 +11369,7 @@
           <p:nvPr/>
         </p:nvPicPr>
         <p:blipFill>
-          <a:blip xmlns:r="http://schemas.openxmlformats.org/officeDocument/2006/relationships" xmlns:a="http://schemas.openxmlformats.org/drawingml/2006/main" r:embed="R0a32c4e4c1ee42a0"/>
+          <a:blip xmlns:r="http://schemas.openxmlformats.org/officeDocument/2006/relationships" xmlns:a="http://schemas.openxmlformats.org/drawingml/2006/main" r:embed="R0da98654db0f421d"/>
           <a:stretch xmlns:a="http://schemas.openxmlformats.org/drawingml/2006/main">
             <a:fillRect l="0" t="0" r="0" b="0"/>
           </a:stretch>
@@ -10531,7 +11841,7 @@
           <p:nvPr/>
         </p:nvPicPr>
         <p:blipFill>
-          <a:blip xmlns:r="http://schemas.openxmlformats.org/officeDocument/2006/relationships" xmlns:a="http://schemas.openxmlformats.org/drawingml/2006/main" r:embed="Rf9e3254f719643b4"/>
+          <a:blip xmlns:r="http://schemas.openxmlformats.org/officeDocument/2006/relationships" xmlns:a="http://schemas.openxmlformats.org/drawingml/2006/main" r:embed="Rd1a164f5355440db"/>
           <a:stretch xmlns:a="http://schemas.openxmlformats.org/drawingml/2006/main">
             <a:fillRect l="0" t="0" r="0" b="0"/>
           </a:stretch>
@@ -10827,7 +12137,7 @@
           <p:nvPr/>
         </p:nvPicPr>
         <p:blipFill>
-          <a:blip xmlns:r="http://schemas.openxmlformats.org/officeDocument/2006/relationships" xmlns:a="http://schemas.openxmlformats.org/drawingml/2006/main" r:embed="R3564c0909b3c45b0"/>
+          <a:blip xmlns:r="http://schemas.openxmlformats.org/officeDocument/2006/relationships" xmlns:a="http://schemas.openxmlformats.org/drawingml/2006/main" r:embed="R3f98a67ee7b8435a"/>
           <a:stretch xmlns:a="http://schemas.openxmlformats.org/drawingml/2006/main">
             <a:fillRect l="0" t="0" r="0" b="0"/>
           </a:stretch>
@@ -11773,7 +13083,7 @@
           <p:nvPr/>
         </p:nvPicPr>
         <p:blipFill>
-          <a:blip xmlns:r="http://schemas.openxmlformats.org/officeDocument/2006/relationships" xmlns:a="http://schemas.openxmlformats.org/drawingml/2006/main" r:embed="R19122a4a80ce4385"/>
+          <a:blip xmlns:r="http://schemas.openxmlformats.org/officeDocument/2006/relationships" xmlns:a="http://schemas.openxmlformats.org/drawingml/2006/main" r:embed="R400ab7e3633544b7"/>
           <a:stretch xmlns:a="http://schemas.openxmlformats.org/drawingml/2006/main">
             <a:fillRect l="0" t="0" r="0" b="0"/>
           </a:stretch>
@@ -12470,7 +13780,7 @@
           <p:nvPr/>
         </p:nvPicPr>
         <p:blipFill>
-          <a:blip xmlns:r="http://schemas.openxmlformats.org/officeDocument/2006/relationships" xmlns:a="http://schemas.openxmlformats.org/drawingml/2006/main" r:embed="R98ba8bd3ec654168"/>
+          <a:blip xmlns:r="http://schemas.openxmlformats.org/officeDocument/2006/relationships" xmlns:a="http://schemas.openxmlformats.org/drawingml/2006/main" r:embed="R4162297806f14186"/>
           <a:stretch xmlns:a="http://schemas.openxmlformats.org/drawingml/2006/main">
             <a:fillRect l="0" t="0" r="0" b="0"/>
           </a:stretch>
@@ -13586,7 +14896,7 @@
           <p:nvPr/>
         </p:nvPicPr>
         <p:blipFill>
-          <a:blip xmlns:r="http://schemas.openxmlformats.org/officeDocument/2006/relationships" xmlns:a="http://schemas.openxmlformats.org/drawingml/2006/main" r:embed="Rb37e16b5eaed4b4a"/>
+          <a:blip xmlns:r="http://schemas.openxmlformats.org/officeDocument/2006/relationships" xmlns:a="http://schemas.openxmlformats.org/drawingml/2006/main" r:embed="R60cb980f17224686"/>
           <a:stretch xmlns:a="http://schemas.openxmlformats.org/drawingml/2006/main">
             <a:fillRect l="0" t="0" r="0" b="0"/>
           </a:stretch>
@@ -13851,7 +15161,7 @@
         </p:xfrm>
         <a:graphic xmlns:a="http://schemas.openxmlformats.org/drawingml/2006/main">
           <a:graphicData uri="http://schemas.openxmlformats.org/drawingml/2006/chart">
-            <c:chart xmlns:r="http://schemas.openxmlformats.org/officeDocument/2006/relationships" xmlns:c="http://schemas.openxmlformats.org/drawingml/2006/chart" r:id="Rcc76a196c35d47cf"/>
+            <c:chart xmlns:r="http://schemas.openxmlformats.org/officeDocument/2006/relationships" xmlns:c="http://schemas.openxmlformats.org/drawingml/2006/chart" r:id="Rf617e4bef4ee412a"/>
           </a:graphicData>
         </a:graphic>
       </p:graphicFrame>

</xml_diff>

<commit_message>
Finalize corrected opening-offer pipeline and report
</commit_message>
<xml_diff>
--- a/report/ebay_anchoring_rl_presentation.pptx
+++ b/report/ebay_anchoring_rl_presentation.pptx
@@ -2,27 +2,26 @@
 <file path=ppt/presentation.xml><?xml version="1.0" encoding="utf-8"?>
 <p:presentation xmlns:p="http://schemas.openxmlformats.org/presentationml/2006/main">
   <p:sldMasterIdLst>
-    <p:sldMasterId xmlns:r="http://schemas.openxmlformats.org/officeDocument/2006/relationships" id="2147483648" r:id="Rb18b11d49b1a4a87"/>
+    <p:sldMasterId xmlns:r="http://schemas.openxmlformats.org/officeDocument/2006/relationships" id="2147483648" r:id="R3419f6d499974777"/>
   </p:sldMasterIdLst>
   <p:notesMasterIdLst>
-    <p:notesMasterId xmlns:r="http://schemas.openxmlformats.org/officeDocument/2006/relationships" r:id="R17906ce6c9864ee5"/>
+    <p:notesMasterId xmlns:r="http://schemas.openxmlformats.org/officeDocument/2006/relationships" r:id="R9d32fefdebaf493a"/>
   </p:notesMasterIdLst>
   <p:sldIdLst>
-    <p:sldId xmlns:r="http://schemas.openxmlformats.org/officeDocument/2006/relationships" id="256" r:id="R06e1c4abb53c4108"/>
-    <p:sldId xmlns:r="http://schemas.openxmlformats.org/officeDocument/2006/relationships" id="257" r:id="R71e60174eb224aee"/>
-    <p:sldId xmlns:r="http://schemas.openxmlformats.org/officeDocument/2006/relationships" id="258" r:id="R9ccebb2805cb420d"/>
-    <p:sldId xmlns:r="http://schemas.openxmlformats.org/officeDocument/2006/relationships" id="259" r:id="R914bc5981272473e"/>
-    <p:sldId xmlns:r="http://schemas.openxmlformats.org/officeDocument/2006/relationships" id="260" r:id="R23ee085260d04396"/>
-    <p:sldId xmlns:r="http://schemas.openxmlformats.org/officeDocument/2006/relationships" id="261" r:id="R437251f166274495"/>
-    <p:sldId xmlns:r="http://schemas.openxmlformats.org/officeDocument/2006/relationships" id="262" r:id="R4f75eb74ff684624"/>
-    <p:sldId xmlns:r="http://schemas.openxmlformats.org/officeDocument/2006/relationships" id="263" r:id="Re4cc04a768f5454c"/>
-    <p:sldId xmlns:r="http://schemas.openxmlformats.org/officeDocument/2006/relationships" id="264" r:id="R39779d0770234719"/>
-    <p:sldId xmlns:r="http://schemas.openxmlformats.org/officeDocument/2006/relationships" id="265" r:id="Rf0851880686d40ec"/>
-    <p:sldId xmlns:r="http://schemas.openxmlformats.org/officeDocument/2006/relationships" id="266" r:id="R46a1eed907394a3e"/>
-    <p:sldId xmlns:r="http://schemas.openxmlformats.org/officeDocument/2006/relationships" id="267" r:id="Re00eddf80dda4df9"/>
-    <p:sldId xmlns:r="http://schemas.openxmlformats.org/officeDocument/2006/relationships" id="268" r:id="R86524e7d278e40cc"/>
-    <p:sldId xmlns:r="http://schemas.openxmlformats.org/officeDocument/2006/relationships" id="269" r:id="R6814c36df9404a80"/>
-    <p:sldId xmlns:r="http://schemas.openxmlformats.org/officeDocument/2006/relationships" id="270" r:id="Ra8a45ae55f9646c8"/>
+    <p:sldId xmlns:r="http://schemas.openxmlformats.org/officeDocument/2006/relationships" id="256" r:id="Re414cd07c6b744b3"/>
+    <p:sldId xmlns:r="http://schemas.openxmlformats.org/officeDocument/2006/relationships" id="257" r:id="Rc0e86462fb0a466e"/>
+    <p:sldId xmlns:r="http://schemas.openxmlformats.org/officeDocument/2006/relationships" id="258" r:id="Rfbc8da35a89642b5"/>
+    <p:sldId xmlns:r="http://schemas.openxmlformats.org/officeDocument/2006/relationships" id="259" r:id="R46dfcf6ff05e4001"/>
+    <p:sldId xmlns:r="http://schemas.openxmlformats.org/officeDocument/2006/relationships" id="260" r:id="R96568e83eed34f8b"/>
+    <p:sldId xmlns:r="http://schemas.openxmlformats.org/officeDocument/2006/relationships" id="261" r:id="R992c2511cc264fc0"/>
+    <p:sldId xmlns:r="http://schemas.openxmlformats.org/officeDocument/2006/relationships" id="262" r:id="R9f23c51ee58d4a87"/>
+    <p:sldId xmlns:r="http://schemas.openxmlformats.org/officeDocument/2006/relationships" id="263" r:id="Re66edfa6de134311"/>
+    <p:sldId xmlns:r="http://schemas.openxmlformats.org/officeDocument/2006/relationships" id="264" r:id="Rbb1aeec6a66d4f55"/>
+    <p:sldId xmlns:r="http://schemas.openxmlformats.org/officeDocument/2006/relationships" id="265" r:id="R37f466412c934eb3"/>
+    <p:sldId xmlns:r="http://schemas.openxmlformats.org/officeDocument/2006/relationships" id="266" r:id="Rc81bb15bde834311"/>
+    <p:sldId xmlns:r="http://schemas.openxmlformats.org/officeDocument/2006/relationships" id="267" r:id="Rc8f9b63ace48418a"/>
+    <p:sldId xmlns:r="http://schemas.openxmlformats.org/officeDocument/2006/relationships" id="268" r:id="Ra5214e9ff7794fe2"/>
+    <p:sldId xmlns:r="http://schemas.openxmlformats.org/officeDocument/2006/relationships" id="269" r:id="R6a7d928bace54772"/>
   </p:sldIdLst>
   <p:sldSz cx="9144000" cy="5143500"/>
   <p:notesSz cx="6858000" cy="9144000"/>
@@ -714,7 +713,7 @@
           <a:lstStyle xmlns:a="http://schemas.openxmlformats.org/drawingml/2006/main"/>
           <a:p xmlns:a="http://schemas.openxmlformats.org/drawingml/2006/main">
             <a:r>
-              <a:t>Read column two before column three. Observed, model estimate, simulator-only. The honest finding: no policy provably beats historical buyers; the contribution is knowing which numbers deserve trust.</a:t>
+              <a:t>Read evidence type before expected savings. The fixed 70 percent rule is fully supported and remains practically competitive with more complex policies.</a:t>
             </a:r>
           </a:p>
         </p:txBody>
@@ -784,7 +783,7 @@
           <a:lstStyle xmlns:a="http://schemas.openxmlformats.org/drawingml/2006/main"/>
           <a:p xmlns:a="http://schemas.openxmlformats.org/drawingml/2006/main">
             <a:r>
-              <a:t>Claims triage. If asked why savings estimates look small: they are per-thread expected savings including failed offers.</a:t>
+              <a:t>H1 is supported, H2 is partial, and H3 is supported only as a simulator sensitivity result. No live causal effect is claimed.</a:t>
             </a:r>
           </a:p>
         </p:txBody>
@@ -854,7 +853,7 @@
           <a:lstStyle xmlns:a="http://schemas.openxmlformats.org/drawingml/2006/main"/>
           <a:p xmlns:a="http://schemas.openxmlformats.org/drawingml/2006/main">
             <a:r>
-              <a:t>Close on the symmetry: behavioral insight for buyers, methodological insight for RL. Invite questions on OPE or the simulator.</a:t>
+              <a:t>Close with the practical 70 percent default and the support-flag rule for personalization.</a:t>
             </a:r>
           </a:p>
         </p:txBody>
@@ -950,72 +949,6 @@
 </p:notes>
 </file>
 
-<file path=ppt/notesSlides/notesSlide15.xml><?xml version="1.0" encoding="utf-8"?>
-<p:notes xmlns:p="http://schemas.openxmlformats.org/presentationml/2006/main">
-  <p:cSld>
-    <p:spTree>
-      <p:nvGrpSpPr>
-        <p:cNvPr id="1" name=""/>
-        <p:cNvGrpSpPr/>
-        <p:nvPr/>
-      </p:nvGrpSpPr>
-      <p:grpSpPr>
-        <a:xfrm xmlns:a="http://schemas.openxmlformats.org/drawingml/2006/main"/>
-      </p:grpSpPr>
-      <p:sp>
-        <p:nvSpPr>
-          <p:cNvPr id="2" name="Slide Image Placeholder 1"/>
-          <p:cNvSpPr>
-            <a:spLocks xmlns:a="http://schemas.openxmlformats.org/drawingml/2006/main" noGrp="1"/>
-          </p:cNvSpPr>
-          <p:nvPr>
-            <p:ph type="sldImg" idx="0"/>
-          </p:nvPr>
-        </p:nvSpPr>
-        <p:spPr/>
-      </p:sp>
-      <p:sp>
-        <p:nvSpPr>
-          <p:cNvPr id="3" name="Notes Placeholder 2"/>
-          <p:cNvSpPr>
-            <a:spLocks xmlns:a="http://schemas.openxmlformats.org/drawingml/2006/main" noGrp="1"/>
-          </p:cNvSpPr>
-          <p:nvPr>
-            <p:ph type="body" idx="1"/>
-          </p:nvPr>
-        </p:nvSpPr>
-        <p:spPr/>
-        <p:txBody>
-          <a:bodyPr xmlns:a="http://schemas.openxmlformats.org/drawingml/2006/main"/>
-          <a:lstStyle xmlns:a="http://schemas.openxmlformats.org/drawingml/2006/main"/>
-          <a:p xmlns:a="http://schemas.openxmlformats.org/drawingml/2006/main"/>
-        </p:txBody>
-      </p:sp>
-      <p:sp>
-        <p:nvSpPr>
-          <p:cNvPr id="4" name="Slide Number Placeholder 3"/>
-          <p:cNvSpPr>
-            <a:spLocks xmlns:a="http://schemas.openxmlformats.org/drawingml/2006/main" noGrp="1"/>
-          </p:cNvSpPr>
-          <p:nvPr>
-            <p:ph type="sldNum" idx="5"/>
-          </p:nvPr>
-        </p:nvSpPr>
-        <p:spPr/>
-        <p:txBody>
-          <a:bodyPr xmlns:a="http://schemas.openxmlformats.org/drawingml/2006/main"/>
-          <a:lstStyle xmlns:a="http://schemas.openxmlformats.org/drawingml/2006/main"/>
-          <a:p xmlns:a="http://schemas.openxmlformats.org/drawingml/2006/main"/>
-        </p:txBody>
-      </p:sp>
-    </p:spTree>
-  </p:cSld>
-  <p:clrMapOvr>
-    <a:masterClrMapping xmlns:a="http://schemas.openxmlformats.org/drawingml/2006/main"/>
-  </p:clrMapOvr>
-</p:notes>
-</file>
-
 <file path=ppt/notesSlides/notesSlide2.xml><?xml version="1.0" encoding="utf-8"?>
 <p:notes xmlns:p="http://schemas.openxmlformats.org/presentationml/2006/main">
   <p:cSld>
@@ -1406,7 +1339,7 @@
           <a:lstStyle xmlns:a="http://schemas.openxmlformats.org/drawingml/2006/main"/>
           <a:p xmlns:a="http://schemas.openxmlformats.org/drawingml/2006/main">
             <a:r>
-              <a:t>Ported findings slide: Phase 1 is a response model, not a value function. AUC says prediction is usable; the ESS number previews why greedy maximization of this surface fails.</a:t>
+              <a:t>Phase 1 is both discriminative and calibrated. The key limitation is not prediction quality alone; it is observational support when the model is optimized.</a:t>
             </a:r>
           </a:p>
         </p:txBody>
@@ -1546,7 +1479,7 @@
           <a:lstStyle xmlns:a="http://schemas.openxmlformats.org/drawingml/2006/main"/>
           <a:p xmlns:a="http://schemas.openxmlformats.org/drawingml/2006/main">
             <a:r>
-              <a:t>The headline diagnostic. CQL and the fixed anchor retain around 36 percent effective support; greedy collapses to under one percent. High estimated reward, no evaluability.</a:t>
+              <a:t>At h = 0.05, greedy has lower ESS than CQL or fixed 0.70. These estimated-propensity diagnostics are useful for support, not causal policy lift.</a:t>
             </a:r>
           </a:p>
         </p:txBody>
@@ -4502,17 +4435,17 @@
   </p:cSld>
   <p:clrMap bg1="lt1" tx1="dk1" bg2="lt2" tx2="dk2" accent1="accent1" accent2="accent2" accent3="accent3" accent4="accent4" accent5="accent5" accent6="accent6" hlink="hlink" folHlink="folHlink"/>
   <p:sldLayoutIdLst>
-    <p:sldLayoutId xmlns:r="http://schemas.openxmlformats.org/officeDocument/2006/relationships" id="2147483649" r:id="R83e70888bb23499e"/>
-    <p:sldLayoutId xmlns:r="http://schemas.openxmlformats.org/officeDocument/2006/relationships" id="2147483650" r:id="R1767977c581d4835"/>
-    <p:sldLayoutId xmlns:r="http://schemas.openxmlformats.org/officeDocument/2006/relationships" id="2147483651" r:id="Red5587056e884629"/>
-    <p:sldLayoutId xmlns:r="http://schemas.openxmlformats.org/officeDocument/2006/relationships" id="2147483652" r:id="Ra41f1bdad1e04776"/>
-    <p:sldLayoutId xmlns:r="http://schemas.openxmlformats.org/officeDocument/2006/relationships" id="2147483653" r:id="R00b7778e8b6d4f1a"/>
-    <p:sldLayoutId xmlns:r="http://schemas.openxmlformats.org/officeDocument/2006/relationships" id="2147483654" r:id="R5f7ac345e5a948df"/>
-    <p:sldLayoutId xmlns:r="http://schemas.openxmlformats.org/officeDocument/2006/relationships" id="2147483655" r:id="Re27b9ef12f994ceb"/>
-    <p:sldLayoutId xmlns:r="http://schemas.openxmlformats.org/officeDocument/2006/relationships" id="2147483656" r:id="R85a04191d6064dc9"/>
-    <p:sldLayoutId xmlns:r="http://schemas.openxmlformats.org/officeDocument/2006/relationships" id="2147483657" r:id="Rdf2685746d1243e1"/>
-    <p:sldLayoutId xmlns:r="http://schemas.openxmlformats.org/officeDocument/2006/relationships" id="2147483658" r:id="Rc5053c11f2384d6d"/>
-    <p:sldLayoutId xmlns:r="http://schemas.openxmlformats.org/officeDocument/2006/relationships" id="2147483659" r:id="R7e122ed921414cf0"/>
+    <p:sldLayoutId xmlns:r="http://schemas.openxmlformats.org/officeDocument/2006/relationships" id="2147483649" r:id="Ra292774b760a4da7"/>
+    <p:sldLayoutId xmlns:r="http://schemas.openxmlformats.org/officeDocument/2006/relationships" id="2147483650" r:id="Rf46b8eb557584e62"/>
+    <p:sldLayoutId xmlns:r="http://schemas.openxmlformats.org/officeDocument/2006/relationships" id="2147483651" r:id="R589c31d0e5964da2"/>
+    <p:sldLayoutId xmlns:r="http://schemas.openxmlformats.org/officeDocument/2006/relationships" id="2147483652" r:id="R8941f7aff2b94135"/>
+    <p:sldLayoutId xmlns:r="http://schemas.openxmlformats.org/officeDocument/2006/relationships" id="2147483653" r:id="R036164d91ee34ad2"/>
+    <p:sldLayoutId xmlns:r="http://schemas.openxmlformats.org/officeDocument/2006/relationships" id="2147483654" r:id="Rbbc89adddf944437"/>
+    <p:sldLayoutId xmlns:r="http://schemas.openxmlformats.org/officeDocument/2006/relationships" id="2147483655" r:id="R8863600462bc436f"/>
+    <p:sldLayoutId xmlns:r="http://schemas.openxmlformats.org/officeDocument/2006/relationships" id="2147483656" r:id="R4a3c8010670e4d34"/>
+    <p:sldLayoutId xmlns:r="http://schemas.openxmlformats.org/officeDocument/2006/relationships" id="2147483657" r:id="Rba474a5fd5864b2d"/>
+    <p:sldLayoutId xmlns:r="http://schemas.openxmlformats.org/officeDocument/2006/relationships" id="2147483658" r:id="R0ba059de7a864bd7"/>
+    <p:sldLayoutId xmlns:r="http://schemas.openxmlformats.org/officeDocument/2006/relationships" id="2147483659" r:id="R8295b6f88e434cff"/>
   </p:sldLayoutIdLst>
   <p:txStyles>
     <p:titleStyle>
@@ -5944,7 +5877,6 @@
           </a:p>
         </c:rich>
       </c:tx>
-      <c:overlay val="0"/>
       <c:txPr>
         <a:bodyPr xmlns:a="http://schemas.openxmlformats.org/drawingml/2006/main" anchorCtr="1"/>
         <a:lstStyle xmlns:a="http://schemas.openxmlformats.org/drawingml/2006/main"/>
@@ -6005,13 +5937,13 @@
                 <c:formatCode>General</c:formatCode>
                 <c:ptCount val="3"/>
                 <c:pt idx="0">
-                  <c:v>0.008</c:v>
+                  <c:v>0.256</c:v>
                 </c:pt>
                 <c:pt idx="1">
                   <c:v>0.362</c:v>
                 </c:pt>
                 <c:pt idx="2">
-                  <c:v>0.362</c:v>
+                  <c:v>0.355</c:v>
                 </c:pt>
               </c:numCache>
             </c:numRef>
@@ -6093,7 +6025,7 @@
           <p:nvPr/>
         </p:nvPicPr>
         <p:blipFill>
-          <a:blip xmlns:r="http://schemas.openxmlformats.org/officeDocument/2006/relationships" xmlns:a="http://schemas.openxmlformats.org/drawingml/2006/main" r:embed="R920131b0e46b4504"/>
+          <a:blip xmlns:r="http://schemas.openxmlformats.org/officeDocument/2006/relationships" xmlns:a="http://schemas.openxmlformats.org/drawingml/2006/main" r:embed="Rf52065732c3c4ff0"/>
           <a:stretch xmlns:a="http://schemas.openxmlformats.org/drawingml/2006/main">
             <a:fillRect l="0" t="0" r="0" b="0"/>
           </a:stretch>
@@ -6396,7 +6328,7 @@
           <p:nvPr/>
         </p:nvPicPr>
         <p:blipFill>
-          <a:blip xmlns:r="http://schemas.openxmlformats.org/officeDocument/2006/relationships" xmlns:a="http://schemas.openxmlformats.org/drawingml/2006/main" r:embed="R13c728c21e4f46a2"/>
+          <a:blip xmlns:r="http://schemas.openxmlformats.org/officeDocument/2006/relationships" xmlns:a="http://schemas.openxmlformats.org/drawingml/2006/main" r:embed="R0d14f01e92024e7c"/>
           <a:stretch xmlns:a="http://schemas.openxmlformats.org/drawingml/2006/main">
             <a:fillRect l="0" t="0" r="0" b="0"/>
           </a:stretch>
@@ -6692,7 +6624,7 @@
           <p:nvPr/>
         </p:nvPicPr>
         <p:blipFill>
-          <a:blip xmlns:r="http://schemas.openxmlformats.org/officeDocument/2006/relationships" xmlns:a="http://schemas.openxmlformats.org/drawingml/2006/main" r:embed="R96f9dbd99e8f4684"/>
+          <a:blip xmlns:r="http://schemas.openxmlformats.org/officeDocument/2006/relationships" xmlns:a="http://schemas.openxmlformats.org/drawingml/2006/main" r:embed="Rc34ac51e16964d8b"/>
           <a:stretch xmlns:a="http://schemas.openxmlformats.org/drawingml/2006/main">
             <a:fillRect l="0" t="0" r="0" b="0"/>
           </a:stretch>
@@ -6752,7 +6684,7 @@
                 <a:ea typeface="Arial"/>
                 <a:cs typeface="Arial"/>
               </a:rPr>
-              <a:t>What: evidence triage, not a leaderboard</a:t>
+              <a:t>What: the simple rule remains competitive</a:t>
             </a:r>
           </a:p>
         </p:txBody>
@@ -6973,7 +6905,7 @@
                           <a:ea typeface="Arial"/>
                           <a:cs typeface="Arial"/>
                         </a:rPr>
-                        <a:t>Deal / accept rate</a:t>
+                        <a:t>Accept rate</a:t>
                       </a:r>
                     </a:p>
                   </a:txBody>
@@ -7023,7 +6955,7 @@
                           <a:ea typeface="Arial"/>
                           <a:cs typeface="Arial"/>
                         </a:rPr>
-                        <a:t>Behavioral (historical)</a:t>
+                        <a:t>Historical</a:t>
                       </a:r>
                     </a:p>
                   </a:txBody>
@@ -7068,7 +7000,7 @@
                           <a:ea typeface="Arial"/>
                           <a:cs typeface="Arial"/>
                         </a:rPr>
-                        <a:t>0.050</a:t>
+                        <a:t>0.0973</a:t>
                       </a:r>
                     </a:p>
                   </a:txBody>
@@ -7092,7 +7024,7 @@
                           <a:ea typeface="Arial"/>
                           <a:cs typeface="Arial"/>
                         </a:rPr>
-                        <a:t>0.128</a:t>
+                        <a:t>0.3346</a:t>
                       </a:r>
                     </a:p>
                   </a:txBody>
@@ -7116,7 +7048,7 @@
                           <a:ea typeface="Arial"/>
                           <a:cs typeface="Arial"/>
                         </a:rPr>
-                        <a:t>0.665</a:t>
+                        <a:t>0.6062</a:t>
                       </a:r>
                     </a:p>
                   </a:txBody>
@@ -7139,7 +7071,7 @@
                           <a:ea typeface="Arial"/>
                           <a:cs typeface="Arial"/>
                         </a:rPr>
-                        <a:t>Fixed anchor 0.70</a:t>
+                        <a:t>Fixed 0.70</a:t>
                       </a:r>
                     </a:p>
                   </a:txBody>
@@ -7184,7 +7116,7 @@
                           <a:ea typeface="Arial"/>
                           <a:cs typeface="Arial"/>
                         </a:rPr>
-                        <a:t>0.027</a:t>
+                        <a:t>0.1268</a:t>
                       </a:r>
                     </a:p>
                   </a:txBody>
@@ -7208,7 +7140,7 @@
                           <a:ea typeface="Arial"/>
                           <a:cs typeface="Arial"/>
                         </a:rPr>
-                        <a:t>0.089</a:t>
+                        <a:t>0.4226</a:t>
                       </a:r>
                     </a:p>
                   </a:txBody>
@@ -7232,7 +7164,7 @@
                           <a:ea typeface="Arial"/>
                           <a:cs typeface="Arial"/>
                         </a:rPr>
-                        <a:t>0.700</a:t>
+                        <a:t>0.7000</a:t>
                       </a:r>
                     </a:p>
                   </a:txBody>
@@ -7255,7 +7187,7 @@
                           <a:ea typeface="Arial"/>
                           <a:cs typeface="Arial"/>
                         </a:rPr>
-                        <a:t>CQL offline RL</a:t>
+                        <a:t>Greedy</a:t>
                       </a:r>
                     </a:p>
                   </a:txBody>
@@ -7300,7 +7232,7 @@
                           <a:ea typeface="Arial"/>
                           <a:cs typeface="Arial"/>
                         </a:rPr>
-                        <a:t>0.020</a:t>
+                        <a:t>0.1371</a:t>
                       </a:r>
                     </a:p>
                   </a:txBody>
@@ -7324,7 +7256,7 @@
                           <a:ea typeface="Arial"/>
                           <a:cs typeface="Arial"/>
                         </a:rPr>
-                        <a:t>0.087</a:t>
+                        <a:t>0.5007</a:t>
                       </a:r>
                     </a:p>
                   </a:txBody>
@@ -7348,7 +7280,7 @@
                           <a:ea typeface="Arial"/>
                           <a:cs typeface="Arial"/>
                         </a:rPr>
-                        <a:t>0.769</a:t>
+                        <a:t>0.7333</a:t>
                       </a:r>
                     </a:p>
                   </a:txBody>
@@ -7371,7 +7303,7 @@
                           <a:ea typeface="Arial"/>
                           <a:cs typeface="Arial"/>
                         </a:rPr>
-                        <a:t>PPO faithful simulator</a:t>
+                        <a:t>CQL</a:t>
                       </a:r>
                     </a:p>
                   </a:txBody>
@@ -7392,7 +7324,7 @@
                           <a:ea typeface="Arial"/>
                           <a:cs typeface="Arial"/>
                         </a:rPr>
-                        <a:t>simulator-only</a:t>
+                        <a:t>model estimate</a:t>
                       </a:r>
                     </a:p>
                   </a:txBody>
@@ -7416,7 +7348,7 @@
                           <a:ea typeface="Arial"/>
                           <a:cs typeface="Arial"/>
                         </a:rPr>
-                        <a:t>0.184</a:t>
+                        <a:t>0.1219</a:t>
                       </a:r>
                     </a:p>
                   </a:txBody>
@@ -7440,7 +7372,7 @@
                           <a:ea typeface="Arial"/>
                           <a:cs typeface="Arial"/>
                         </a:rPr>
-                        <a:t>0.270</a:t>
+                        <a:t>0.4214</a:t>
                       </a:r>
                     </a:p>
                   </a:txBody>
@@ -7464,7 +7396,7 @@
                           <a:ea typeface="Arial"/>
                           <a:cs typeface="Arial"/>
                         </a:rPr>
-                        <a:t>0.318</a:t>
+                        <a:t>0.7025</a:t>
                       </a:r>
                     </a:p>
                   </a:txBody>
@@ -7524,7 +7456,7 @@
                 <a:ea typeface="Arial"/>
                 <a:cs typeface="Arial"/>
               </a:rPr>
-              <a:t>Rows carry different evidence types: the PPO row is a learned-simulator stress test and is not comparable to the observed behavioral row.</a:t>
+              <a:t>Observed outcomes and Phase-1 estimates are different evidence types; neither is causal marketplace lift.</a:t>
             </a:r>
           </a:p>
         </p:txBody>
@@ -7574,7 +7506,7 @@
                 <a:ea typeface="Arial"/>
                 <a:cs typeface="Arial"/>
               </a:rPr>
-              <a:t>Under the same model surface, conservative CQL does not beat logged behavior - a negative result that motivates the diagnostics.</a:t>
+              <a:t>PPO falls from 0.1273 to 0.1209 under robustness checks (-4.99%): simulator sensitivity, not marketplace evidence.</a:t>
             </a:r>
           </a:p>
         </p:txBody>
@@ -7610,7 +7542,7 @@
           <p:nvPr/>
         </p:nvPicPr>
         <p:blipFill>
-          <a:blip xmlns:r="http://schemas.openxmlformats.org/officeDocument/2006/relationships" xmlns:a="http://schemas.openxmlformats.org/drawingml/2006/main" r:embed="R9b40bd527ba242e2"/>
+          <a:blip xmlns:r="http://schemas.openxmlformats.org/officeDocument/2006/relationships" xmlns:a="http://schemas.openxmlformats.org/drawingml/2006/main" r:embed="R82eb75edc1454c02"/>
           <a:stretch xmlns:a="http://schemas.openxmlformats.org/drawingml/2006/main">
             <a:fillRect l="0" t="0" r="0" b="0"/>
           </a:stretch>
@@ -7820,7 +7752,7 @@
                 <a:ea typeface="Arial"/>
                 <a:cs typeface="Arial"/>
               </a:rPr>
-              <a:t>Supported</a:t>
+              <a:t>H1 supported</a:t>
             </a:r>
           </a:p>
         </p:txBody>
@@ -7870,7 +7802,7 @@
                 <a:ea typeface="Arial"/>
                 <a:cs typeface="Arial"/>
               </a:rPr>
-              <a:t>Greedy supervised maximization leaves the data's support; CQL stays evaluable (ESS 36% vs 0.8%).</a:t>
+              <a:t>99.981% of supervised-greedy choices are interior; the population curve peaks near 0.67.</a:t>
             </a:r>
           </a:p>
         </p:txBody>
@@ -7920,7 +7852,7 @@
                 <a:ea typeface="Arial"/>
                 <a:cs typeface="Arial"/>
               </a:rPr>
-              <a:t>Cautious</a:t>
+              <a:t>H2 partial</a:t>
             </a:r>
           </a:p>
         </p:txBody>
@@ -7970,7 +7902,7 @@
                 <a:ea typeface="Arial"/>
                 <a:cs typeface="Arial"/>
               </a:rPr>
-              <a:t>PPO's high simulator savings are a stress test of the learned environment, not marketplace performance.</a:t>
+              <a:t>Greedy stays in p5-p95 support 90.99% vs CQL 99.92%; OPE remains bandwidth-sensitive and non-causal.</a:t>
             </a:r>
           </a:p>
         </p:txBody>
@@ -8015,6 +7947,106 @@
               <a:rPr sz="1350" b="1" i="0">
                 <a:solidFill>
                   <a:srgbClr val="000000"/>
+                </a:solidFill>
+                <a:latin typeface="Arial"/>
+                <a:ea typeface="Arial"/>
+                <a:cs typeface="Arial"/>
+              </a:rPr>
+              <a:t>H3 simulator</a:t>
+            </a:r>
+          </a:p>
+        </p:txBody>
+      </p:sp>
+      <p:sp>
+        <p:nvSpPr>
+          <p:cNvPr id="11" name="TextBox 10">
+            <a:extLst xmlns:a="http://schemas.openxmlformats.org/drawingml/2006/main">
+              <a:ext uri="{FF2B5EF4-FFF2-40B4-BE49-F238E27FC236}">
+                <a16:creationId xmlns:a16="http://schemas.microsoft.com/office/drawing/2014/main" id="{FB0D60BA-8227-41A2-B66D-EC00C9DA5A8A}"/>
+              </a:ext>
+            </a:extLst>
+          </p:cNvPr>
+          <p:cNvSpPr>
+            <a:spLocks xmlns:a="http://schemas.openxmlformats.org/drawingml/2006/main" noGrp="1"/>
+          </p:cNvSpPr>
+          <p:nvPr/>
+        </p:nvSpPr>
+        <p:spPr>
+          <a:xfrm xmlns:a="http://schemas.openxmlformats.org/drawingml/2006/main">
+            <a:off x="2011680" y="2697480"/>
+            <a:ext cx="6766560" cy="685800"/>
+          </a:xfrm>
+          <a:prstGeom xmlns:a="http://schemas.openxmlformats.org/drawingml/2006/main" prst="rect">
+            <a:avLst/>
+          </a:prstGeom>
+          <a:noFill xmlns:a="http://schemas.openxmlformats.org/drawingml/2006/main"/>
+        </p:spPr>
+        <p:txBody>
+          <a:bodyPr xmlns:a="http://schemas.openxmlformats.org/drawingml/2006/main" wrap="square">
+            <a:spAutoFit/>
+          </a:bodyPr>
+          <a:lstStyle xmlns:a="http://schemas.openxmlformats.org/drawingml/2006/main"/>
+          <a:p xmlns:a="http://schemas.openxmlformats.org/drawingml/2006/main">
+            <a:pPr algn="l">
+              <a:spcAft>
+                <a:spcPts val="600"/>
+              </a:spcAft>
+              <a:buNone/>
+            </a:pPr>
+            <a:r>
+              <a:rPr sz="1250" b="0" i="0">
+                <a:solidFill>
+                  <a:srgbClr val="000000"/>
+                </a:solidFill>
+                <a:latin typeface="Arial"/>
+                <a:ea typeface="Arial"/>
+                <a:cs typeface="Arial"/>
+              </a:rPr>
+              <a:t>Robust PPO reward is 4.99% below basic PPO, supporting simulator sensitivity only.</a:t>
+            </a:r>
+          </a:p>
+        </p:txBody>
+      </p:sp>
+      <p:sp>
+        <p:nvSpPr>
+          <p:cNvPr id="12" name="TextBox 11">
+            <a:extLst xmlns:a="http://schemas.openxmlformats.org/drawingml/2006/main">
+              <a:ext uri="{FF2B5EF4-FFF2-40B4-BE49-F238E27FC236}">
+                <a16:creationId xmlns:a16="http://schemas.microsoft.com/office/drawing/2014/main" id="{0F901A1F-412A-411D-A3AC-7CA5BA918422}"/>
+              </a:ext>
+            </a:extLst>
+          </p:cNvPr>
+          <p:cNvSpPr>
+            <a:spLocks xmlns:a="http://schemas.openxmlformats.org/drawingml/2006/main" noGrp="1"/>
+          </p:cNvSpPr>
+          <p:nvPr/>
+        </p:nvSpPr>
+        <p:spPr>
+          <a:xfrm xmlns:a="http://schemas.openxmlformats.org/drawingml/2006/main">
+            <a:off x="384048" y="3657600"/>
+            <a:ext cx="1554480" cy="365760"/>
+          </a:xfrm>
+          <a:prstGeom xmlns:a="http://schemas.openxmlformats.org/drawingml/2006/main" prst="rect">
+            <a:avLst/>
+          </a:prstGeom>
+          <a:noFill xmlns:a="http://schemas.openxmlformats.org/drawingml/2006/main"/>
+        </p:spPr>
+        <p:txBody>
+          <a:bodyPr xmlns:a="http://schemas.openxmlformats.org/drawingml/2006/main" wrap="square">
+            <a:spAutoFit/>
+          </a:bodyPr>
+          <a:lstStyle xmlns:a="http://schemas.openxmlformats.org/drawingml/2006/main"/>
+          <a:p xmlns:a="http://schemas.openxmlformats.org/drawingml/2006/main">
+            <a:pPr algn="l">
+              <a:spcAft>
+                <a:spcPts val="600"/>
+              </a:spcAft>
+              <a:buNone/>
+            </a:pPr>
+            <a:r>
+              <a:rPr sz="1350" b="1" i="0">
+                <a:solidFill>
+                  <a:srgbClr val="0065BD"/>
                 </a:solidFill>
                 <a:latin typeface="Arial"/>
                 <a:ea typeface="Arial"/>
@@ -8027,10 +8059,10 @@
       </p:sp>
       <p:sp>
         <p:nvSpPr>
-          <p:cNvPr id="11" name="TextBox 10">
-            <a:extLst xmlns:a="http://schemas.openxmlformats.org/drawingml/2006/main">
-              <a:ext uri="{FF2B5EF4-FFF2-40B4-BE49-F238E27FC236}">
-                <a16:creationId xmlns:a16="http://schemas.microsoft.com/office/drawing/2014/main" id="{FB0D60BA-8227-41A2-B66D-EC00C9DA5A8A}"/>
+          <p:cNvPr id="13" name="TextBox 12">
+            <a:extLst xmlns:a="http://schemas.openxmlformats.org/drawingml/2006/main">
+              <a:ext uri="{FF2B5EF4-FFF2-40B4-BE49-F238E27FC236}">
+                <a16:creationId xmlns:a16="http://schemas.microsoft.com/office/drawing/2014/main" id="{B7B9B380-DF38-48F4-8BEF-7283E5BD7741}"/>
               </a:ext>
             </a:extLst>
           </p:cNvPr>
@@ -8041,8 +8073,8 @@
         </p:nvSpPr>
         <p:spPr>
           <a:xfrm xmlns:a="http://schemas.openxmlformats.org/drawingml/2006/main">
-            <a:off x="2011680" y="2697480"/>
-            <a:ext cx="6766560" cy="685800"/>
+            <a:off x="2011680" y="3657600"/>
+            <a:ext cx="6766560" cy="914400"/>
           </a:xfrm>
           <a:prstGeom xmlns:a="http://schemas.openxmlformats.org/drawingml/2006/main" prst="rect">
             <a:avLst/>
@@ -8070,107 +8102,7 @@
                 <a:ea typeface="Arial"/>
                 <a:cs typeface="Arial"/>
               </a:rPr>
-              <a:t>Live marketplace lift, causal anchoring effects, or an optimal offer policy.</a:t>
-            </a:r>
-          </a:p>
-        </p:txBody>
-      </p:sp>
-      <p:sp>
-        <p:nvSpPr>
-          <p:cNvPr id="12" name="TextBox 11">
-            <a:extLst xmlns:a="http://schemas.openxmlformats.org/drawingml/2006/main">
-              <a:ext uri="{FF2B5EF4-FFF2-40B4-BE49-F238E27FC236}">
-                <a16:creationId xmlns:a16="http://schemas.microsoft.com/office/drawing/2014/main" id="{0F901A1F-412A-411D-A3AC-7CA5BA918422}"/>
-              </a:ext>
-            </a:extLst>
-          </p:cNvPr>
-          <p:cNvSpPr>
-            <a:spLocks xmlns:a="http://schemas.openxmlformats.org/drawingml/2006/main" noGrp="1"/>
-          </p:cNvSpPr>
-          <p:nvPr/>
-        </p:nvSpPr>
-        <p:spPr>
-          <a:xfrm xmlns:a="http://schemas.openxmlformats.org/drawingml/2006/main">
-            <a:off x="384048" y="3657600"/>
-            <a:ext cx="1554480" cy="365760"/>
-          </a:xfrm>
-          <a:prstGeom xmlns:a="http://schemas.openxmlformats.org/drawingml/2006/main" prst="rect">
-            <a:avLst/>
-          </a:prstGeom>
-          <a:noFill xmlns:a="http://schemas.openxmlformats.org/drawingml/2006/main"/>
-        </p:spPr>
-        <p:txBody>
-          <a:bodyPr xmlns:a="http://schemas.openxmlformats.org/drawingml/2006/main" wrap="square">
-            <a:spAutoFit/>
-          </a:bodyPr>
-          <a:lstStyle xmlns:a="http://schemas.openxmlformats.org/drawingml/2006/main"/>
-          <a:p xmlns:a="http://schemas.openxmlformats.org/drawingml/2006/main">
-            <a:pPr algn="l">
-              <a:spcAft>
-                <a:spcPts val="600"/>
-              </a:spcAft>
-              <a:buNone/>
-            </a:pPr>
-            <a:r>
-              <a:rPr sz="1350" b="1" i="0">
-                <a:solidFill>
-                  <a:srgbClr val="0065BD"/>
-                </a:solidFill>
-                <a:latin typeface="Arial"/>
-                <a:ea typeface="Arial"/>
-                <a:cs typeface="Arial"/>
-              </a:rPr>
-              <a:t>Future work</a:t>
-            </a:r>
-          </a:p>
-        </p:txBody>
-      </p:sp>
-      <p:sp>
-        <p:nvSpPr>
-          <p:cNvPr id="13" name="TextBox 12">
-            <a:extLst xmlns:a="http://schemas.openxmlformats.org/drawingml/2006/main">
-              <a:ext uri="{FF2B5EF4-FFF2-40B4-BE49-F238E27FC236}">
-                <a16:creationId xmlns:a16="http://schemas.microsoft.com/office/drawing/2014/main" id="{B7B9B380-DF38-48F4-8BEF-7283E5BD7741}"/>
-              </a:ext>
-            </a:extLst>
-          </p:cNvPr>
-          <p:cNvSpPr>
-            <a:spLocks xmlns:a="http://schemas.openxmlformats.org/drawingml/2006/main" noGrp="1"/>
-          </p:cNvSpPr>
-          <p:nvPr/>
-        </p:nvSpPr>
-        <p:spPr>
-          <a:xfrm xmlns:a="http://schemas.openxmlformats.org/drawingml/2006/main">
-            <a:off x="2011680" y="3657600"/>
-            <a:ext cx="6766560" cy="914400"/>
-          </a:xfrm>
-          <a:prstGeom xmlns:a="http://schemas.openxmlformats.org/drawingml/2006/main" prst="rect">
-            <a:avLst/>
-          </a:prstGeom>
-          <a:noFill xmlns:a="http://schemas.openxmlformats.org/drawingml/2006/main"/>
-        </p:spPr>
-        <p:txBody>
-          <a:bodyPr xmlns:a="http://schemas.openxmlformats.org/drawingml/2006/main" wrap="square">
-            <a:spAutoFit/>
-          </a:bodyPr>
-          <a:lstStyle xmlns:a="http://schemas.openxmlformats.org/drawingml/2006/main"/>
-          <a:p xmlns:a="http://schemas.openxmlformats.org/drawingml/2006/main">
-            <a:pPr algn="l">
-              <a:spcAft>
-                <a:spcPts val="600"/>
-              </a:spcAft>
-              <a:buNone/>
-            </a:pPr>
-            <a:r>
-              <a:rPr sz="1250" b="0" i="0">
-                <a:solidFill>
-                  <a:srgbClr val="000000"/>
-                </a:solidFill>
-                <a:latin typeface="Arial"/>
-                <a:ea typeface="Arial"/>
-                <a:cs typeface="Arial"/>
-              </a:rPr>
-              <a:t>Sequential counteroffers (about 40% of threads contain a second move), richer item features, temporal and leaf-holdout robustness tables.</a:t>
+              <a:t>Live marketplace lift, causal anchoring effects, resale margin, or total buyer welfare.</a:t>
             </a:r>
           </a:p>
         </p:txBody>
@@ -8206,7 +8138,7 @@
           <p:nvPr/>
         </p:nvPicPr>
         <p:blipFill>
-          <a:blip xmlns:r="http://schemas.openxmlformats.org/officeDocument/2006/relationships" xmlns:a="http://schemas.openxmlformats.org/drawingml/2006/main" r:embed="R88f30944e7a54d84"/>
+          <a:blip xmlns:r="http://schemas.openxmlformats.org/officeDocument/2006/relationships" xmlns:a="http://schemas.openxmlformats.org/drawingml/2006/main" r:embed="R933f44b7c8f34e7d"/>
           <a:stretch xmlns:a="http://schemas.openxmlformats.org/drawingml/2006/main">
             <a:fillRect l="0" t="0" r="0" b="0"/>
           </a:stretch>
@@ -8416,7 +8348,7 @@
                 <a:ea typeface="Arial"/>
                 <a:cs typeface="Arial"/>
               </a:rPr>
-              <a:t>The lowest offer is not the best decision - and the highest estimate is not the best evidence.</a:t>
+              <a:t>The simplest defensible opening offer is near 70% of the listing price.</a:t>
             </a:r>
           </a:p>
         </p:txBody>
@@ -8466,7 +8398,7 @@
                 <a:ea typeface="Arial"/>
                 <a:cs typeface="Arial"/>
               </a:rPr>
-              <a:t>Contribution: a reproducible, support-aware pipeline that makes extrapolation measurable before a recommendation is trusted.</a:t>
+              <a:t>Use supervised-greedy personalization only when its support flag is true; otherwise prefer CQL or fixed 70%.</a:t>
             </a:r>
           </a:p>
           <a:p xmlns:a="http://schemas.openxmlformats.org/drawingml/2006/main">
@@ -8485,7 +8417,7 @@
                 <a:ea typeface="Arial"/>
                 <a:cs typeface="Arial"/>
               </a:rPr>
-              <a:t>Next: multi-turn counteroffers with explicit uncertainty - the rejection branch stops being zero.</a:t>
+              <a:t>Contribution: corrected event semantics, calibrated acceptance, a measurable reward-support trade-off, and a quantified PPO robustness gap.</a:t>
             </a:r>
           </a:p>
         </p:txBody>
@@ -8571,7 +8503,7 @@
       </p:grpSpPr>
       <p:sp>
         <p:nvSpPr>
-          <p:cNvPr id="1" name="">
+          <p:cNvPr id="20" name="">
             <a:extLst xmlns:a="http://schemas.openxmlformats.org/drawingml/2006/main">
               <a:ext uri="{FF2B5EF4-FFF2-40B4-BE49-F238E27FC236}">
                 <a16:creationId xmlns:a16="http://schemas.microsoft.com/office/drawing/2014/main" id="{0855E245-BD5D-4DF9-BCCE-7D5954D294BF}"/>
@@ -9408,1237 +9340,6 @@
     <p:extLst>
       <p:ext uri="{BB962C8B-B14F-4D97-AF65-F5344CB8AC3E}">
         <p14:creationId xmlns:p14="http://schemas.microsoft.com/office/powerpoint/2010/main" val="985585785"/>
-      </p:ext>
-    </p:extLst>
-  </p:cSld>
-</p:sld>
-</file>
-
-<file path=ppt/slides/slide15.xml><?xml version="1.0" encoding="utf-8"?>
-<p:sld xmlns:p="http://schemas.openxmlformats.org/presentationml/2006/main">
-  <p:cSld>
-    <p:bg>
-      <p:bgPr>
-        <a:solidFill xmlns:a="http://schemas.openxmlformats.org/drawingml/2006/main">
-          <a:srgbClr val="FFFFFF"/>
-        </a:solidFill>
-      </p:bgPr>
-    </p:bg>
-    <p:spTree>
-      <p:nvGrpSpPr>
-        <p:cNvPr id="1" name=""/>
-        <p:cNvGrpSpPr/>
-        <p:nvPr/>
-      </p:nvGrpSpPr>
-      <p:grpSpPr>
-        <a:xfrm xmlns:a="http://schemas.openxmlformats.org/drawingml/2006/main"/>
-      </p:grpSpPr>
-      <p:sp>
-        <p:nvSpPr>
-          <p:cNvPr id="1" name="">
-            <a:extLst xmlns:a="http://schemas.openxmlformats.org/drawingml/2006/main">
-              <a:ext uri="{FF2B5EF4-FFF2-40B4-BE49-F238E27FC236}">
-                <a16:creationId xmlns:a16="http://schemas.microsoft.com/office/drawing/2014/main" id="{222E4CEA-A60B-4B78-BEE9-F39BC428FDD4}"/>
-              </a:ext>
-            </a:extLst>
-          </p:cNvPr>
-          <p:cNvSpPr>
-            <a:spLocks xmlns:a="http://schemas.openxmlformats.org/drawingml/2006/main" noGrp="1"/>
-          </p:cNvSpPr>
-          <p:nvPr/>
-        </p:nvSpPr>
-        <p:spPr>
-          <a:xfrm xmlns:a="http://schemas.openxmlformats.org/drawingml/2006/main">
-            <a:off x="514350" y="381000"/>
-            <a:ext cx="8048625" cy="409575"/>
-          </a:xfrm>
-          <a:prstGeom xmlns:a="http://schemas.openxmlformats.org/drawingml/2006/main" prst="rect">
-            <a:avLst/>
-          </a:prstGeom>
-          <a:noFill xmlns:a="http://schemas.openxmlformats.org/drawingml/2006/main"/>
-          <a:ln xmlns:a="http://schemas.openxmlformats.org/drawingml/2006/main" w="0">
-            <a:noFill/>
-            <a:prstDash val="solid"/>
-          </a:ln>
-        </p:spPr>
-        <p:txBody>
-          <a:bodyPr xmlns:a="http://schemas.openxmlformats.org/drawingml/2006/main"/>
-          <a:lstStyle xmlns:a="http://schemas.openxmlformats.org/drawingml/2006/main"/>
-          <a:p xmlns:a="http://schemas.openxmlformats.org/drawingml/2006/main">
-            <a:pPr algn="l">
-              <a:defRPr sz="2175" b="1">
-                <a:solidFill>
-                  <a:srgbClr val="000000"/>
-                </a:solidFill>
-              </a:defRPr>
-            </a:pPr>
-            <a:r>
-              <a:rPr sz="2175" b="1">
-                <a:solidFill>
-                  <a:srgbClr val="000000"/>
-                </a:solidFill>
-              </a:rPr>
-              <a:t>Appendix: real data deliverables are local, not tracked</a:t>
-            </a:r>
-          </a:p>
-        </p:txBody>
-      </p:sp>
-      <p:sp>
-        <p:nvSpPr>
-          <p:cNvPr id="2" name="">
-            <a:extLst xmlns:a="http://schemas.openxmlformats.org/drawingml/2006/main">
-              <a:ext uri="{FF2B5EF4-FFF2-40B4-BE49-F238E27FC236}">
-                <a16:creationId xmlns:a16="http://schemas.microsoft.com/office/drawing/2014/main" id="{0FDD08E2-31FA-4D31-A546-F99EBFA4424F}"/>
-              </a:ext>
-            </a:extLst>
-          </p:cNvPr>
-          <p:cNvSpPr>
-            <a:spLocks xmlns:a="http://schemas.openxmlformats.org/drawingml/2006/main" noGrp="1"/>
-          </p:cNvSpPr>
-          <p:nvPr/>
-        </p:nvSpPr>
-        <p:spPr>
-          <a:xfrm xmlns:a="http://schemas.openxmlformats.org/drawingml/2006/main">
-            <a:off x="514350" y="876300"/>
-            <a:ext cx="1524000" cy="28575"/>
-          </a:xfrm>
-          <a:prstGeom xmlns:a="http://schemas.openxmlformats.org/drawingml/2006/main" prst="rect">
-            <a:avLst/>
-          </a:prstGeom>
-          <a:solidFill xmlns:a="http://schemas.openxmlformats.org/drawingml/2006/main">
-            <a:srgbClr val="005293"/>
-          </a:solidFill>
-          <a:ln xmlns:a="http://schemas.openxmlformats.org/drawingml/2006/main" w="0">
-            <a:noFill/>
-            <a:prstDash val="solid"/>
-          </a:ln>
-        </p:spPr>
-      </p:sp>
-      <p:sp>
-        <p:nvSpPr>
-          <p:cNvPr id="3" name="">
-            <a:extLst xmlns:a="http://schemas.openxmlformats.org/drawingml/2006/main">
-              <a:ext uri="{FF2B5EF4-FFF2-40B4-BE49-F238E27FC236}">
-                <a16:creationId xmlns:a16="http://schemas.microsoft.com/office/drawing/2014/main" id="{CD08FDA4-C2E3-4353-AED5-49F87F5E082E}"/>
-              </a:ext>
-            </a:extLst>
-          </p:cNvPr>
-          <p:cNvSpPr>
-            <a:spLocks xmlns:a="http://schemas.openxmlformats.org/drawingml/2006/main" noGrp="1"/>
-          </p:cNvSpPr>
-          <p:nvPr/>
-        </p:nvSpPr>
-        <p:spPr>
-          <a:xfrm xmlns:a="http://schemas.openxmlformats.org/drawingml/2006/main">
-            <a:off x="514350" y="1104900"/>
-            <a:ext cx="7810500" cy="304800"/>
-          </a:xfrm>
-          <a:prstGeom xmlns:a="http://schemas.openxmlformats.org/drawingml/2006/main" prst="rect">
-            <a:avLst/>
-          </a:prstGeom>
-          <a:noFill xmlns:a="http://schemas.openxmlformats.org/drawingml/2006/main"/>
-          <a:ln xmlns:a="http://schemas.openxmlformats.org/drawingml/2006/main" w="0">
-            <a:noFill/>
-            <a:prstDash val="solid"/>
-          </a:ln>
-        </p:spPr>
-        <p:txBody>
-          <a:bodyPr xmlns:a="http://schemas.openxmlformats.org/drawingml/2006/main"/>
-          <a:lstStyle xmlns:a="http://schemas.openxmlformats.org/drawingml/2006/main"/>
-          <a:p xmlns:a="http://schemas.openxmlformats.org/drawingml/2006/main">
-            <a:pPr algn="l">
-              <a:defRPr sz="1238" b="0">
-                <a:solidFill>
-                  <a:srgbClr val="666666"/>
-                </a:solidFill>
-              </a:defRPr>
-            </a:pPr>
-            <a:r>
-              <a:rPr sz="1238" b="0">
-                <a:solidFill>
-                  <a:srgbClr val="666666"/>
-                </a:solidFill>
-              </a:rPr>
-              <a:t>The repository tracks code and final report assets; production reruns recreate these ignored local files.</a:t>
-            </a:r>
-          </a:p>
-        </p:txBody>
-      </p:sp>
-      <p:sp>
-        <p:nvSpPr>
-          <p:cNvPr id="4" name="">
-            <a:extLst xmlns:a="http://schemas.openxmlformats.org/drawingml/2006/main">
-              <a:ext uri="{FF2B5EF4-FFF2-40B4-BE49-F238E27FC236}">
-                <a16:creationId xmlns:a16="http://schemas.microsoft.com/office/drawing/2014/main" id="{C3118999-1055-4853-B7D2-1B330F733539}"/>
-              </a:ext>
-            </a:extLst>
-          </p:cNvPr>
-          <p:cNvSpPr>
-            <a:spLocks xmlns:a="http://schemas.openxmlformats.org/drawingml/2006/main" noGrp="1"/>
-          </p:cNvSpPr>
-          <p:nvPr/>
-        </p:nvSpPr>
-        <p:spPr>
-          <a:xfrm xmlns:a="http://schemas.openxmlformats.org/drawingml/2006/main">
-            <a:off x="514350" y="1676400"/>
-            <a:ext cx="2457450" cy="790575"/>
-          </a:xfrm>
-          <a:prstGeom xmlns:a="http://schemas.openxmlformats.org/drawingml/2006/main" prst="rect">
-            <a:avLst/>
-          </a:prstGeom>
-          <a:solidFill xmlns:a="http://schemas.openxmlformats.org/drawingml/2006/main">
-            <a:srgbClr val="FFFFFF"/>
-          </a:solidFill>
-          <a:ln xmlns:a="http://schemas.openxmlformats.org/drawingml/2006/main" w="9525">
-            <a:solidFill>
-              <a:srgbClr val="D7E6F2"/>
-            </a:solidFill>
-            <a:prstDash val="solid"/>
-          </a:ln>
-        </p:spPr>
-      </p:sp>
-      <p:sp>
-        <p:nvSpPr>
-          <p:cNvPr id="5" name="">
-            <a:extLst xmlns:a="http://schemas.openxmlformats.org/drawingml/2006/main">
-              <a:ext uri="{FF2B5EF4-FFF2-40B4-BE49-F238E27FC236}">
-                <a16:creationId xmlns:a16="http://schemas.microsoft.com/office/drawing/2014/main" id="{DE9F2EC6-BD0F-4DA0-A85B-747D2400BE62}"/>
-              </a:ext>
-            </a:extLst>
-          </p:cNvPr>
-          <p:cNvSpPr>
-            <a:spLocks xmlns:a="http://schemas.openxmlformats.org/drawingml/2006/main" noGrp="1"/>
-          </p:cNvSpPr>
-          <p:nvPr/>
-        </p:nvSpPr>
-        <p:spPr>
-          <a:xfrm xmlns:a="http://schemas.openxmlformats.org/drawingml/2006/main">
-            <a:off x="514350" y="1676400"/>
-            <a:ext cx="66675" cy="790575"/>
-          </a:xfrm>
-          <a:prstGeom xmlns:a="http://schemas.openxmlformats.org/drawingml/2006/main" prst="rect">
-            <a:avLst/>
-          </a:prstGeom>
-          <a:solidFill xmlns:a="http://schemas.openxmlformats.org/drawingml/2006/main">
-            <a:srgbClr val="005293"/>
-          </a:solidFill>
-          <a:ln xmlns:a="http://schemas.openxmlformats.org/drawingml/2006/main" w="0">
-            <a:noFill/>
-            <a:prstDash val="solid"/>
-          </a:ln>
-        </p:spPr>
-      </p:sp>
-      <p:sp>
-        <p:nvSpPr>
-          <p:cNvPr id="6" name="">
-            <a:extLst xmlns:a="http://schemas.openxmlformats.org/drawingml/2006/main">
-              <a:ext uri="{FF2B5EF4-FFF2-40B4-BE49-F238E27FC236}">
-                <a16:creationId xmlns:a16="http://schemas.microsoft.com/office/drawing/2014/main" id="{5666912E-8C27-4C8E-8DA6-C7F64826AC07}"/>
-              </a:ext>
-            </a:extLst>
-          </p:cNvPr>
-          <p:cNvSpPr>
-            <a:spLocks xmlns:a="http://schemas.openxmlformats.org/drawingml/2006/main" noGrp="1"/>
-          </p:cNvSpPr>
-          <p:nvPr/>
-        </p:nvSpPr>
-        <p:spPr>
-          <a:xfrm xmlns:a="http://schemas.openxmlformats.org/drawingml/2006/main">
-            <a:off x="676275" y="1771650"/>
-            <a:ext cx="2190750" cy="190500"/>
-          </a:xfrm>
-          <a:prstGeom xmlns:a="http://schemas.openxmlformats.org/drawingml/2006/main" prst="rect">
-            <a:avLst/>
-          </a:prstGeom>
-          <a:noFill xmlns:a="http://schemas.openxmlformats.org/drawingml/2006/main"/>
-          <a:ln xmlns:a="http://schemas.openxmlformats.org/drawingml/2006/main" w="0">
-            <a:noFill/>
-            <a:prstDash val="solid"/>
-          </a:ln>
-        </p:spPr>
-        <p:txBody>
-          <a:bodyPr xmlns:a="http://schemas.openxmlformats.org/drawingml/2006/main"/>
-          <a:lstStyle xmlns:a="http://schemas.openxmlformats.org/drawingml/2006/main"/>
-          <a:p xmlns:a="http://schemas.openxmlformats.org/drawingml/2006/main">
-            <a:pPr algn="l">
-              <a:defRPr sz="1125" b="1">
-                <a:solidFill>
-                  <a:srgbClr val="005293"/>
-                </a:solidFill>
-              </a:defRPr>
-            </a:pPr>
-            <a:r>
-              <a:rPr sz="1125" b="1">
-                <a:solidFill>
-                  <a:srgbClr val="005293"/>
-                </a:solidFill>
-              </a:rPr>
-              <a:t>1. Raw input</a:t>
-            </a:r>
-          </a:p>
-        </p:txBody>
-      </p:sp>
-      <p:sp>
-        <p:nvSpPr>
-          <p:cNvPr id="7" name="">
-            <a:extLst xmlns:a="http://schemas.openxmlformats.org/drawingml/2006/main">
-              <a:ext uri="{FF2B5EF4-FFF2-40B4-BE49-F238E27FC236}">
-                <a16:creationId xmlns:a16="http://schemas.microsoft.com/office/drawing/2014/main" id="{828FF00F-F8CA-4C77-8162-C7BA561FA8AD}"/>
-              </a:ext>
-            </a:extLst>
-          </p:cNvPr>
-          <p:cNvSpPr>
-            <a:spLocks xmlns:a="http://schemas.openxmlformats.org/drawingml/2006/main" noGrp="1"/>
-          </p:cNvSpPr>
-          <p:nvPr/>
-        </p:nvSpPr>
-        <p:spPr>
-          <a:xfrm xmlns:a="http://schemas.openxmlformats.org/drawingml/2006/main">
-            <a:off x="676275" y="2009775"/>
-            <a:ext cx="2190750" cy="381000"/>
-          </a:xfrm>
-          <a:prstGeom xmlns:a="http://schemas.openxmlformats.org/drawingml/2006/main" prst="rect">
-            <a:avLst/>
-          </a:prstGeom>
-          <a:noFill xmlns:a="http://schemas.openxmlformats.org/drawingml/2006/main"/>
-          <a:ln xmlns:a="http://schemas.openxmlformats.org/drawingml/2006/main" w="0">
-            <a:noFill/>
-            <a:prstDash val="solid"/>
-          </a:ln>
-        </p:spPr>
-        <p:txBody>
-          <a:bodyPr xmlns:a="http://schemas.openxmlformats.org/drawingml/2006/main"/>
-          <a:lstStyle xmlns:a="http://schemas.openxmlformats.org/drawingml/2006/main"/>
-          <a:p xmlns:a="http://schemas.openxmlformats.org/drawingml/2006/main">
-            <a:pPr algn="l">
-              <a:defRPr sz="923" b="0">
-                <a:solidFill>
-                  <a:srgbClr val="000000"/>
-                </a:solidFill>
-              </a:defRPr>
-            </a:pPr>
-            <a:r>
-              <a:rPr sz="923" b="0">
-                <a:solidFill>
-                  <a:srgbClr val="000000"/>
-                </a:solidFill>
-              </a:rPr>
-              <a:t>clean_master_dataset.parquet</a:t>
-            </a:r>
-          </a:p>
-        </p:txBody>
-      </p:sp>
-      <p:sp>
-        <p:nvSpPr>
-          <p:cNvPr id="8" name="">
-            <a:extLst xmlns:a="http://schemas.openxmlformats.org/drawingml/2006/main">
-              <a:ext uri="{FF2B5EF4-FFF2-40B4-BE49-F238E27FC236}">
-                <a16:creationId xmlns:a16="http://schemas.microsoft.com/office/drawing/2014/main" id="{732120A8-16A4-4FAF-A90F-8B9D747D49DC}"/>
-              </a:ext>
-            </a:extLst>
-          </p:cNvPr>
-          <p:cNvSpPr>
-            <a:spLocks xmlns:a="http://schemas.openxmlformats.org/drawingml/2006/main" noGrp="1"/>
-          </p:cNvSpPr>
-          <p:nvPr/>
-        </p:nvSpPr>
-        <p:spPr>
-          <a:xfrm xmlns:a="http://schemas.openxmlformats.org/drawingml/2006/main">
-            <a:off x="3343275" y="1676400"/>
-            <a:ext cx="2457450" cy="790575"/>
-          </a:xfrm>
-          <a:prstGeom xmlns:a="http://schemas.openxmlformats.org/drawingml/2006/main" prst="rect">
-            <a:avLst/>
-          </a:prstGeom>
-          <a:solidFill xmlns:a="http://schemas.openxmlformats.org/drawingml/2006/main">
-            <a:srgbClr val="FFFFFF"/>
-          </a:solidFill>
-          <a:ln xmlns:a="http://schemas.openxmlformats.org/drawingml/2006/main" w="9525">
-            <a:solidFill>
-              <a:srgbClr val="D7E6F2"/>
-            </a:solidFill>
-            <a:prstDash val="solid"/>
-          </a:ln>
-        </p:spPr>
-      </p:sp>
-      <p:sp>
-        <p:nvSpPr>
-          <p:cNvPr id="9" name="">
-            <a:extLst xmlns:a="http://schemas.openxmlformats.org/drawingml/2006/main">
-              <a:ext uri="{FF2B5EF4-FFF2-40B4-BE49-F238E27FC236}">
-                <a16:creationId xmlns:a16="http://schemas.microsoft.com/office/drawing/2014/main" id="{AAF7B4B4-9963-4404-95AE-33D41EDE86BE}"/>
-              </a:ext>
-            </a:extLst>
-          </p:cNvPr>
-          <p:cNvSpPr>
-            <a:spLocks xmlns:a="http://schemas.openxmlformats.org/drawingml/2006/main" noGrp="1"/>
-          </p:cNvSpPr>
-          <p:nvPr/>
-        </p:nvSpPr>
-        <p:spPr>
-          <a:xfrm xmlns:a="http://schemas.openxmlformats.org/drawingml/2006/main">
-            <a:off x="3343275" y="1676400"/>
-            <a:ext cx="66675" cy="790575"/>
-          </a:xfrm>
-          <a:prstGeom xmlns:a="http://schemas.openxmlformats.org/drawingml/2006/main" prst="rect">
-            <a:avLst/>
-          </a:prstGeom>
-          <a:solidFill xmlns:a="http://schemas.openxmlformats.org/drawingml/2006/main">
-            <a:srgbClr val="64A0C8"/>
-          </a:solidFill>
-          <a:ln xmlns:a="http://schemas.openxmlformats.org/drawingml/2006/main" w="0">
-            <a:noFill/>
-            <a:prstDash val="solid"/>
-          </a:ln>
-        </p:spPr>
-      </p:sp>
-      <p:sp>
-        <p:nvSpPr>
-          <p:cNvPr id="10" name="">
-            <a:extLst xmlns:a="http://schemas.openxmlformats.org/drawingml/2006/main">
-              <a:ext uri="{FF2B5EF4-FFF2-40B4-BE49-F238E27FC236}">
-                <a16:creationId xmlns:a16="http://schemas.microsoft.com/office/drawing/2014/main" id="{C271639E-39B6-4A44-AD71-CF915DAFA671}"/>
-              </a:ext>
-            </a:extLst>
-          </p:cNvPr>
-          <p:cNvSpPr>
-            <a:spLocks xmlns:a="http://schemas.openxmlformats.org/drawingml/2006/main" noGrp="1"/>
-          </p:cNvSpPr>
-          <p:nvPr/>
-        </p:nvSpPr>
-        <p:spPr>
-          <a:xfrm xmlns:a="http://schemas.openxmlformats.org/drawingml/2006/main">
-            <a:off x="3505200" y="1771650"/>
-            <a:ext cx="2190750" cy="190500"/>
-          </a:xfrm>
-          <a:prstGeom xmlns:a="http://schemas.openxmlformats.org/drawingml/2006/main" prst="rect">
-            <a:avLst/>
-          </a:prstGeom>
-          <a:noFill xmlns:a="http://schemas.openxmlformats.org/drawingml/2006/main"/>
-          <a:ln xmlns:a="http://schemas.openxmlformats.org/drawingml/2006/main" w="0">
-            <a:noFill/>
-            <a:prstDash val="solid"/>
-          </a:ln>
-        </p:spPr>
-        <p:txBody>
-          <a:bodyPr xmlns:a="http://schemas.openxmlformats.org/drawingml/2006/main"/>
-          <a:lstStyle xmlns:a="http://schemas.openxmlformats.org/drawingml/2006/main"/>
-          <a:p xmlns:a="http://schemas.openxmlformats.org/drawingml/2006/main">
-            <a:pPr algn="l">
-              <a:defRPr sz="1125" b="1">
-                <a:solidFill>
-                  <a:srgbClr val="005293"/>
-                </a:solidFill>
-              </a:defRPr>
-            </a:pPr>
-            <a:r>
-              <a:rPr sz="1125" b="1">
-                <a:solidFill>
-                  <a:srgbClr val="005293"/>
-                </a:solidFill>
-              </a:rPr>
-              <a:t>2. MDP splits</a:t>
-            </a:r>
-          </a:p>
-        </p:txBody>
-      </p:sp>
-      <p:sp>
-        <p:nvSpPr>
-          <p:cNvPr id="11" name="">
-            <a:extLst xmlns:a="http://schemas.openxmlformats.org/drawingml/2006/main">
-              <a:ext uri="{FF2B5EF4-FFF2-40B4-BE49-F238E27FC236}">
-                <a16:creationId xmlns:a16="http://schemas.microsoft.com/office/drawing/2014/main" id="{821614BE-AC71-4240-947A-51075B976E99}"/>
-              </a:ext>
-            </a:extLst>
-          </p:cNvPr>
-          <p:cNvSpPr>
-            <a:spLocks xmlns:a="http://schemas.openxmlformats.org/drawingml/2006/main" noGrp="1"/>
-          </p:cNvSpPr>
-          <p:nvPr/>
-        </p:nvSpPr>
-        <p:spPr>
-          <a:xfrm xmlns:a="http://schemas.openxmlformats.org/drawingml/2006/main">
-            <a:off x="3505200" y="2009775"/>
-            <a:ext cx="2190750" cy="381000"/>
-          </a:xfrm>
-          <a:prstGeom xmlns:a="http://schemas.openxmlformats.org/drawingml/2006/main" prst="rect">
-            <a:avLst/>
-          </a:prstGeom>
-          <a:noFill xmlns:a="http://schemas.openxmlformats.org/drawingml/2006/main"/>
-          <a:ln xmlns:a="http://schemas.openxmlformats.org/drawingml/2006/main" w="0">
-            <a:noFill/>
-            <a:prstDash val="solid"/>
-          </a:ln>
-        </p:spPr>
-        <p:txBody>
-          <a:bodyPr xmlns:a="http://schemas.openxmlformats.org/drawingml/2006/main"/>
-          <a:lstStyle xmlns:a="http://schemas.openxmlformats.org/drawingml/2006/main"/>
-          <a:p xmlns:a="http://schemas.openxmlformats.org/drawingml/2006/main">
-            <a:pPr algn="l">
-              <a:defRPr sz="923" b="0">
-                <a:solidFill>
-                  <a:srgbClr val="000000"/>
-                </a:solidFill>
-              </a:defRPr>
-            </a:pPr>
-            <a:r>
-              <a:rPr sz="923" b="0">
-                <a:solidFill>
-                  <a:srgbClr val="000000"/>
-                </a:solidFill>
-              </a:rPr>
-              <a:t>data/train.parquet, val.parquet, test.parquet</a:t>
-            </a:r>
-          </a:p>
-          <a:p xmlns:a="http://schemas.openxmlformats.org/drawingml/2006/main">
-            <a:pPr algn="l">
-              <a:defRPr sz="923" b="0">
-                <a:solidFill>
-                  <a:srgbClr val="000000"/>
-                </a:solidFill>
-              </a:defRPr>
-            </a:pPr>
-            <a:r>
-              <a:rPr sz="923" b="0">
-                <a:solidFill>
-                  <a:srgbClr val="000000"/>
-                </a:solidFill>
-              </a:rPr>
-              <a:t>split_summary.csv, preprocess_stats.json</a:t>
-            </a:r>
-          </a:p>
-        </p:txBody>
-      </p:sp>
-      <p:sp>
-        <p:nvSpPr>
-          <p:cNvPr id="12" name="">
-            <a:extLst xmlns:a="http://schemas.openxmlformats.org/drawingml/2006/main">
-              <a:ext uri="{FF2B5EF4-FFF2-40B4-BE49-F238E27FC236}">
-                <a16:creationId xmlns:a16="http://schemas.microsoft.com/office/drawing/2014/main" id="{9BA012F1-6A8A-47C2-9FBD-A9D033017807}"/>
-              </a:ext>
-            </a:extLst>
-          </p:cNvPr>
-          <p:cNvSpPr>
-            <a:spLocks xmlns:a="http://schemas.openxmlformats.org/drawingml/2006/main" noGrp="1"/>
-          </p:cNvSpPr>
-          <p:nvPr/>
-        </p:nvSpPr>
-        <p:spPr>
-          <a:xfrm xmlns:a="http://schemas.openxmlformats.org/drawingml/2006/main">
-            <a:off x="6172200" y="1676400"/>
-            <a:ext cx="2457450" cy="790575"/>
-          </a:xfrm>
-          <a:prstGeom xmlns:a="http://schemas.openxmlformats.org/drawingml/2006/main" prst="rect">
-            <a:avLst/>
-          </a:prstGeom>
-          <a:solidFill xmlns:a="http://schemas.openxmlformats.org/drawingml/2006/main">
-            <a:srgbClr val="FFFFFF"/>
-          </a:solidFill>
-          <a:ln xmlns:a="http://schemas.openxmlformats.org/drawingml/2006/main" w="9525">
-            <a:solidFill>
-              <a:srgbClr val="D7E6F2"/>
-            </a:solidFill>
-            <a:prstDash val="solid"/>
-          </a:ln>
-        </p:spPr>
-      </p:sp>
-      <p:sp>
-        <p:nvSpPr>
-          <p:cNvPr id="13" name="">
-            <a:extLst xmlns:a="http://schemas.openxmlformats.org/drawingml/2006/main">
-              <a:ext uri="{FF2B5EF4-FFF2-40B4-BE49-F238E27FC236}">
-                <a16:creationId xmlns:a16="http://schemas.microsoft.com/office/drawing/2014/main" id="{B215D18D-3942-465F-87D6-A40659A0F721}"/>
-              </a:ext>
-            </a:extLst>
-          </p:cNvPr>
-          <p:cNvSpPr>
-            <a:spLocks xmlns:a="http://schemas.openxmlformats.org/drawingml/2006/main" noGrp="1"/>
-          </p:cNvSpPr>
-          <p:nvPr/>
-        </p:nvSpPr>
-        <p:spPr>
-          <a:xfrm xmlns:a="http://schemas.openxmlformats.org/drawingml/2006/main">
-            <a:off x="6172200" y="1676400"/>
-            <a:ext cx="66675" cy="790575"/>
-          </a:xfrm>
-          <a:prstGeom xmlns:a="http://schemas.openxmlformats.org/drawingml/2006/main" prst="rect">
-            <a:avLst/>
-          </a:prstGeom>
-          <a:solidFill xmlns:a="http://schemas.openxmlformats.org/drawingml/2006/main">
-            <a:srgbClr val="A2AD00"/>
-          </a:solidFill>
-          <a:ln xmlns:a="http://schemas.openxmlformats.org/drawingml/2006/main" w="0">
-            <a:noFill/>
-            <a:prstDash val="solid"/>
-          </a:ln>
-        </p:spPr>
-      </p:sp>
-      <p:sp>
-        <p:nvSpPr>
-          <p:cNvPr id="14" name="">
-            <a:extLst xmlns:a="http://schemas.openxmlformats.org/drawingml/2006/main">
-              <a:ext uri="{FF2B5EF4-FFF2-40B4-BE49-F238E27FC236}">
-                <a16:creationId xmlns:a16="http://schemas.microsoft.com/office/drawing/2014/main" id="{BCD2BC1A-380E-433A-BAA1-330907A4C86C}"/>
-              </a:ext>
-            </a:extLst>
-          </p:cNvPr>
-          <p:cNvSpPr>
-            <a:spLocks xmlns:a="http://schemas.openxmlformats.org/drawingml/2006/main" noGrp="1"/>
-          </p:cNvSpPr>
-          <p:nvPr/>
-        </p:nvSpPr>
-        <p:spPr>
-          <a:xfrm xmlns:a="http://schemas.openxmlformats.org/drawingml/2006/main">
-            <a:off x="6334125" y="1771650"/>
-            <a:ext cx="2190750" cy="190500"/>
-          </a:xfrm>
-          <a:prstGeom xmlns:a="http://schemas.openxmlformats.org/drawingml/2006/main" prst="rect">
-            <a:avLst/>
-          </a:prstGeom>
-          <a:noFill xmlns:a="http://schemas.openxmlformats.org/drawingml/2006/main"/>
-          <a:ln xmlns:a="http://schemas.openxmlformats.org/drawingml/2006/main" w="0">
-            <a:noFill/>
-            <a:prstDash val="solid"/>
-          </a:ln>
-        </p:spPr>
-        <p:txBody>
-          <a:bodyPr xmlns:a="http://schemas.openxmlformats.org/drawingml/2006/main"/>
-          <a:lstStyle xmlns:a="http://schemas.openxmlformats.org/drawingml/2006/main"/>
-          <a:p xmlns:a="http://schemas.openxmlformats.org/drawingml/2006/main">
-            <a:pPr algn="l">
-              <a:defRPr sz="1125" b="1">
-                <a:solidFill>
-                  <a:srgbClr val="005293"/>
-                </a:solidFill>
-              </a:defRPr>
-            </a:pPr>
-            <a:r>
-              <a:rPr sz="1125" b="1">
-                <a:solidFill>
-                  <a:srgbClr val="005293"/>
-                </a:solidFill>
-              </a:rPr>
-              <a:t>3. Trained models</a:t>
-            </a:r>
-          </a:p>
-        </p:txBody>
-      </p:sp>
-      <p:sp>
-        <p:nvSpPr>
-          <p:cNvPr id="15" name="">
-            <a:extLst xmlns:a="http://schemas.openxmlformats.org/drawingml/2006/main">
-              <a:ext uri="{FF2B5EF4-FFF2-40B4-BE49-F238E27FC236}">
-                <a16:creationId xmlns:a16="http://schemas.microsoft.com/office/drawing/2014/main" id="{E7EEBE91-7615-4423-8838-3FF0E394C5EB}"/>
-              </a:ext>
-            </a:extLst>
-          </p:cNvPr>
-          <p:cNvSpPr>
-            <a:spLocks xmlns:a="http://schemas.openxmlformats.org/drawingml/2006/main" noGrp="1"/>
-          </p:cNvSpPr>
-          <p:nvPr/>
-        </p:nvSpPr>
-        <p:spPr>
-          <a:xfrm xmlns:a="http://schemas.openxmlformats.org/drawingml/2006/main">
-            <a:off x="6334125" y="2009775"/>
-            <a:ext cx="2190750" cy="381000"/>
-          </a:xfrm>
-          <a:prstGeom xmlns:a="http://schemas.openxmlformats.org/drawingml/2006/main" prst="rect">
-            <a:avLst/>
-          </a:prstGeom>
-          <a:noFill xmlns:a="http://schemas.openxmlformats.org/drawingml/2006/main"/>
-          <a:ln xmlns:a="http://schemas.openxmlformats.org/drawingml/2006/main" w="0">
-            <a:noFill/>
-            <a:prstDash val="solid"/>
-          </a:ln>
-        </p:spPr>
-        <p:txBody>
-          <a:bodyPr xmlns:a="http://schemas.openxmlformats.org/drawingml/2006/main"/>
-          <a:lstStyle xmlns:a="http://schemas.openxmlformats.org/drawingml/2006/main"/>
-          <a:p xmlns:a="http://schemas.openxmlformats.org/drawingml/2006/main">
-            <a:pPr algn="l">
-              <a:defRPr sz="923" b="0">
-                <a:solidFill>
-                  <a:srgbClr val="000000"/>
-                </a:solidFill>
-              </a:defRPr>
-            </a:pPr>
-            <a:r>
-              <a:rPr sz="923" b="0">
-                <a:solidFill>
-                  <a:srgbClr val="000000"/>
-                </a:solidFill>
-              </a:rPr>
-              <a:t>deal_classifier.ubj, cql_best.pt,</a:t>
-            </a:r>
-          </a:p>
-          <a:p xmlns:a="http://schemas.openxmlformats.org/drawingml/2006/main">
-            <a:pPr algn="l">
-              <a:defRPr sz="923" b="0">
-                <a:solidFill>
-                  <a:srgbClr val="000000"/>
-                </a:solidFill>
-              </a:defRPr>
-            </a:pPr>
-            <a:r>
-              <a:rPr sz="923" b="0">
-                <a:solidFill>
-                  <a:srgbClr val="000000"/>
-                </a:solidFill>
-              </a:rPr>
-              <a:t>cql_scaler.pkl, ppo_best_faithful.pt</a:t>
-            </a:r>
-          </a:p>
-        </p:txBody>
-      </p:sp>
-      <p:sp>
-        <p:nvSpPr>
-          <p:cNvPr id="16" name="">
-            <a:extLst xmlns:a="http://schemas.openxmlformats.org/drawingml/2006/main">
-              <a:ext uri="{FF2B5EF4-FFF2-40B4-BE49-F238E27FC236}">
-                <a16:creationId xmlns:a16="http://schemas.microsoft.com/office/drawing/2014/main" id="{95EE70FD-D108-4183-9B99-F4E5D0B85DAF}"/>
-              </a:ext>
-            </a:extLst>
-          </p:cNvPr>
-          <p:cNvSpPr>
-            <a:spLocks xmlns:a="http://schemas.openxmlformats.org/drawingml/2006/main" noGrp="1"/>
-          </p:cNvSpPr>
-          <p:nvPr/>
-        </p:nvSpPr>
-        <p:spPr>
-          <a:xfrm xmlns:a="http://schemas.openxmlformats.org/drawingml/2006/main">
-            <a:off x="514350" y="2790825"/>
-            <a:ext cx="3876675" cy="790575"/>
-          </a:xfrm>
-          <a:prstGeom xmlns:a="http://schemas.openxmlformats.org/drawingml/2006/main" prst="rect">
-            <a:avLst/>
-          </a:prstGeom>
-          <a:solidFill xmlns:a="http://schemas.openxmlformats.org/drawingml/2006/main">
-            <a:srgbClr val="FFFFFF"/>
-          </a:solidFill>
-          <a:ln xmlns:a="http://schemas.openxmlformats.org/drawingml/2006/main" w="9525">
-            <a:solidFill>
-              <a:srgbClr val="D7E6F2"/>
-            </a:solidFill>
-            <a:prstDash val="solid"/>
-          </a:ln>
-        </p:spPr>
-      </p:sp>
-      <p:sp>
-        <p:nvSpPr>
-          <p:cNvPr id="17" name="">
-            <a:extLst xmlns:a="http://schemas.openxmlformats.org/drawingml/2006/main">
-              <a:ext uri="{FF2B5EF4-FFF2-40B4-BE49-F238E27FC236}">
-                <a16:creationId xmlns:a16="http://schemas.microsoft.com/office/drawing/2014/main" id="{78204229-7734-49C0-A3D0-D0777AACF37F}"/>
-              </a:ext>
-            </a:extLst>
-          </p:cNvPr>
-          <p:cNvSpPr>
-            <a:spLocks xmlns:a="http://schemas.openxmlformats.org/drawingml/2006/main" noGrp="1"/>
-          </p:cNvSpPr>
-          <p:nvPr/>
-        </p:nvSpPr>
-        <p:spPr>
-          <a:xfrm xmlns:a="http://schemas.openxmlformats.org/drawingml/2006/main">
-            <a:off x="514350" y="2790825"/>
-            <a:ext cx="66675" cy="790575"/>
-          </a:xfrm>
-          <a:prstGeom xmlns:a="http://schemas.openxmlformats.org/drawingml/2006/main" prst="rect">
-            <a:avLst/>
-          </a:prstGeom>
-          <a:solidFill xmlns:a="http://schemas.openxmlformats.org/drawingml/2006/main">
-            <a:srgbClr val="005293"/>
-          </a:solidFill>
-          <a:ln xmlns:a="http://schemas.openxmlformats.org/drawingml/2006/main" w="0">
-            <a:noFill/>
-            <a:prstDash val="solid"/>
-          </a:ln>
-        </p:spPr>
-      </p:sp>
-      <p:sp>
-        <p:nvSpPr>
-          <p:cNvPr id="18" name="">
-            <a:extLst xmlns:a="http://schemas.openxmlformats.org/drawingml/2006/main">
-              <a:ext uri="{FF2B5EF4-FFF2-40B4-BE49-F238E27FC236}">
-                <a16:creationId xmlns:a16="http://schemas.microsoft.com/office/drawing/2014/main" id="{1FA5A17F-EF36-42B0-B324-0AF725D10B78}"/>
-              </a:ext>
-            </a:extLst>
-          </p:cNvPr>
-          <p:cNvSpPr>
-            <a:spLocks xmlns:a="http://schemas.openxmlformats.org/drawingml/2006/main" noGrp="1"/>
-          </p:cNvSpPr>
-          <p:nvPr/>
-        </p:nvSpPr>
-        <p:spPr>
-          <a:xfrm xmlns:a="http://schemas.openxmlformats.org/drawingml/2006/main">
-            <a:off x="676275" y="2886075"/>
-            <a:ext cx="3609975" cy="190500"/>
-          </a:xfrm>
-          <a:prstGeom xmlns:a="http://schemas.openxmlformats.org/drawingml/2006/main" prst="rect">
-            <a:avLst/>
-          </a:prstGeom>
-          <a:noFill xmlns:a="http://schemas.openxmlformats.org/drawingml/2006/main"/>
-          <a:ln xmlns:a="http://schemas.openxmlformats.org/drawingml/2006/main" w="0">
-            <a:noFill/>
-            <a:prstDash val="solid"/>
-          </a:ln>
-        </p:spPr>
-        <p:txBody>
-          <a:bodyPr xmlns:a="http://schemas.openxmlformats.org/drawingml/2006/main"/>
-          <a:lstStyle xmlns:a="http://schemas.openxmlformats.org/drawingml/2006/main"/>
-          <a:p xmlns:a="http://schemas.openxmlformats.org/drawingml/2006/main">
-            <a:pPr algn="l">
-              <a:defRPr sz="1125" b="1">
-                <a:solidFill>
-                  <a:srgbClr val="005293"/>
-                </a:solidFill>
-              </a:defRPr>
-            </a:pPr>
-            <a:r>
-              <a:rPr sz="1125" b="1">
-                <a:solidFill>
-                  <a:srgbClr val="005293"/>
-                </a:solidFill>
-              </a:rPr>
-              <a:t>4. Evaluation outputs</a:t>
-            </a:r>
-          </a:p>
-        </p:txBody>
-      </p:sp>
-      <p:sp>
-        <p:nvSpPr>
-          <p:cNvPr id="19" name="">
-            <a:extLst xmlns:a="http://schemas.openxmlformats.org/drawingml/2006/main">
-              <a:ext uri="{FF2B5EF4-FFF2-40B4-BE49-F238E27FC236}">
-                <a16:creationId xmlns:a16="http://schemas.microsoft.com/office/drawing/2014/main" id="{71254B44-B0AB-4E33-83A1-E9EC5950D232}"/>
-              </a:ext>
-            </a:extLst>
-          </p:cNvPr>
-          <p:cNvSpPr>
-            <a:spLocks xmlns:a="http://schemas.openxmlformats.org/drawingml/2006/main" noGrp="1"/>
-          </p:cNvSpPr>
-          <p:nvPr/>
-        </p:nvSpPr>
-        <p:spPr>
-          <a:xfrm xmlns:a="http://schemas.openxmlformats.org/drawingml/2006/main">
-            <a:off x="676275" y="3124200"/>
-            <a:ext cx="3609975" cy="381000"/>
-          </a:xfrm>
-          <a:prstGeom xmlns:a="http://schemas.openxmlformats.org/drawingml/2006/main" prst="rect">
-            <a:avLst/>
-          </a:prstGeom>
-          <a:noFill xmlns:a="http://schemas.openxmlformats.org/drawingml/2006/main"/>
-          <a:ln xmlns:a="http://schemas.openxmlformats.org/drawingml/2006/main" w="0">
-            <a:noFill/>
-            <a:prstDash val="solid"/>
-          </a:ln>
-        </p:spPr>
-        <p:txBody>
-          <a:bodyPr xmlns:a="http://schemas.openxmlformats.org/drawingml/2006/main"/>
-          <a:lstStyle xmlns:a="http://schemas.openxmlformats.org/drawingml/2006/main"/>
-          <a:p xmlns:a="http://schemas.openxmlformats.org/drawingml/2006/main">
-            <a:pPr algn="l">
-              <a:defRPr sz="923" b="0">
-                <a:solidFill>
-                  <a:srgbClr val="000000"/>
-                </a:solidFill>
-              </a:defRPr>
-            </a:pPr>
-            <a:r>
-              <a:rPr sz="923" b="0">
-                <a:solidFill>
-                  <a:srgbClr val="000000"/>
-                </a:solidFill>
-              </a:rPr>
-              <a:t>policy_comparison.csv, ope_policy_eval.csv,</a:t>
-            </a:r>
-          </a:p>
-          <a:p xmlns:a="http://schemas.openxmlformats.org/drawingml/2006/main">
-            <a:pPr algn="l">
-              <a:defRPr sz="923" b="0">
-                <a:solidFill>
-                  <a:srgbClr val="000000"/>
-                </a:solidFill>
-              </a:defRPr>
-            </a:pPr>
-            <a:r>
-              <a:rPr sz="923" b="0">
-                <a:solidFill>
-                  <a:srgbClr val="000000"/>
-                </a:solidFill>
-              </a:rPr>
-              <a:t>ope_weight_diagnostics.csv, ope_summary.json</a:t>
-            </a:r>
-          </a:p>
-        </p:txBody>
-      </p:sp>
-      <p:sp>
-        <p:nvSpPr>
-          <p:cNvPr id="20" name="">
-            <a:extLst xmlns:a="http://schemas.openxmlformats.org/drawingml/2006/main">
-              <a:ext uri="{FF2B5EF4-FFF2-40B4-BE49-F238E27FC236}">
-                <a16:creationId xmlns:a16="http://schemas.microsoft.com/office/drawing/2014/main" id="{AF0B470A-BACA-42E6-BA82-9ACA56A61FDD}"/>
-              </a:ext>
-            </a:extLst>
-          </p:cNvPr>
-          <p:cNvSpPr>
-            <a:spLocks xmlns:a="http://schemas.openxmlformats.org/drawingml/2006/main" noGrp="1"/>
-          </p:cNvSpPr>
-          <p:nvPr/>
-        </p:nvSpPr>
-        <p:spPr>
-          <a:xfrm xmlns:a="http://schemas.openxmlformats.org/drawingml/2006/main">
-            <a:off x="4752975" y="2790825"/>
-            <a:ext cx="3876675" cy="790575"/>
-          </a:xfrm>
-          <a:prstGeom xmlns:a="http://schemas.openxmlformats.org/drawingml/2006/main" prst="rect">
-            <a:avLst/>
-          </a:prstGeom>
-          <a:solidFill xmlns:a="http://schemas.openxmlformats.org/drawingml/2006/main">
-            <a:srgbClr val="FFFFFF"/>
-          </a:solidFill>
-          <a:ln xmlns:a="http://schemas.openxmlformats.org/drawingml/2006/main" w="9525">
-            <a:solidFill>
-              <a:srgbClr val="D7E6F2"/>
-            </a:solidFill>
-            <a:prstDash val="solid"/>
-          </a:ln>
-        </p:spPr>
-      </p:sp>
-      <p:sp>
-        <p:nvSpPr>
-          <p:cNvPr id="21" name="">
-            <a:extLst xmlns:a="http://schemas.openxmlformats.org/drawingml/2006/main">
-              <a:ext uri="{FF2B5EF4-FFF2-40B4-BE49-F238E27FC236}">
-                <a16:creationId xmlns:a16="http://schemas.microsoft.com/office/drawing/2014/main" id="{FD07B89D-C885-4028-B11F-E6F05A918C96}"/>
-              </a:ext>
-            </a:extLst>
-          </p:cNvPr>
-          <p:cNvSpPr>
-            <a:spLocks xmlns:a="http://schemas.openxmlformats.org/drawingml/2006/main" noGrp="1"/>
-          </p:cNvSpPr>
-          <p:nvPr/>
-        </p:nvSpPr>
-        <p:spPr>
-          <a:xfrm xmlns:a="http://schemas.openxmlformats.org/drawingml/2006/main">
-            <a:off x="4752975" y="2790825"/>
-            <a:ext cx="66675" cy="790575"/>
-          </a:xfrm>
-          <a:prstGeom xmlns:a="http://schemas.openxmlformats.org/drawingml/2006/main" prst="rect">
-            <a:avLst/>
-          </a:prstGeom>
-          <a:solidFill xmlns:a="http://schemas.openxmlformats.org/drawingml/2006/main">
-            <a:srgbClr val="64A0C8"/>
-          </a:solidFill>
-          <a:ln xmlns:a="http://schemas.openxmlformats.org/drawingml/2006/main" w="0">
-            <a:noFill/>
-            <a:prstDash val="solid"/>
-          </a:ln>
-        </p:spPr>
-      </p:sp>
-      <p:sp>
-        <p:nvSpPr>
-          <p:cNvPr id="22" name="">
-            <a:extLst xmlns:a="http://schemas.openxmlformats.org/drawingml/2006/main">
-              <a:ext uri="{FF2B5EF4-FFF2-40B4-BE49-F238E27FC236}">
-                <a16:creationId xmlns:a16="http://schemas.microsoft.com/office/drawing/2014/main" id="{956AACE2-234F-4772-B555-9AF0DEC24015}"/>
-              </a:ext>
-            </a:extLst>
-          </p:cNvPr>
-          <p:cNvSpPr>
-            <a:spLocks xmlns:a="http://schemas.openxmlformats.org/drawingml/2006/main" noGrp="1"/>
-          </p:cNvSpPr>
-          <p:nvPr/>
-        </p:nvSpPr>
-        <p:spPr>
-          <a:xfrm xmlns:a="http://schemas.openxmlformats.org/drawingml/2006/main">
-            <a:off x="4914900" y="2886075"/>
-            <a:ext cx="3609975" cy="190500"/>
-          </a:xfrm>
-          <a:prstGeom xmlns:a="http://schemas.openxmlformats.org/drawingml/2006/main" prst="rect">
-            <a:avLst/>
-          </a:prstGeom>
-          <a:noFill xmlns:a="http://schemas.openxmlformats.org/drawingml/2006/main"/>
-          <a:ln xmlns:a="http://schemas.openxmlformats.org/drawingml/2006/main" w="0">
-            <a:noFill/>
-            <a:prstDash val="solid"/>
-          </a:ln>
-        </p:spPr>
-        <p:txBody>
-          <a:bodyPr xmlns:a="http://schemas.openxmlformats.org/drawingml/2006/main"/>
-          <a:lstStyle xmlns:a="http://schemas.openxmlformats.org/drawingml/2006/main"/>
-          <a:p xmlns:a="http://schemas.openxmlformats.org/drawingml/2006/main">
-            <a:pPr algn="l">
-              <a:defRPr sz="1125" b="1">
-                <a:solidFill>
-                  <a:srgbClr val="005293"/>
-                </a:solidFill>
-              </a:defRPr>
-            </a:pPr>
-            <a:r>
-              <a:rPr sz="1125" b="1">
-                <a:solidFill>
-                  <a:srgbClr val="005293"/>
-                </a:solidFill>
-              </a:rPr>
-              <a:t>5. Recommendation outputs</a:t>
-            </a:r>
-          </a:p>
-        </p:txBody>
-      </p:sp>
-      <p:sp>
-        <p:nvSpPr>
-          <p:cNvPr id="23" name="">
-            <a:extLst xmlns:a="http://schemas.openxmlformats.org/drawingml/2006/main">
-              <a:ext uri="{FF2B5EF4-FFF2-40B4-BE49-F238E27FC236}">
-                <a16:creationId xmlns:a16="http://schemas.microsoft.com/office/drawing/2014/main" id="{E600B103-4AA2-4A4C-8B26-C9BD014C830E}"/>
-              </a:ext>
-            </a:extLst>
-          </p:cNvPr>
-          <p:cNvSpPr>
-            <a:spLocks xmlns:a="http://schemas.openxmlformats.org/drawingml/2006/main" noGrp="1"/>
-          </p:cNvSpPr>
-          <p:nvPr/>
-        </p:nvSpPr>
-        <p:spPr>
-          <a:xfrm xmlns:a="http://schemas.openxmlformats.org/drawingml/2006/main">
-            <a:off x="4914900" y="3124200"/>
-            <a:ext cx="3609975" cy="381000"/>
-          </a:xfrm>
-          <a:prstGeom xmlns:a="http://schemas.openxmlformats.org/drawingml/2006/main" prst="rect">
-            <a:avLst/>
-          </a:prstGeom>
-          <a:noFill xmlns:a="http://schemas.openxmlformats.org/drawingml/2006/main"/>
-          <a:ln xmlns:a="http://schemas.openxmlformats.org/drawingml/2006/main" w="0">
-            <a:noFill/>
-            <a:prstDash val="solid"/>
-          </a:ln>
-        </p:spPr>
-        <p:txBody>
-          <a:bodyPr xmlns:a="http://schemas.openxmlformats.org/drawingml/2006/main"/>
-          <a:lstStyle xmlns:a="http://schemas.openxmlformats.org/drawingml/2006/main"/>
-          <a:p xmlns:a="http://schemas.openxmlformats.org/drawingml/2006/main">
-            <a:pPr algn="l">
-              <a:defRPr sz="923" b="0">
-                <a:solidFill>
-                  <a:srgbClr val="000000"/>
-                </a:solidFill>
-              </a:defRPr>
-            </a:pPr>
-            <a:r>
-              <a:rPr sz="923" b="0">
-                <a:solidFill>
-                  <a:srgbClr val="000000"/>
-                </a:solidFill>
-              </a:rPr>
-              <a:t>offer_recommendations.csv</a:t>
-            </a:r>
-          </a:p>
-          <a:p xmlns:a="http://schemas.openxmlformats.org/drawingml/2006/main">
-            <a:pPr algn="l">
-              <a:defRPr sz="923" b="0">
-                <a:solidFill>
-                  <a:srgbClr val="000000"/>
-                </a:solidFill>
-              </a:defRPr>
-            </a:pPr>
-            <a:r>
-              <a:rPr sz="923" b="0">
-                <a:solidFill>
-                  <a:srgbClr val="000000"/>
-                </a:solidFill>
-              </a:rPr>
-              <a:t>single-listing menus from recommend_one.py</a:t>
-            </a:r>
-          </a:p>
-        </p:txBody>
-      </p:sp>
-      <p:sp>
-        <p:nvSpPr>
-          <p:cNvPr id="24" name="">
-            <a:extLst xmlns:a="http://schemas.openxmlformats.org/drawingml/2006/main">
-              <a:ext uri="{FF2B5EF4-FFF2-40B4-BE49-F238E27FC236}">
-                <a16:creationId xmlns:a16="http://schemas.microsoft.com/office/drawing/2014/main" id="{CB6B5882-6416-4348-A869-AA11F8FFBC4F}"/>
-              </a:ext>
-            </a:extLst>
-          </p:cNvPr>
-          <p:cNvSpPr>
-            <a:spLocks xmlns:a="http://schemas.openxmlformats.org/drawingml/2006/main" noGrp="1"/>
-          </p:cNvSpPr>
-          <p:nvPr/>
-        </p:nvSpPr>
-        <p:spPr>
-          <a:xfrm xmlns:a="http://schemas.openxmlformats.org/drawingml/2006/main">
-            <a:off x="514350" y="4000500"/>
-            <a:ext cx="8115300" cy="590550"/>
-          </a:xfrm>
-          <a:prstGeom xmlns:a="http://schemas.openxmlformats.org/drawingml/2006/main" prst="rect">
-            <a:avLst/>
-          </a:prstGeom>
-          <a:solidFill xmlns:a="http://schemas.openxmlformats.org/drawingml/2006/main">
-            <a:srgbClr val="EAF3FA"/>
-          </a:solidFill>
-          <a:ln xmlns:a="http://schemas.openxmlformats.org/drawingml/2006/main" w="9525">
-            <a:solidFill>
-              <a:srgbClr val="C7DDEC"/>
-            </a:solidFill>
-            <a:prstDash val="solid"/>
-          </a:ln>
-        </p:spPr>
-      </p:sp>
-      <p:sp>
-        <p:nvSpPr>
-          <p:cNvPr id="25" name="">
-            <a:extLst xmlns:a="http://schemas.openxmlformats.org/drawingml/2006/main">
-              <a:ext uri="{FF2B5EF4-FFF2-40B4-BE49-F238E27FC236}">
-                <a16:creationId xmlns:a16="http://schemas.microsoft.com/office/drawing/2014/main" id="{D14C4C11-9F92-4663-B715-5767CDFE6282}"/>
-              </a:ext>
-            </a:extLst>
-          </p:cNvPr>
-          <p:cNvSpPr>
-            <a:spLocks xmlns:a="http://schemas.openxmlformats.org/drawingml/2006/main" noGrp="1"/>
-          </p:cNvSpPr>
-          <p:nvPr/>
-        </p:nvSpPr>
-        <p:spPr>
-          <a:xfrm xmlns:a="http://schemas.openxmlformats.org/drawingml/2006/main">
-            <a:off x="742950" y="4181475"/>
-            <a:ext cx="7658100" cy="247650"/>
-          </a:xfrm>
-          <a:prstGeom xmlns:a="http://schemas.openxmlformats.org/drawingml/2006/main" prst="rect">
-            <a:avLst/>
-          </a:prstGeom>
-          <a:noFill xmlns:a="http://schemas.openxmlformats.org/drawingml/2006/main"/>
-          <a:ln xmlns:a="http://schemas.openxmlformats.org/drawingml/2006/main" w="0">
-            <a:noFill/>
-            <a:prstDash val="solid"/>
-          </a:ln>
-        </p:spPr>
-        <p:txBody>
-          <a:bodyPr xmlns:a="http://schemas.openxmlformats.org/drawingml/2006/main"/>
-          <a:lstStyle xmlns:a="http://schemas.openxmlformats.org/drawingml/2006/main"/>
-          <a:p xmlns:a="http://schemas.openxmlformats.org/drawingml/2006/main">
-            <a:pPr algn="ctr">
-              <a:defRPr sz="1140" b="1">
-                <a:solidFill>
-                  <a:srgbClr val="005293"/>
-                </a:solidFill>
-              </a:defRPr>
-            </a:pPr>
-            <a:r>
-              <a:rPr sz="1140" b="1">
-                <a:solidFill>
-                  <a:srgbClr val="005293"/>
-                </a:solidFill>
-              </a:rPr>
-              <a:t>Tracked final deliverables: technical_report.md/.pdf, results dashboard figure, and this presentation deck.</a:t>
-            </a:r>
-          </a:p>
-        </p:txBody>
-      </p:sp>
-      <p:sp>
-        <p:nvSpPr>
-          <p:cNvPr id="26" name="">
-            <a:extLst xmlns:a="http://schemas.openxmlformats.org/drawingml/2006/main">
-              <a:ext uri="{FF2B5EF4-FFF2-40B4-BE49-F238E27FC236}">
-                <a16:creationId xmlns:a16="http://schemas.microsoft.com/office/drawing/2014/main" id="{D4ED4CC9-DC87-4666-8FD5-2061BB0338C3}"/>
-              </a:ext>
-            </a:extLst>
-          </p:cNvPr>
-          <p:cNvSpPr>
-            <a:spLocks xmlns:a="http://schemas.openxmlformats.org/drawingml/2006/main" noGrp="1"/>
-          </p:cNvSpPr>
-          <p:nvPr/>
-        </p:nvSpPr>
-        <p:spPr>
-          <a:xfrm xmlns:a="http://schemas.openxmlformats.org/drawingml/2006/main">
-            <a:off x="304800" y="4857750"/>
-            <a:ext cx="6191250" cy="228600"/>
-          </a:xfrm>
-          <a:prstGeom xmlns:a="http://schemas.openxmlformats.org/drawingml/2006/main" prst="rect">
-            <a:avLst/>
-          </a:prstGeom>
-          <a:noFill xmlns:a="http://schemas.openxmlformats.org/drawingml/2006/main"/>
-          <a:ln xmlns:a="http://schemas.openxmlformats.org/drawingml/2006/main" w="0">
-            <a:noFill/>
-            <a:prstDash val="solid"/>
-          </a:ln>
-        </p:spPr>
-        <p:txBody>
-          <a:bodyPr xmlns:a="http://schemas.openxmlformats.org/drawingml/2006/main"/>
-          <a:lstStyle xmlns:a="http://schemas.openxmlformats.org/drawingml/2006/main"/>
-          <a:p xmlns:a="http://schemas.openxmlformats.org/drawingml/2006/main">
-            <a:pPr algn="l">
-              <a:defRPr sz="1102" b="0">
-                <a:solidFill>
-                  <a:srgbClr val="000000"/>
-                </a:solidFill>
-              </a:defRPr>
-            </a:pPr>
-            <a:r>
-              <a:rPr sz="1102" b="0">
-                <a:solidFill>
-                  <a:srgbClr val="000000"/>
-                </a:solidFill>
-              </a:rPr>
-              <a:t>eBay Best Offer anchoring RL | Advanced Seminar (WIHN0043SE)</a:t>
-            </a:r>
-          </a:p>
-        </p:txBody>
-      </p:sp>
-      <p:sp>
-        <p:nvSpPr>
-          <p:cNvPr id="27" name="">
-            <a:extLst xmlns:a="http://schemas.openxmlformats.org/drawingml/2006/main">
-              <a:ext uri="{FF2B5EF4-FFF2-40B4-BE49-F238E27FC236}">
-                <a16:creationId xmlns:a16="http://schemas.microsoft.com/office/drawing/2014/main" id="{6C8C6AD7-06A6-4963-AD76-9CED3F4C5F84}"/>
-              </a:ext>
-            </a:extLst>
-          </p:cNvPr>
-          <p:cNvSpPr>
-            <a:spLocks xmlns:a="http://schemas.openxmlformats.org/drawingml/2006/main" noGrp="1"/>
-          </p:cNvSpPr>
-          <p:nvPr/>
-        </p:nvSpPr>
-        <p:spPr>
-          <a:xfrm xmlns:a="http://schemas.openxmlformats.org/drawingml/2006/main">
-            <a:off x="7810500" y="4857750"/>
-            <a:ext cx="1009650" cy="228600"/>
-          </a:xfrm>
-          <a:prstGeom xmlns:a="http://schemas.openxmlformats.org/drawingml/2006/main" prst="rect">
-            <a:avLst/>
-          </a:prstGeom>
-          <a:noFill xmlns:a="http://schemas.openxmlformats.org/drawingml/2006/main"/>
-          <a:ln xmlns:a="http://schemas.openxmlformats.org/drawingml/2006/main" w="0">
-            <a:noFill/>
-            <a:prstDash val="solid"/>
-          </a:ln>
-        </p:spPr>
-        <p:txBody>
-          <a:bodyPr xmlns:a="http://schemas.openxmlformats.org/drawingml/2006/main"/>
-          <a:lstStyle xmlns:a="http://schemas.openxmlformats.org/drawingml/2006/main"/>
-          <a:p xmlns:a="http://schemas.openxmlformats.org/drawingml/2006/main">
-            <a:pPr algn="r">
-              <a:defRPr sz="1102" b="0">
-                <a:solidFill>
-                  <a:srgbClr val="000000"/>
-                </a:solidFill>
-              </a:defRPr>
-            </a:pPr>
-            <a:r>
-              <a:rPr sz="1102" b="0">
-                <a:solidFill>
-                  <a:srgbClr val="000000"/>
-                </a:solidFill>
-              </a:rPr>
-              <a:t>15</a:t>
-            </a:r>
-          </a:p>
-        </p:txBody>
-      </p:sp>
-    </p:spTree>
-    <p:extLst>
-      <p:ext uri="{BB962C8B-B14F-4D97-AF65-F5344CB8AC3E}">
-        <p14:creationId xmlns:p14="http://schemas.microsoft.com/office/powerpoint/2010/main" val="1637574051"/>
       </p:ext>
     </p:extLst>
   </p:cSld>
@@ -10666,7 +9367,7 @@
           <p:nvPr/>
         </p:nvPicPr>
         <p:blipFill>
-          <a:blip xmlns:r="http://schemas.openxmlformats.org/officeDocument/2006/relationships" xmlns:a="http://schemas.openxmlformats.org/drawingml/2006/main" r:embed="Reb9b0537ef0841ec"/>
+          <a:blip xmlns:r="http://schemas.openxmlformats.org/officeDocument/2006/relationships" xmlns:a="http://schemas.openxmlformats.org/drawingml/2006/main" r:embed="R6454c11476164e1e"/>
           <a:stretch xmlns:a="http://schemas.openxmlformats.org/drawingml/2006/main">
             <a:fillRect l="0" t="0" r="0" b="0"/>
           </a:stretch>
@@ -10962,7 +9663,7 @@
           <p:nvPr/>
         </p:nvPicPr>
         <p:blipFill>
-          <a:blip xmlns:r="http://schemas.openxmlformats.org/officeDocument/2006/relationships" xmlns:a="http://schemas.openxmlformats.org/drawingml/2006/main" r:embed="R8334ccdc9af64609"/>
+          <a:blip xmlns:r="http://schemas.openxmlformats.org/officeDocument/2006/relationships" xmlns:a="http://schemas.openxmlformats.org/drawingml/2006/main" r:embed="Rc1c06ea4198f4c46"/>
           <a:stretch xmlns:a="http://schemas.openxmlformats.org/drawingml/2006/main">
             <a:fillRect l="0" t="0" r="0" b="0"/>
           </a:stretch>
@@ -11284,7 +9985,7 @@
         </p:xfrm>
         <a:graphic xmlns:a="http://schemas.openxmlformats.org/drawingml/2006/main">
           <a:graphicData uri="http://schemas.openxmlformats.org/drawingml/2006/chart">
-            <c:chart xmlns:r="http://schemas.openxmlformats.org/officeDocument/2006/relationships" xmlns:c="http://schemas.openxmlformats.org/drawingml/2006/chart" r:id="Re61742e8892b470e"/>
+            <c:chart xmlns:r="http://schemas.openxmlformats.org/officeDocument/2006/relationships" xmlns:c="http://schemas.openxmlformats.org/drawingml/2006/chart" r:id="Ra8cb33024dda46c7"/>
           </a:graphicData>
         </a:graphic>
       </p:graphicFrame>
@@ -11369,7 +10070,7 @@
           <p:nvPr/>
         </p:nvPicPr>
         <p:blipFill>
-          <a:blip xmlns:r="http://schemas.openxmlformats.org/officeDocument/2006/relationships" xmlns:a="http://schemas.openxmlformats.org/drawingml/2006/main" r:embed="R0da98654db0f421d"/>
+          <a:blip xmlns:r="http://schemas.openxmlformats.org/officeDocument/2006/relationships" xmlns:a="http://schemas.openxmlformats.org/drawingml/2006/main" r:embed="R974b91b9d8904609"/>
           <a:stretch xmlns:a="http://schemas.openxmlformats.org/drawingml/2006/main">
             <a:fillRect l="0" t="0" r="0" b="0"/>
           </a:stretch>
@@ -11841,7 +10542,7 @@
           <p:nvPr/>
         </p:nvPicPr>
         <p:blipFill>
-          <a:blip xmlns:r="http://schemas.openxmlformats.org/officeDocument/2006/relationships" xmlns:a="http://schemas.openxmlformats.org/drawingml/2006/main" r:embed="Rd1a164f5355440db"/>
+          <a:blip xmlns:r="http://schemas.openxmlformats.org/officeDocument/2006/relationships" xmlns:a="http://schemas.openxmlformats.org/drawingml/2006/main" r:embed="Rdc66e2e15bc3411d"/>
           <a:stretch xmlns:a="http://schemas.openxmlformats.org/drawingml/2006/main">
             <a:fillRect l="0" t="0" r="0" b="0"/>
           </a:stretch>
@@ -12051,7 +10752,7 @@
                 <a:ea typeface="Arial"/>
                 <a:cs typeface="Arial"/>
               </a:rPr>
-              <a:t>From 9.6M logged offers to a support-aware comparison</a:t>
+              <a:t>From 5.71M valid opening offers to a support-aware comparison</a:t>
             </a:r>
           </a:p>
         </p:txBody>
@@ -12137,7 +10838,7 @@
           <p:nvPr/>
         </p:nvPicPr>
         <p:blipFill>
-          <a:blip xmlns:r="http://schemas.openxmlformats.org/officeDocument/2006/relationships" xmlns:a="http://schemas.openxmlformats.org/drawingml/2006/main" r:embed="R3f98a67ee7b8435a"/>
+          <a:blip xmlns:r="http://schemas.openxmlformats.org/officeDocument/2006/relationships" xmlns:a="http://schemas.openxmlformats.org/drawingml/2006/main" r:embed="Reefe3a392f764195"/>
           <a:stretch xmlns:a="http://schemas.openxmlformats.org/drawingml/2006/main">
             <a:fillRect l="0" t="0" r="0" b="0"/>
           </a:stretch>
@@ -12797,7 +11498,7 @@
                 <a:ea typeface="Arial"/>
                 <a:cs typeface="Arial"/>
               </a:rPr>
-              <a:t>7.67M</a:t>
+              <a:t>5.71M</a:t>
             </a:r>
           </a:p>
         </p:txBody>
@@ -12847,7 +11548,7 @@
                 <a:ea typeface="Arial"/>
                 <a:cs typeface="Arial"/>
               </a:rPr>
-              <a:t>training interactions</a:t>
+              <a:t>valid fashion opening offers</a:t>
             </a:r>
           </a:p>
         </p:txBody>
@@ -12897,7 +11598,7 @@
                 <a:ea typeface="Arial"/>
                 <a:cs typeface="Arial"/>
               </a:rPr>
-              <a:t>0.701</a:t>
+              <a:t>0.834</a:t>
             </a:r>
           </a:p>
         </p:txBody>
@@ -12997,7 +11698,7 @@
                 <a:ea typeface="Arial"/>
                 <a:cs typeface="Arial"/>
               </a:rPr>
-              <a:t>0.31 - 0.93</a:t>
+              <a:t>0.268 - 0.867</a:t>
             </a:r>
           </a:p>
         </p:txBody>
@@ -13047,7 +11748,7 @@
                 <a:ea typeface="Arial"/>
                 <a:cs typeface="Arial"/>
               </a:rPr>
-              <a:t>anchor support (p5 - p95)</a:t>
+              <a:t>train anchor support (p5 - p95)</a:t>
             </a:r>
           </a:p>
         </p:txBody>
@@ -13083,7 +11784,7 @@
           <p:nvPr/>
         </p:nvPicPr>
         <p:blipFill>
-          <a:blip xmlns:r="http://schemas.openxmlformats.org/officeDocument/2006/relationships" xmlns:a="http://schemas.openxmlformats.org/drawingml/2006/main" r:embed="R400ab7e3633544b7"/>
+          <a:blip xmlns:r="http://schemas.openxmlformats.org/officeDocument/2006/relationships" xmlns:a="http://schemas.openxmlformats.org/drawingml/2006/main" r:embed="R90193e582d594a25"/>
           <a:stretch xmlns:a="http://schemas.openxmlformats.org/drawingml/2006/main">
             <a:fillRect l="0" t="0" r="0" b="0"/>
           </a:stretch>
@@ -13115,7 +11816,7 @@
         <p:spPr>
           <a:xfrm xmlns:a="http://schemas.openxmlformats.org/drawingml/2006/main">
             <a:off x="384048" y="292608"/>
-            <a:ext cx="7589520" cy="685800"/>
+            <a:ext cx="7589520" cy="822960"/>
           </a:xfrm>
           <a:prstGeom xmlns:a="http://schemas.openxmlformats.org/drawingml/2006/main" prst="rect">
             <a:avLst/>
@@ -13143,7 +11844,7 @@
                 <a:ea typeface="Arial"/>
                 <a:cs typeface="Arial"/>
               </a:rPr>
-              <a:t>How: Phase 1 predicts acceptance - greedy use is unsafe</a:t>
+              <a:t>How: Phase 1 is calibrated - greedy still needs support checks</a:t>
             </a:r>
           </a:p>
         </p:txBody>
@@ -13312,7 +12013,7 @@
                 <a:ea typeface="Arial"/>
                 <a:cs typeface="Arial"/>
               </a:rPr>
-              <a:t>It is a response model, not a value function - expected savings are derived afterwards as P(accept) × (1 − a).</a:t>
+              <a:t>Expected savings is then P(accept) × (1 − a).</a:t>
             </a:r>
           </a:p>
           <a:p xmlns:a="http://schemas.openxmlformats.org/drawingml/2006/main">
@@ -13331,7 +12032,7 @@
                 <a:ea typeface="Arial"/>
                 <a:cs typeface="Arial"/>
               </a:rPr>
-              <a:t>The model is useful for prediction and simple baselines.</a:t>
+              <a:t>AUC 0.834 and Brier 0.154 support useful probability prediction.</a:t>
             </a:r>
           </a:p>
           <a:p xmlns:a="http://schemas.openxmlformats.org/drawingml/2006/main">
@@ -13350,7 +12051,7 @@
                 <a:ea typeface="Arial"/>
                 <a:cs typeface="Arial"/>
               </a:rPr>
-              <a:t>The failure appears when the learned surface is maximized greedily: target anchors move outside reliable logged support.</a:t>
+              <a:t>But actions are observational, so grid optimization still needs historical-support checks.</a:t>
             </a:r>
           </a:p>
         </p:txBody>
@@ -13483,7 +12184,7 @@
                           <a:ea typeface="Arial"/>
                           <a:cs typeface="Arial"/>
                         </a:rPr>
-                        <a:t>AUC 0.701</a:t>
+                        <a:t>AUC 0.834</a:t>
                       </a:r>
                     </a:p>
                   </a:txBody>
@@ -13504,7 +12205,7 @@
                           <a:ea typeface="Arial"/>
                           <a:cs typeface="Arial"/>
                         </a:rPr>
-                        <a:t>usable acceptance model</a:t>
+                        <a:t>strong discrimination</a:t>
                       </a:r>
                     </a:p>
                   </a:txBody>
@@ -13527,7 +12228,7 @@
                           <a:ea typeface="Arial"/>
                           <a:cs typeface="Arial"/>
                         </a:rPr>
-                        <a:t>Fixed 0.70</a:t>
+                        <a:t>Calibration</a:t>
                       </a:r>
                     </a:p>
                   </a:txBody>
@@ -13548,7 +12249,7 @@
                           <a:ea typeface="Arial"/>
                           <a:cs typeface="Arial"/>
                         </a:rPr>
-                        <a:t>0.0268</a:t>
+                        <a:t>Brier 0.154</a:t>
                       </a:r>
                     </a:p>
                   </a:txBody>
@@ -13569,7 +12270,7 @@
                           <a:ea typeface="Arial"/>
                           <a:cs typeface="Arial"/>
                         </a:rPr>
-                        <a:t>expected savings (model)</a:t>
+                        <a:t>probability quality</a:t>
                       </a:r>
                     </a:p>
                   </a:txBody>
@@ -13592,7 +12293,7 @@
                           <a:ea typeface="Arial"/>
                           <a:cs typeface="Arial"/>
                         </a:rPr>
-                        <a:t>Greedy use</a:t>
+                        <a:t>Greedy</a:t>
                       </a:r>
                     </a:p>
                   </a:txBody>
@@ -13613,7 +12314,7 @@
                           <a:ea typeface="Arial"/>
                           <a:cs typeface="Arial"/>
                         </a:rPr>
-                        <a:t>ESS 0.008</a:t>
+                        <a:t>Support 91.0%</a:t>
                       </a:r>
                     </a:p>
                   </a:txBody>
@@ -13634,7 +12335,7 @@
                           <a:ea typeface="Arial"/>
                           <a:cs typeface="Arial"/>
                         </a:rPr>
-                        <a:t>almost no logged support</a:t>
+                        <a:t>some extrapolation</a:t>
                       </a:r>
                     </a:p>
                   </a:txBody>
@@ -13694,7 +12395,7 @@
                 <a:ea typeface="Arial"/>
                 <a:cs typeface="Arial"/>
               </a:rPr>
-              <a:t>ESS shown for bandwidth h = 0.05.</a:t>
+              <a:t>OPE ESS at h = 0.05: fixed 35.5% | greedy 25.6% | CQL 36.2%.</a:t>
             </a:r>
           </a:p>
         </p:txBody>
@@ -13744,7 +12445,7 @@
                 <a:ea typeface="Arial"/>
                 <a:cs typeface="Arial"/>
               </a:rPr>
-              <a:t>This closes Phase 1: prediction works, but support-aware optimization is still needed.</a:t>
+              <a:t>Phase 1 is useful for prediction; support-aware optimization is still needed.</a:t>
             </a:r>
           </a:p>
         </p:txBody>
@@ -13780,7 +12481,7 @@
           <p:nvPr/>
         </p:nvPicPr>
         <p:blipFill>
-          <a:blip xmlns:r="http://schemas.openxmlformats.org/officeDocument/2006/relationships" xmlns:a="http://schemas.openxmlformats.org/drawingml/2006/main" r:embed="R4162297806f14186"/>
+          <a:blip xmlns:r="http://schemas.openxmlformats.org/officeDocument/2006/relationships" xmlns:a="http://schemas.openxmlformats.org/drawingml/2006/main" r:embed="R0ef54806462a491a"/>
           <a:stretch xmlns:a="http://schemas.openxmlformats.org/drawingml/2006/main">
             <a:fillRect l="0" t="0" r="0" b="0"/>
           </a:stretch>
@@ -14896,7 +13597,7 @@
           <p:nvPr/>
         </p:nvPicPr>
         <p:blipFill>
-          <a:blip xmlns:r="http://schemas.openxmlformats.org/officeDocument/2006/relationships" xmlns:a="http://schemas.openxmlformats.org/drawingml/2006/main" r:embed="R60cb980f17224686"/>
+          <a:blip xmlns:r="http://schemas.openxmlformats.org/officeDocument/2006/relationships" xmlns:a="http://schemas.openxmlformats.org/drawingml/2006/main" r:embed="Ra4531a8f57b04339"/>
           <a:stretch xmlns:a="http://schemas.openxmlformats.org/drawingml/2006/main">
             <a:fillRect l="0" t="0" r="0" b="0"/>
           </a:stretch>
@@ -15106,7 +13807,7 @@
                 <a:ea typeface="Arial"/>
                 <a:cs typeface="Arial"/>
               </a:rPr>
-              <a:t>True logging propensities are unavailable, so off-policy evaluation is diagnostic, not causal.</a:t>
+              <a:t>True logging propensities are unavailable, so off-policy evaluation remains diagnostic, not causal.</a:t>
             </a:r>
           </a:p>
           <a:p xmlns:a="http://schemas.openxmlformats.org/drawingml/2006/main">
@@ -15125,7 +13826,7 @@
                 <a:ea typeface="Arial"/>
                 <a:cs typeface="Arial"/>
               </a:rPr>
-              <a:t>Effective sample size (ESS) measures how much logged data actually supports a target policy.</a:t>
+              <a:t>At h = 0.05, greedy has the weakest support (ESS 25.6%); CQL retains 36.2% and fixed 0.70 retains 35.5%.</a:t>
             </a:r>
           </a:p>
           <a:p xmlns:a="http://schemas.openxmlformats.org/drawingml/2006/main">
@@ -15144,7 +13845,7 @@
                 <a:ea typeface="Arial"/>
                 <a:cs typeface="Arial"/>
               </a:rPr>
-              <a:t>Greedy keeps 0.8% effective support: its attractive estimate is unverifiable extrapolation.</a:t>
+              <a:t>SNIPS: greedy 0.1277 | CQL 0.1235 | fixed 0.1257. Bandwidth sensitivity prevents a causal lift claim.</a:t>
             </a:r>
           </a:p>
         </p:txBody>
@@ -15161,7 +13862,7 @@
         </p:xfrm>
         <a:graphic xmlns:a="http://schemas.openxmlformats.org/drawingml/2006/main">
           <a:graphicData uri="http://schemas.openxmlformats.org/drawingml/2006/chart">
-            <c:chart xmlns:r="http://schemas.openxmlformats.org/officeDocument/2006/relationships" xmlns:c="http://schemas.openxmlformats.org/drawingml/2006/chart" r:id="Rf617e4bef4ee412a"/>
+            <c:chart xmlns:r="http://schemas.openxmlformats.org/officeDocument/2006/relationships" xmlns:c="http://schemas.openxmlformats.org/drawingml/2006/chart" r:id="R6ec0e7b6f14d4baa"/>
           </a:graphicData>
         </a:graphic>
       </p:graphicFrame>

</xml_diff>